<commit_message>
Mejorar PPTX: fases con mayor detalle y diapositiva guia para publicacion web
</commit_message>
<xml_diff>
--- a/Ruta-Emprendimiento-CIE.pptx
+++ b/Ruta-Emprendimiento-CIE.pptx
@@ -12,8 +12,8 @@
   </p:handoutMasterIdLst>
   <p:sldIdLst>
     <p:sldId id="626" r:id="rId2"/>
+    <p:sldId id="648" r:id="rId27"/>
     <p:sldId id="631" r:id="rId7"/>
-    <p:sldId id="648" r:id="rId27"/>
     <p:sldId id="649" r:id="rId28"/>
     <p:sldId id="650" r:id="rId29"/>
     <p:sldId id="651" r:id="rId30"/>
@@ -25,6 +25,7 @@
     <p:sldId id="657" r:id="rId36"/>
     <p:sldId id="658" r:id="rId37"/>
     <p:sldId id="659" r:id="rId38"/>
+    <p:sldId id="660" r:id="rId39"/>
     <p:sldId id="580" r:id="rId18"/>
   </p:sldIdLst>
   <p:sldSz cx="24384000" cy="13716000"/>
@@ -5247,7 +5248,7 @@
             <a:p>
               <a:pPr algn="l" hangingPunct="1"/>
               <a:r>
-                <a:rPr lang="es-CO" sz="3000" dirty="0">
+                <a:rPr lang="es-CO" sz="2600" dirty="0">
                   <a:solidFill>
                     <a:schemeClr val="tx1"/>
                   </a:solidFill>
@@ -5255,7 +5256,7 @@
                   <a:ea typeface="Century Gothic" charset="0"/>
                   <a:cs typeface="Century Gothic" charset="0"/>
                 </a:rPr>
-                <a:t>Ruta institucional</a:t>
+                <a:t>Guía de la ruta institucional</a:t>
               </a:r>
             </a:p>
           </p:txBody>
@@ -5307,7 +5308,7 @@
               </a:lnSpc>
             </a:pPr>
             <a:r>
-              <a:rPr lang="es-ES" sz="3000" b="1" dirty="0">
+              <a:rPr lang="es-ES" sz="2800" b="1" dirty="0">
                 <a:solidFill>
                   <a:schemeClr val="tx1"/>
                 </a:solidFill>
@@ -5324,7 +5325,7 @@
               </a:lnSpc>
             </a:pPr>
             <a:r>
-              <a:rPr lang="es-ES" sz="2200" b="1" dirty="0">
+              <a:rPr lang="es-ES" sz="2000" b="1" dirty="0">
                 <a:solidFill>
                   <a:schemeClr val="tx1"/>
                 </a:solidFill>
@@ -5341,14 +5342,14 @@
               </a:lnSpc>
             </a:pPr>
             <a:r>
-              <a:rPr lang="es-ES" sz="2200" b="1" dirty="0">
+              <a:rPr lang="es-ES" sz="2000" b="1" dirty="0">
                 <a:solidFill>
                   <a:schemeClr val="tx1"/>
                 </a:solidFill>
                 <a:latin typeface="Century Gothic" panose="020B0502020202020204" pitchFamily="34" charset="0"/>
                 <a:cs typeface="Candara"/>
               </a:rPr>
-              <a:t>Ronaldo Javier Martínez Mur — Práctica Profesional</a:t>
+              <a:t>Guía para estudiantes, egresados y docentes</a:t>
             </a:r>
           </a:p>
         </p:txBody>
@@ -5587,7 +5588,7 @@
                 </a:solidFill>
                 <a:latin typeface="Century Gothic" panose="020B0502020202020204" pitchFamily="34" charset="0"/>
               </a:rPr>
-              <a:t>Fundamento en el PDI 2022-2031</a:t>
+              <a:t>¿Qué es la Ruta de Emprendimiento?</a:t>
             </a:r>
             <a:endParaRPr kumimoji="0" lang="en-US" sz="4800" b="0" i="0" u="none" strike="noStrike" kern="1200" cap="none" spc="0" normalizeH="0" baseline="0" noProof="0" dirty="0">
               <a:ln>
@@ -5614,8 +5615,8 @@
         </p:nvSpPr>
         <p:spPr>
           <a:xfrm>
-            <a:off x="4796053" y="8498663"/>
-            <a:ext cx="14791894" cy="2000550"/>
+            <a:off x="3200400" y="7589520"/>
+            <a:ext cx="18013680" cy="5486400"/>
           </a:xfrm>
           <a:prstGeom prst="rect">
             <a:avLst/>
@@ -5891,53 +5892,53 @@
           <a:p>
             <a:pPr algn="ctr" hangingPunct="1"/>
             <a:r>
-              <a:rPr lang="es-CO" sz="2200" b="1" dirty="0">
+              <a:rPr lang="es-CO" sz="2000" b="1" dirty="0">
                 <a:solidFill>
                   <a:schemeClr val="accent6"/>
                 </a:solidFill>
                 <a:latin typeface="Century Gothic" panose="020B0502020202020204" pitchFamily="34" charset="0"/>
                 <a:cs typeface="Candara"/>
               </a:rPr>
-              <a:t>•  Línea Estratégica 3: Extensión y Proyección Social.</a:t>
+              <a:t>•  Instrumento que organiza, por fases, el acompañamiento del CIE al emprendedor.</a:t>
             </a:r>
           </a:p>
           <a:p>
             <a:pPr algn="ctr" hangingPunct="1"/>
             <a:r>
-              <a:rPr lang="es-CO" sz="2200" b="1" dirty="0">
+              <a:rPr lang="es-CO" sz="2000" b="1" dirty="0">
                 <a:solidFill>
                   <a:schemeClr val="accent6"/>
                 </a:solidFill>
                 <a:latin typeface="Century Gothic" panose="020B0502020202020204" pitchFamily="34" charset="0"/>
                 <a:cs typeface="Candara"/>
               </a:rPr>
-              <a:t>•  Estrategia 7: sensibilización, acompañamiento y transferencia de conocimiento.</a:t>
+              <a:t>•  Dirigida a estudiantes, egresados y docentes de todas las facultades.</a:t>
             </a:r>
           </a:p>
           <a:p>
             <a:pPr algn="ctr" hangingPunct="1"/>
             <a:r>
-              <a:rPr lang="es-CO" sz="2200" b="1" dirty="0">
+              <a:rPr lang="es-CO" sz="2000" b="1" dirty="0">
                 <a:solidFill>
                   <a:schemeClr val="accent6"/>
                 </a:solidFill>
                 <a:latin typeface="Century Gothic" panose="020B0502020202020204" pitchFamily="34" charset="0"/>
                 <a:cs typeface="Candara"/>
               </a:rPr>
-              <a:t>•  Estrategia 2: cultura de innovación y emprendimiento mediante formación y asesoría.</a:t>
+              <a:t>•  Va desde despertar la idea hasta conectarla con financiación y el mercado.</a:t>
             </a:r>
           </a:p>
           <a:p>
             <a:pPr algn="ctr" hangingPunct="1"/>
             <a:r>
-              <a:rPr lang="es-CO" sz="2200" b="1" dirty="0">
+              <a:rPr lang="es-CO" sz="2000" b="1" dirty="0">
                 <a:solidFill>
                   <a:schemeClr val="accent6"/>
                 </a:solidFill>
                 <a:latin typeface="Century Gothic" panose="020B0502020202020204" pitchFamily="34" charset="0"/>
                 <a:cs typeface="Candara"/>
               </a:rPr>
-              <a:t>•  Metas: política de innovación y emprendimiento; Centro 'UA Emprende' (sostenibilidad ≥3%); 2 spin-off; Parque Tecnológico del Caribe.</a:t>
+              <a:t>•  Es no lineal: cada proyecto entra en la fase según su nivel de madurez.</a:t>
             </a:r>
           </a:p>
         </p:txBody>
@@ -6019,7 +6020,7 @@
                 </a:solidFill>
                 <a:latin typeface="Century Gothic" panose="020B0502020202020204" pitchFamily="34" charset="0"/>
               </a:rPr>
-              <a:t>Principios de la ruta</a:t>
+              <a:t>Fundamento en el PDI 2022-2031</a:t>
             </a:r>
             <a:endParaRPr kumimoji="0" lang="en-US" sz="4800" b="0" i="0" u="none" strike="noStrike" kern="1200" cap="none" spc="0" normalizeH="0" baseline="0" noProof="0" dirty="0">
               <a:ln>
@@ -6046,8 +6047,8 @@
         </p:nvSpPr>
         <p:spPr>
           <a:xfrm>
-            <a:off x="4796053" y="8498663"/>
-            <a:ext cx="14791894" cy="2000550"/>
+            <a:off x="3200400" y="7589520"/>
+            <a:ext cx="18013680" cy="5486400"/>
           </a:xfrm>
           <a:prstGeom prst="rect">
             <a:avLst/>
@@ -6323,79 +6324,53 @@
           <a:p>
             <a:pPr algn="ctr" hangingPunct="1"/>
             <a:r>
-              <a:rPr lang="es-CO" sz="2200" b="1" dirty="0">
+              <a:rPr lang="es-CO" sz="1900" b="1" dirty="0">
                 <a:solidFill>
                   <a:schemeClr val="accent6"/>
                 </a:solidFill>
                 <a:latin typeface="Century Gothic" panose="020B0502020202020204" pitchFamily="34" charset="0"/>
                 <a:cs typeface="Candara"/>
               </a:rPr>
-              <a:t>•  No lineal: cada iniciativa entra según su nivel de madurez.</a:t>
+              <a:t>•  Línea Estratégica 3: Extensión y Proyección Social.</a:t>
             </a:r>
           </a:p>
           <a:p>
             <a:pPr algn="ctr" hangingPunct="1"/>
             <a:r>
-              <a:rPr lang="es-CO" sz="2200" b="1" dirty="0">
+              <a:rPr lang="es-CO" sz="1900" b="1" dirty="0">
                 <a:solidFill>
                   <a:schemeClr val="accent6"/>
                 </a:solidFill>
                 <a:latin typeface="Century Gothic" panose="020B0502020202020204" pitchFamily="34" charset="0"/>
                 <a:cs typeface="Candara"/>
               </a:rPr>
-              <a:t>•  Flexible y personalizada.</a:t>
+              <a:t>•  Estrategia 7: sensibilización, acompañamiento y transferencia de conocimiento.</a:t>
             </a:r>
           </a:p>
           <a:p>
             <a:pPr algn="ctr" hangingPunct="1"/>
             <a:r>
-              <a:rPr lang="es-CO" sz="2200" b="1" dirty="0">
+              <a:rPr lang="es-CO" sz="1900" b="1" dirty="0">
                 <a:solidFill>
                   <a:schemeClr val="accent6"/>
                 </a:solidFill>
                 <a:latin typeface="Century Gothic" panose="020B0502020202020204" pitchFamily="34" charset="0"/>
                 <a:cs typeface="Candara"/>
               </a:rPr>
-              <a:t>•  Transversal a todas las facultades.</a:t>
+              <a:t>•  Estrategia 2: cultura de innovación y emprendimiento (formación y asesoría).</a:t>
             </a:r>
           </a:p>
           <a:p>
             <a:pPr algn="ctr" hangingPunct="1"/>
             <a:r>
-              <a:rPr lang="es-CO" sz="2200" b="1" dirty="0">
+              <a:rPr lang="es-CO" sz="1900" b="1" dirty="0">
                 <a:solidFill>
                   <a:schemeClr val="accent6"/>
                 </a:solidFill>
                 <a:latin typeface="Century Gothic" panose="020B0502020202020204" pitchFamily="34" charset="0"/>
                 <a:cs typeface="Candara"/>
               </a:rPr>
-              <a:t>•  Articulada con el ecosistema regional.</a:t>
-            </a:r>
-          </a:p>
-          <a:p>
-            <a:pPr algn="ctr" hangingPunct="1"/>
-            <a:r>
-              <a:rPr lang="es-CO" sz="2200" b="1" dirty="0">
-                <a:solidFill>
-                  <a:schemeClr val="accent6"/>
-                </a:solidFill>
-                <a:latin typeface="Century Gothic" panose="020B0502020202020204" pitchFamily="34" charset="0"/>
-                <a:cs typeface="Candara"/>
-              </a:rPr>
-              <a:t>•  Basada en la demanda real de los estudiantes.</a:t>
-            </a:r>
-          </a:p>
-          <a:p>
-            <a:pPr algn="ctr" hangingPunct="1"/>
-            <a:r>
-              <a:rPr lang="es-CO" sz="2200" b="1" dirty="0">
-                <a:solidFill>
-                  <a:schemeClr val="accent6"/>
-                </a:solidFill>
-                <a:latin typeface="Century Gothic" panose="020B0502020202020204" pitchFamily="34" charset="0"/>
-                <a:cs typeface="Candara"/>
-              </a:rPr>
-              <a:t>•  Medible, con indicadores de impacto.</a:t>
+              <a:t>•  Metas: política de innovación y emprendimiento; Centro 'UA Emprende' (sostenibilidad ≥3%); 2 spin-off; Parque Tecnológico del Caribe.</a:t>
             </a:r>
           </a:p>
         </p:txBody>
@@ -6477,7 +6452,7 @@
                 </a:solidFill>
                 <a:latin typeface="Century Gothic" panose="020B0502020202020204" pitchFamily="34" charset="0"/>
               </a:rPr>
-              <a:t>Actores y roles</a:t>
+              <a:t>Principios de la ruta</a:t>
             </a:r>
             <a:endParaRPr kumimoji="0" lang="en-US" sz="4800" b="0" i="0" u="none" strike="noStrike" kern="1200" cap="none" spc="0" normalizeH="0" baseline="0" noProof="0" dirty="0">
               <a:ln>
@@ -6504,8 +6479,8 @@
         </p:nvSpPr>
         <p:spPr>
           <a:xfrm>
-            <a:off x="4796053" y="8498663"/>
-            <a:ext cx="14791894" cy="2000550"/>
+            <a:off x="3200400" y="7589520"/>
+            <a:ext cx="18013680" cy="5486400"/>
           </a:xfrm>
           <a:prstGeom prst="rect">
             <a:avLst/>
@@ -6781,66 +6756,79 @@
           <a:p>
             <a:pPr algn="ctr" hangingPunct="1"/>
             <a:r>
-              <a:rPr lang="es-CO" sz="2200" b="1" dirty="0">
+              <a:rPr lang="es-CO" sz="2000" b="1" dirty="0">
                 <a:solidFill>
                   <a:schemeClr val="accent6"/>
                 </a:solidFill>
                 <a:latin typeface="Century Gothic" panose="020B0502020202020204" pitchFamily="34" charset="0"/>
                 <a:cs typeface="Candara"/>
               </a:rPr>
-              <a:t>•  CIE: coordina la ruta y mide indicadores.</a:t>
+              <a:t>•  No lineal: cada iniciativa entra según su nivel de madurez.</a:t>
             </a:r>
           </a:p>
           <a:p>
             <a:pPr algn="ctr" hangingPunct="1"/>
             <a:r>
-              <a:rPr lang="es-CO" sz="2200" b="1" dirty="0">
+              <a:rPr lang="es-CO" sz="2000" b="1" dirty="0">
                 <a:solidFill>
                   <a:schemeClr val="accent6"/>
                 </a:solidFill>
                 <a:latin typeface="Century Gothic" panose="020B0502020202020204" pitchFamily="34" charset="0"/>
                 <a:cs typeface="Candara"/>
               </a:rPr>
-              <a:t>•  Docente enlace por facultad: puente permanente CIE–facultad.</a:t>
+              <a:t>•  Flexible y personalizada.</a:t>
             </a:r>
           </a:p>
           <a:p>
             <a:pPr algn="ctr" hangingPunct="1"/>
             <a:r>
-              <a:rPr lang="es-CO" sz="2200" b="1" dirty="0">
+              <a:rPr lang="es-CO" sz="2000" b="1" dirty="0">
                 <a:solidFill>
                   <a:schemeClr val="accent6"/>
                 </a:solidFill>
                 <a:latin typeface="Century Gothic" panose="020B0502020202020204" pitchFamily="34" charset="0"/>
                 <a:cs typeface="Candara"/>
               </a:rPr>
-              <a:t>•  Pool de mentores multidisciplinarios: docentes, empresarios y egresados.</a:t>
+              <a:t>•  Transversal a todas las facultades.</a:t>
             </a:r>
           </a:p>
           <a:p>
             <a:pPr algn="ctr" hangingPunct="1"/>
             <a:r>
-              <a:rPr lang="es-CO" sz="2200" b="1" dirty="0">
+              <a:rPr lang="es-CO" sz="2000" b="1" dirty="0">
                 <a:solidFill>
                   <a:schemeClr val="accent6"/>
                 </a:solidFill>
                 <a:latin typeface="Century Gothic" panose="020B0502020202020204" pitchFamily="34" charset="0"/>
                 <a:cs typeface="Candara"/>
               </a:rPr>
-              <a:t>•  Semilleros y grupos de investigación.</a:t>
+              <a:t>•  Articulada con el ecosistema regional.</a:t>
             </a:r>
           </a:p>
           <a:p>
             <a:pPr algn="ctr" hangingPunct="1"/>
             <a:r>
-              <a:rPr lang="es-CO" sz="2200" b="1" dirty="0">
+              <a:rPr lang="es-CO" sz="2000" b="1" dirty="0">
                 <a:solidFill>
                   <a:schemeClr val="accent6"/>
                 </a:solidFill>
                 <a:latin typeface="Century Gothic" panose="020B0502020202020204" pitchFamily="34" charset="0"/>
                 <a:cs typeface="Candara"/>
               </a:rPr>
-              <a:t>•  Aliados externos: Cientech (OTRI), Cámaras de Comercio, MacondoLab, Ruta N.</a:t>
+              <a:t>•  Basada en la demanda real de los estudiantes.</a:t>
+            </a:r>
+          </a:p>
+          <a:p>
+            <a:pPr algn="ctr" hangingPunct="1"/>
+            <a:r>
+              <a:rPr lang="es-CO" sz="2000" b="1" dirty="0">
+                <a:solidFill>
+                  <a:schemeClr val="accent6"/>
+                </a:solidFill>
+                <a:latin typeface="Century Gothic" panose="020B0502020202020204" pitchFamily="34" charset="0"/>
+                <a:cs typeface="Candara"/>
+              </a:rPr>
+              <a:t>•  Medible, con indicadores de impacto.</a:t>
             </a:r>
           </a:p>
         </p:txBody>
@@ -6922,7 +6910,7 @@
                 </a:solidFill>
                 <a:latin typeface="Century Gothic" panose="020B0502020202020204" pitchFamily="34" charset="0"/>
               </a:rPr>
-              <a:t>Esquema general de la ruta</a:t>
+              <a:t>Actores y roles</a:t>
             </a:r>
             <a:endParaRPr kumimoji="0" lang="en-US" sz="4800" b="0" i="0" u="none" strike="noStrike" kern="1200" cap="none" spc="0" normalizeH="0" baseline="0" noProof="0" dirty="0">
               <a:ln>
@@ -6939,30 +6927,357 @@
           </a:p>
         </p:txBody>
       </p:sp>
-      <p:pic>
-        <p:nvPicPr>
-          <p:cNvPr id="13" name="Picture 12" descr="ruta_emprendimiento.png"/>
-          <p:cNvPicPr>
-            <a:picLocks noChangeAspect="1"/>
-          </p:cNvPicPr>
+      <p:sp>
+        <p:nvSpPr>
+          <p:cNvPr id="13" name="Google Shape;139;p19"/>
+          <p:cNvSpPr txBox="1">
+            <a:spLocks/>
+          </p:cNvSpPr>
           <p:nvPr/>
-        </p:nvPicPr>
-        <p:blipFill>
-          <a:blip r:embed="rId2"/>
-          <a:stretch>
-            <a:fillRect/>
-          </a:stretch>
-        </p:blipFill>
+        </p:nvSpPr>
         <p:spPr>
           <a:xfrm>
-            <a:off x="6520793" y="7498079"/>
-            <a:ext cx="11345461" cy="5486400"/>
+            <a:off x="3200400" y="7589520"/>
+            <a:ext cx="18013680" cy="5486400"/>
           </a:xfrm>
           <a:prstGeom prst="rect">
             <a:avLst/>
           </a:prstGeom>
         </p:spPr>
-      </p:pic>
+        <p:txBody>
+          <a:bodyPr spcFirstLastPara="1" wrap="square" lIns="91425" tIns="91425" rIns="91425" bIns="91425" anchor="t" anchorCtr="0">
+            <a:noAutofit/>
+          </a:bodyPr>
+          <a:lstStyle>
+            <a:lvl1pPr marL="0" marR="0" indent="0" algn="just" defTabSz="825500" rtl="0" latinLnBrk="0">
+              <a:lnSpc>
+                <a:spcPct val="120000"/>
+              </a:lnSpc>
+              <a:spcBef>
+                <a:spcPts val="0"/>
+              </a:spcBef>
+              <a:spcAft>
+                <a:spcPts val="0"/>
+              </a:spcAft>
+              <a:buClrTx/>
+              <a:buSzTx/>
+              <a:buFontTx/>
+              <a:buNone/>
+              <a:tabLst/>
+              <a:defRPr sz="2400" b="0" i="0" u="none" strike="noStrike" cap="none" spc="0" baseline="0">
+                <a:ln>
+                  <a:noFill/>
+                </a:ln>
+                <a:solidFill>
+                  <a:srgbClr val="868A8D"/>
+                </a:solidFill>
+                <a:uFillTx/>
+                <a:latin typeface="Montserrat Light"/>
+                <a:ea typeface="Montserrat Light"/>
+                <a:cs typeface="Montserrat Light"/>
+                <a:sym typeface="Montserrat Light"/>
+              </a:defRPr>
+            </a:lvl1pPr>
+            <a:lvl2pPr marL="0" marR="0" indent="228600" algn="just" defTabSz="825500" rtl="0" latinLnBrk="0">
+              <a:lnSpc>
+                <a:spcPct val="120000"/>
+              </a:lnSpc>
+              <a:spcBef>
+                <a:spcPts val="0"/>
+              </a:spcBef>
+              <a:spcAft>
+                <a:spcPts val="0"/>
+              </a:spcAft>
+              <a:buClrTx/>
+              <a:buSzTx/>
+              <a:buFontTx/>
+              <a:buNone/>
+              <a:tabLst/>
+              <a:defRPr sz="2400" b="0" i="0" u="none" strike="noStrike" cap="none" spc="0" baseline="0">
+                <a:ln>
+                  <a:noFill/>
+                </a:ln>
+                <a:solidFill>
+                  <a:srgbClr val="868A8D"/>
+                </a:solidFill>
+                <a:uFillTx/>
+                <a:latin typeface="Montserrat Light"/>
+                <a:ea typeface="Montserrat Light"/>
+                <a:cs typeface="Montserrat Light"/>
+                <a:sym typeface="Montserrat Light"/>
+              </a:defRPr>
+            </a:lvl2pPr>
+            <a:lvl3pPr marL="0" marR="0" indent="457200" algn="just" defTabSz="825500" rtl="0" latinLnBrk="0">
+              <a:lnSpc>
+                <a:spcPct val="120000"/>
+              </a:lnSpc>
+              <a:spcBef>
+                <a:spcPts val="0"/>
+              </a:spcBef>
+              <a:spcAft>
+                <a:spcPts val="0"/>
+              </a:spcAft>
+              <a:buClrTx/>
+              <a:buSzTx/>
+              <a:buFontTx/>
+              <a:buNone/>
+              <a:tabLst/>
+              <a:defRPr sz="2400" b="0" i="0" u="none" strike="noStrike" cap="none" spc="0" baseline="0">
+                <a:ln>
+                  <a:noFill/>
+                </a:ln>
+                <a:solidFill>
+                  <a:srgbClr val="868A8D"/>
+                </a:solidFill>
+                <a:uFillTx/>
+                <a:latin typeface="Montserrat Light"/>
+                <a:ea typeface="Montserrat Light"/>
+                <a:cs typeface="Montserrat Light"/>
+                <a:sym typeface="Montserrat Light"/>
+              </a:defRPr>
+            </a:lvl3pPr>
+            <a:lvl4pPr marL="0" marR="0" indent="685800" algn="just" defTabSz="825500" rtl="0" latinLnBrk="0">
+              <a:lnSpc>
+                <a:spcPct val="120000"/>
+              </a:lnSpc>
+              <a:spcBef>
+                <a:spcPts val="0"/>
+              </a:spcBef>
+              <a:spcAft>
+                <a:spcPts val="0"/>
+              </a:spcAft>
+              <a:buClrTx/>
+              <a:buSzTx/>
+              <a:buFontTx/>
+              <a:buNone/>
+              <a:tabLst/>
+              <a:defRPr sz="2400" b="0" i="0" u="none" strike="noStrike" cap="none" spc="0" baseline="0">
+                <a:ln>
+                  <a:noFill/>
+                </a:ln>
+                <a:solidFill>
+                  <a:srgbClr val="868A8D"/>
+                </a:solidFill>
+                <a:uFillTx/>
+                <a:latin typeface="Montserrat Light"/>
+                <a:ea typeface="Montserrat Light"/>
+                <a:cs typeface="Montserrat Light"/>
+                <a:sym typeface="Montserrat Light"/>
+              </a:defRPr>
+            </a:lvl4pPr>
+            <a:lvl5pPr marL="0" marR="0" indent="914400" algn="just" defTabSz="825500" rtl="0" latinLnBrk="0">
+              <a:lnSpc>
+                <a:spcPct val="120000"/>
+              </a:lnSpc>
+              <a:spcBef>
+                <a:spcPts val="0"/>
+              </a:spcBef>
+              <a:spcAft>
+                <a:spcPts val="0"/>
+              </a:spcAft>
+              <a:buClrTx/>
+              <a:buSzTx/>
+              <a:buFontTx/>
+              <a:buNone/>
+              <a:tabLst/>
+              <a:defRPr sz="2400" b="0" i="0" u="none" strike="noStrike" cap="none" spc="0" baseline="0">
+                <a:ln>
+                  <a:noFill/>
+                </a:ln>
+                <a:solidFill>
+                  <a:srgbClr val="868A8D"/>
+                </a:solidFill>
+                <a:uFillTx/>
+                <a:latin typeface="Montserrat Light"/>
+                <a:ea typeface="Montserrat Light"/>
+                <a:cs typeface="Montserrat Light"/>
+                <a:sym typeface="Montserrat Light"/>
+              </a:defRPr>
+            </a:lvl5pPr>
+            <a:lvl6pPr marL="0" marR="0" indent="1143000" algn="just" defTabSz="825500" rtl="0" latinLnBrk="0">
+              <a:lnSpc>
+                <a:spcPct val="120000"/>
+              </a:lnSpc>
+              <a:spcBef>
+                <a:spcPts val="0"/>
+              </a:spcBef>
+              <a:spcAft>
+                <a:spcPts val="0"/>
+              </a:spcAft>
+              <a:buClrTx/>
+              <a:buSzTx/>
+              <a:buFontTx/>
+              <a:buNone/>
+              <a:tabLst/>
+              <a:defRPr sz="2400" b="0" i="0" u="none" strike="noStrike" cap="none" spc="0" baseline="0">
+                <a:ln>
+                  <a:noFill/>
+                </a:ln>
+                <a:solidFill>
+                  <a:srgbClr val="868A8D"/>
+                </a:solidFill>
+                <a:uFillTx/>
+                <a:latin typeface="Montserrat Light"/>
+                <a:ea typeface="Montserrat Light"/>
+                <a:cs typeface="Montserrat Light"/>
+                <a:sym typeface="Montserrat Light"/>
+              </a:defRPr>
+            </a:lvl6pPr>
+            <a:lvl7pPr marL="0" marR="0" indent="1371600" algn="just" defTabSz="825500" rtl="0" latinLnBrk="0">
+              <a:lnSpc>
+                <a:spcPct val="120000"/>
+              </a:lnSpc>
+              <a:spcBef>
+                <a:spcPts val="0"/>
+              </a:spcBef>
+              <a:spcAft>
+                <a:spcPts val="0"/>
+              </a:spcAft>
+              <a:buClrTx/>
+              <a:buSzTx/>
+              <a:buFontTx/>
+              <a:buNone/>
+              <a:tabLst/>
+              <a:defRPr sz="2400" b="0" i="0" u="none" strike="noStrike" cap="none" spc="0" baseline="0">
+                <a:ln>
+                  <a:noFill/>
+                </a:ln>
+                <a:solidFill>
+                  <a:srgbClr val="868A8D"/>
+                </a:solidFill>
+                <a:uFillTx/>
+                <a:latin typeface="Montserrat Light"/>
+                <a:ea typeface="Montserrat Light"/>
+                <a:cs typeface="Montserrat Light"/>
+                <a:sym typeface="Montserrat Light"/>
+              </a:defRPr>
+            </a:lvl7pPr>
+            <a:lvl8pPr marL="0" marR="0" indent="1600200" algn="just" defTabSz="825500" rtl="0" latinLnBrk="0">
+              <a:lnSpc>
+                <a:spcPct val="120000"/>
+              </a:lnSpc>
+              <a:spcBef>
+                <a:spcPts val="0"/>
+              </a:spcBef>
+              <a:spcAft>
+                <a:spcPts val="0"/>
+              </a:spcAft>
+              <a:buClrTx/>
+              <a:buSzTx/>
+              <a:buFontTx/>
+              <a:buNone/>
+              <a:tabLst/>
+              <a:defRPr sz="2400" b="0" i="0" u="none" strike="noStrike" cap="none" spc="0" baseline="0">
+                <a:ln>
+                  <a:noFill/>
+                </a:ln>
+                <a:solidFill>
+                  <a:srgbClr val="868A8D"/>
+                </a:solidFill>
+                <a:uFillTx/>
+                <a:latin typeface="Montserrat Light"/>
+                <a:ea typeface="Montserrat Light"/>
+                <a:cs typeface="Montserrat Light"/>
+                <a:sym typeface="Montserrat Light"/>
+              </a:defRPr>
+            </a:lvl8pPr>
+            <a:lvl9pPr marL="0" marR="0" indent="1828800" algn="just" defTabSz="825500" rtl="0" latinLnBrk="0">
+              <a:lnSpc>
+                <a:spcPct val="120000"/>
+              </a:lnSpc>
+              <a:spcBef>
+                <a:spcPts val="0"/>
+              </a:spcBef>
+              <a:spcAft>
+                <a:spcPts val="0"/>
+              </a:spcAft>
+              <a:buClrTx/>
+              <a:buSzTx/>
+              <a:buFontTx/>
+              <a:buNone/>
+              <a:tabLst/>
+              <a:defRPr sz="2400" b="0" i="0" u="none" strike="noStrike" cap="none" spc="0" baseline="0">
+                <a:ln>
+                  <a:noFill/>
+                </a:ln>
+                <a:solidFill>
+                  <a:srgbClr val="868A8D"/>
+                </a:solidFill>
+                <a:uFillTx/>
+                <a:latin typeface="Montserrat Light"/>
+                <a:ea typeface="Montserrat Light"/>
+                <a:cs typeface="Montserrat Light"/>
+                <a:sym typeface="Montserrat Light"/>
+              </a:defRPr>
+            </a:lvl9pPr>
+          </a:lstStyle>
+          <a:p>
+            <a:pPr algn="ctr" hangingPunct="1"/>
+            <a:r>
+              <a:rPr lang="es-CO" sz="2000" b="1" dirty="0">
+                <a:solidFill>
+                  <a:schemeClr val="accent6"/>
+                </a:solidFill>
+                <a:latin typeface="Century Gothic" panose="020B0502020202020204" pitchFamily="34" charset="0"/>
+                <a:cs typeface="Candara"/>
+              </a:rPr>
+              <a:t>•  CIE: coordina la ruta y mide los indicadores.</a:t>
+            </a:r>
+          </a:p>
+          <a:p>
+            <a:pPr algn="ctr" hangingPunct="1"/>
+            <a:r>
+              <a:rPr lang="es-CO" sz="2000" b="1" dirty="0">
+                <a:solidFill>
+                  <a:schemeClr val="accent6"/>
+                </a:solidFill>
+                <a:latin typeface="Century Gothic" panose="020B0502020202020204" pitchFamily="34" charset="0"/>
+                <a:cs typeface="Candara"/>
+              </a:rPr>
+              <a:t>•  Docente enlace por facultad: puente permanente CIE–facultad.</a:t>
+            </a:r>
+          </a:p>
+          <a:p>
+            <a:pPr algn="ctr" hangingPunct="1"/>
+            <a:r>
+              <a:rPr lang="es-CO" sz="2000" b="1" dirty="0">
+                <a:solidFill>
+                  <a:schemeClr val="accent6"/>
+                </a:solidFill>
+                <a:latin typeface="Century Gothic" panose="020B0502020202020204" pitchFamily="34" charset="0"/>
+                <a:cs typeface="Candara"/>
+              </a:rPr>
+              <a:t>•  Mentores multidisciplinarios: docentes, empresarios y egresados.</a:t>
+            </a:r>
+          </a:p>
+          <a:p>
+            <a:pPr algn="ctr" hangingPunct="1"/>
+            <a:r>
+              <a:rPr lang="es-CO" sz="2000" b="1" dirty="0">
+                <a:solidFill>
+                  <a:schemeClr val="accent6"/>
+                </a:solidFill>
+                <a:latin typeface="Century Gothic" panose="020B0502020202020204" pitchFamily="34" charset="0"/>
+                <a:cs typeface="Candara"/>
+              </a:rPr>
+              <a:t>•  Semilleros y grupos de investigación.</a:t>
+            </a:r>
+          </a:p>
+          <a:p>
+            <a:pPr algn="ctr" hangingPunct="1"/>
+            <a:r>
+              <a:rPr lang="es-CO" sz="2000" b="1" dirty="0">
+                <a:solidFill>
+                  <a:schemeClr val="accent6"/>
+                </a:solidFill>
+                <a:latin typeface="Century Gothic" panose="020B0502020202020204" pitchFamily="34" charset="0"/>
+                <a:cs typeface="Candara"/>
+              </a:rPr>
+              <a:t>•  Aliados externos: Cientech (OTRI), Cámaras de Comercio, MacondoLab, Ruta N.</a:t>
+            </a:r>
+          </a:p>
+        </p:txBody>
+      </p:sp>
     </p:spTree>
   </p:cSld>
   <p:clrMapOvr>
@@ -7040,7 +7355,7 @@
                 </a:solidFill>
                 <a:latin typeface="Century Gothic" panose="020B0502020202020204" pitchFamily="34" charset="0"/>
               </a:rPr>
-              <a:t>Fase 1 · Sensibilización</a:t>
+              <a:t>Esquema general de la ruta</a:t>
             </a:r>
             <a:endParaRPr kumimoji="0" lang="en-US" sz="4800" b="0" i="0" u="none" strike="noStrike" kern="1200" cap="none" spc="0" normalizeH="0" baseline="0" noProof="0" dirty="0">
               <a:ln>
@@ -7057,331 +7372,30 @@
           </a:p>
         </p:txBody>
       </p:sp>
-      <p:sp>
-        <p:nvSpPr>
-          <p:cNvPr id="13" name="Google Shape;139;p19"/>
-          <p:cNvSpPr txBox="1">
-            <a:spLocks/>
-          </p:cNvSpPr>
+      <p:pic>
+        <p:nvPicPr>
+          <p:cNvPr id="13" name="Picture 12" descr="ruta_emprendimiento.png"/>
+          <p:cNvPicPr>
+            <a:picLocks noChangeAspect="1"/>
+          </p:cNvPicPr>
           <p:nvPr/>
-        </p:nvSpPr>
+        </p:nvPicPr>
+        <p:blipFill>
+          <a:blip r:embed="rId2"/>
+          <a:stretch>
+            <a:fillRect/>
+          </a:stretch>
+        </p:blipFill>
         <p:spPr>
           <a:xfrm>
-            <a:off x="4796053" y="8498663"/>
-            <a:ext cx="14791894" cy="2000550"/>
+            <a:off x="6142611" y="7315200"/>
+            <a:ext cx="12101825" cy="5852160"/>
           </a:xfrm>
           <a:prstGeom prst="rect">
             <a:avLst/>
           </a:prstGeom>
         </p:spPr>
-        <p:txBody>
-          <a:bodyPr spcFirstLastPara="1" wrap="square" lIns="91425" tIns="91425" rIns="91425" bIns="91425" anchor="t" anchorCtr="0">
-            <a:noAutofit/>
-          </a:bodyPr>
-          <a:lstStyle>
-            <a:lvl1pPr marL="0" marR="0" indent="0" algn="just" defTabSz="825500" rtl="0" latinLnBrk="0">
-              <a:lnSpc>
-                <a:spcPct val="120000"/>
-              </a:lnSpc>
-              <a:spcBef>
-                <a:spcPts val="0"/>
-              </a:spcBef>
-              <a:spcAft>
-                <a:spcPts val="0"/>
-              </a:spcAft>
-              <a:buClrTx/>
-              <a:buSzTx/>
-              <a:buFontTx/>
-              <a:buNone/>
-              <a:tabLst/>
-              <a:defRPr sz="2400" b="0" i="0" u="none" strike="noStrike" cap="none" spc="0" baseline="0">
-                <a:ln>
-                  <a:noFill/>
-                </a:ln>
-                <a:solidFill>
-                  <a:srgbClr val="868A8D"/>
-                </a:solidFill>
-                <a:uFillTx/>
-                <a:latin typeface="Montserrat Light"/>
-                <a:ea typeface="Montserrat Light"/>
-                <a:cs typeface="Montserrat Light"/>
-                <a:sym typeface="Montserrat Light"/>
-              </a:defRPr>
-            </a:lvl1pPr>
-            <a:lvl2pPr marL="0" marR="0" indent="228600" algn="just" defTabSz="825500" rtl="0" latinLnBrk="0">
-              <a:lnSpc>
-                <a:spcPct val="120000"/>
-              </a:lnSpc>
-              <a:spcBef>
-                <a:spcPts val="0"/>
-              </a:spcBef>
-              <a:spcAft>
-                <a:spcPts val="0"/>
-              </a:spcAft>
-              <a:buClrTx/>
-              <a:buSzTx/>
-              <a:buFontTx/>
-              <a:buNone/>
-              <a:tabLst/>
-              <a:defRPr sz="2400" b="0" i="0" u="none" strike="noStrike" cap="none" spc="0" baseline="0">
-                <a:ln>
-                  <a:noFill/>
-                </a:ln>
-                <a:solidFill>
-                  <a:srgbClr val="868A8D"/>
-                </a:solidFill>
-                <a:uFillTx/>
-                <a:latin typeface="Montserrat Light"/>
-                <a:ea typeface="Montserrat Light"/>
-                <a:cs typeface="Montserrat Light"/>
-                <a:sym typeface="Montserrat Light"/>
-              </a:defRPr>
-            </a:lvl2pPr>
-            <a:lvl3pPr marL="0" marR="0" indent="457200" algn="just" defTabSz="825500" rtl="0" latinLnBrk="0">
-              <a:lnSpc>
-                <a:spcPct val="120000"/>
-              </a:lnSpc>
-              <a:spcBef>
-                <a:spcPts val="0"/>
-              </a:spcBef>
-              <a:spcAft>
-                <a:spcPts val="0"/>
-              </a:spcAft>
-              <a:buClrTx/>
-              <a:buSzTx/>
-              <a:buFontTx/>
-              <a:buNone/>
-              <a:tabLst/>
-              <a:defRPr sz="2400" b="0" i="0" u="none" strike="noStrike" cap="none" spc="0" baseline="0">
-                <a:ln>
-                  <a:noFill/>
-                </a:ln>
-                <a:solidFill>
-                  <a:srgbClr val="868A8D"/>
-                </a:solidFill>
-                <a:uFillTx/>
-                <a:latin typeface="Montserrat Light"/>
-                <a:ea typeface="Montserrat Light"/>
-                <a:cs typeface="Montserrat Light"/>
-                <a:sym typeface="Montserrat Light"/>
-              </a:defRPr>
-            </a:lvl3pPr>
-            <a:lvl4pPr marL="0" marR="0" indent="685800" algn="just" defTabSz="825500" rtl="0" latinLnBrk="0">
-              <a:lnSpc>
-                <a:spcPct val="120000"/>
-              </a:lnSpc>
-              <a:spcBef>
-                <a:spcPts val="0"/>
-              </a:spcBef>
-              <a:spcAft>
-                <a:spcPts val="0"/>
-              </a:spcAft>
-              <a:buClrTx/>
-              <a:buSzTx/>
-              <a:buFontTx/>
-              <a:buNone/>
-              <a:tabLst/>
-              <a:defRPr sz="2400" b="0" i="0" u="none" strike="noStrike" cap="none" spc="0" baseline="0">
-                <a:ln>
-                  <a:noFill/>
-                </a:ln>
-                <a:solidFill>
-                  <a:srgbClr val="868A8D"/>
-                </a:solidFill>
-                <a:uFillTx/>
-                <a:latin typeface="Montserrat Light"/>
-                <a:ea typeface="Montserrat Light"/>
-                <a:cs typeface="Montserrat Light"/>
-                <a:sym typeface="Montserrat Light"/>
-              </a:defRPr>
-            </a:lvl4pPr>
-            <a:lvl5pPr marL="0" marR="0" indent="914400" algn="just" defTabSz="825500" rtl="0" latinLnBrk="0">
-              <a:lnSpc>
-                <a:spcPct val="120000"/>
-              </a:lnSpc>
-              <a:spcBef>
-                <a:spcPts val="0"/>
-              </a:spcBef>
-              <a:spcAft>
-                <a:spcPts val="0"/>
-              </a:spcAft>
-              <a:buClrTx/>
-              <a:buSzTx/>
-              <a:buFontTx/>
-              <a:buNone/>
-              <a:tabLst/>
-              <a:defRPr sz="2400" b="0" i="0" u="none" strike="noStrike" cap="none" spc="0" baseline="0">
-                <a:ln>
-                  <a:noFill/>
-                </a:ln>
-                <a:solidFill>
-                  <a:srgbClr val="868A8D"/>
-                </a:solidFill>
-                <a:uFillTx/>
-                <a:latin typeface="Montserrat Light"/>
-                <a:ea typeface="Montserrat Light"/>
-                <a:cs typeface="Montserrat Light"/>
-                <a:sym typeface="Montserrat Light"/>
-              </a:defRPr>
-            </a:lvl5pPr>
-            <a:lvl6pPr marL="0" marR="0" indent="1143000" algn="just" defTabSz="825500" rtl="0" latinLnBrk="0">
-              <a:lnSpc>
-                <a:spcPct val="120000"/>
-              </a:lnSpc>
-              <a:spcBef>
-                <a:spcPts val="0"/>
-              </a:spcBef>
-              <a:spcAft>
-                <a:spcPts val="0"/>
-              </a:spcAft>
-              <a:buClrTx/>
-              <a:buSzTx/>
-              <a:buFontTx/>
-              <a:buNone/>
-              <a:tabLst/>
-              <a:defRPr sz="2400" b="0" i="0" u="none" strike="noStrike" cap="none" spc="0" baseline="0">
-                <a:ln>
-                  <a:noFill/>
-                </a:ln>
-                <a:solidFill>
-                  <a:srgbClr val="868A8D"/>
-                </a:solidFill>
-                <a:uFillTx/>
-                <a:latin typeface="Montserrat Light"/>
-                <a:ea typeface="Montserrat Light"/>
-                <a:cs typeface="Montserrat Light"/>
-                <a:sym typeface="Montserrat Light"/>
-              </a:defRPr>
-            </a:lvl6pPr>
-            <a:lvl7pPr marL="0" marR="0" indent="1371600" algn="just" defTabSz="825500" rtl="0" latinLnBrk="0">
-              <a:lnSpc>
-                <a:spcPct val="120000"/>
-              </a:lnSpc>
-              <a:spcBef>
-                <a:spcPts val="0"/>
-              </a:spcBef>
-              <a:spcAft>
-                <a:spcPts val="0"/>
-              </a:spcAft>
-              <a:buClrTx/>
-              <a:buSzTx/>
-              <a:buFontTx/>
-              <a:buNone/>
-              <a:tabLst/>
-              <a:defRPr sz="2400" b="0" i="0" u="none" strike="noStrike" cap="none" spc="0" baseline="0">
-                <a:ln>
-                  <a:noFill/>
-                </a:ln>
-                <a:solidFill>
-                  <a:srgbClr val="868A8D"/>
-                </a:solidFill>
-                <a:uFillTx/>
-                <a:latin typeface="Montserrat Light"/>
-                <a:ea typeface="Montserrat Light"/>
-                <a:cs typeface="Montserrat Light"/>
-                <a:sym typeface="Montserrat Light"/>
-              </a:defRPr>
-            </a:lvl7pPr>
-            <a:lvl8pPr marL="0" marR="0" indent="1600200" algn="just" defTabSz="825500" rtl="0" latinLnBrk="0">
-              <a:lnSpc>
-                <a:spcPct val="120000"/>
-              </a:lnSpc>
-              <a:spcBef>
-                <a:spcPts val="0"/>
-              </a:spcBef>
-              <a:spcAft>
-                <a:spcPts val="0"/>
-              </a:spcAft>
-              <a:buClrTx/>
-              <a:buSzTx/>
-              <a:buFontTx/>
-              <a:buNone/>
-              <a:tabLst/>
-              <a:defRPr sz="2400" b="0" i="0" u="none" strike="noStrike" cap="none" spc="0" baseline="0">
-                <a:ln>
-                  <a:noFill/>
-                </a:ln>
-                <a:solidFill>
-                  <a:srgbClr val="868A8D"/>
-                </a:solidFill>
-                <a:uFillTx/>
-                <a:latin typeface="Montserrat Light"/>
-                <a:ea typeface="Montserrat Light"/>
-                <a:cs typeface="Montserrat Light"/>
-                <a:sym typeface="Montserrat Light"/>
-              </a:defRPr>
-            </a:lvl8pPr>
-            <a:lvl9pPr marL="0" marR="0" indent="1828800" algn="just" defTabSz="825500" rtl="0" latinLnBrk="0">
-              <a:lnSpc>
-                <a:spcPct val="120000"/>
-              </a:lnSpc>
-              <a:spcBef>
-                <a:spcPts val="0"/>
-              </a:spcBef>
-              <a:spcAft>
-                <a:spcPts val="0"/>
-              </a:spcAft>
-              <a:buClrTx/>
-              <a:buSzTx/>
-              <a:buFontTx/>
-              <a:buNone/>
-              <a:tabLst/>
-              <a:defRPr sz="2400" b="0" i="0" u="none" strike="noStrike" cap="none" spc="0" baseline="0">
-                <a:ln>
-                  <a:noFill/>
-                </a:ln>
-                <a:solidFill>
-                  <a:srgbClr val="868A8D"/>
-                </a:solidFill>
-                <a:uFillTx/>
-                <a:latin typeface="Montserrat Light"/>
-                <a:ea typeface="Montserrat Light"/>
-                <a:cs typeface="Montserrat Light"/>
-                <a:sym typeface="Montserrat Light"/>
-              </a:defRPr>
-            </a:lvl9pPr>
-          </a:lstStyle>
-          <a:p>
-            <a:pPr algn="ctr" hangingPunct="1"/>
-            <a:r>
-              <a:rPr lang="es-CO" sz="2400" b="1" dirty="0">
-                <a:solidFill>
-                  <a:schemeClr val="accent6"/>
-                </a:solidFill>
-                <a:latin typeface="Century Gothic" panose="020B0502020202020204" pitchFamily="34" charset="0"/>
-                <a:cs typeface="Candara"/>
-              </a:rPr>
-              <a:t>•  Objetivo: despertar la cultura emprendedora.</a:t>
-            </a:r>
-          </a:p>
-          <a:p>
-            <a:pPr algn="ctr" hangingPunct="1"/>
-            <a:r>
-              <a:rPr lang="es-CO" sz="2400" b="1" dirty="0">
-                <a:solidFill>
-                  <a:schemeClr val="accent6"/>
-                </a:solidFill>
-                <a:latin typeface="Century Gothic" panose="020B0502020202020204" pitchFamily="34" charset="0"/>
-                <a:cs typeface="Candara"/>
-              </a:rPr>
-              <a:t>•  Actividades: charlas, ferias, hackathones y retos de innovación.</a:t>
-            </a:r>
-          </a:p>
-          <a:p>
-            <a:pPr algn="ctr" hangingPunct="1"/>
-            <a:r>
-              <a:rPr lang="es-CO" sz="2400" b="1" dirty="0">
-                <a:solidFill>
-                  <a:schemeClr val="accent6"/>
-                </a:solidFill>
-                <a:latin typeface="Century Gothic" panose="020B0502020202020204" pitchFamily="34" charset="0"/>
-                <a:cs typeface="Candara"/>
-              </a:rPr>
-              <a:t>•  Entregable: comunidad sensibilizada y captación de interesados.</a:t>
-            </a:r>
-          </a:p>
-        </p:txBody>
-      </p:sp>
+      </p:pic>
     </p:spTree>
   </p:cSld>
   <p:clrMapOvr>
@@ -7459,7 +7473,7 @@
                 </a:solidFill>
                 <a:latin typeface="Century Gothic" panose="020B0502020202020204" pitchFamily="34" charset="0"/>
               </a:rPr>
-              <a:t>Fase 2 · Identificación e ideación</a:t>
+              <a:t>Fase 1 · Sensibilización</a:t>
             </a:r>
             <a:endParaRPr kumimoji="0" lang="en-US" sz="4800" b="0" i="0" u="none" strike="noStrike" kern="1200" cap="none" spc="0" normalizeH="0" baseline="0" noProof="0" dirty="0">
               <a:ln>
@@ -7486,8 +7500,8 @@
         </p:nvSpPr>
         <p:spPr>
           <a:xfrm>
-            <a:off x="4796053" y="8498663"/>
-            <a:ext cx="14791894" cy="2000550"/>
+            <a:off x="3200400" y="7589520"/>
+            <a:ext cx="18013680" cy="5669280"/>
           </a:xfrm>
           <a:prstGeom prst="rect">
             <a:avLst/>
@@ -7761,42 +7775,153 @@
             </a:lvl9pPr>
           </a:lstStyle>
           <a:p>
-            <a:pPr algn="ctr" hangingPunct="1"/>
+            <a:pPr algn="ctr" hangingPunct="1">
+              <a:spcAft>
+                <a:spcPts val="600"/>
+              </a:spcAft>
+            </a:pPr>
             <a:r>
-              <a:rPr lang="es-CO" sz="2400" b="1" dirty="0">
-                <a:solidFill>
-                  <a:schemeClr val="accent6"/>
-                </a:solidFill>
-                <a:latin typeface="Century Gothic" panose="020B0502020202020204" pitchFamily="34" charset="0"/>
-                <a:cs typeface="Candara"/>
+              <a:rPr b="1" sz="1600">
+                <a:solidFill>
+                  <a:srgbClr val="1E3B7D"/>
+                </a:solidFill>
+                <a:latin typeface="Century Gothic"/>
               </a:rPr>
-              <a:t>•  Objetivo: captar ideas y darles forma inicial.</a:t>
+              <a:t>Objetivo: </a:t>
+            </a:r>
+            <a:r>
+              <a:rPr sz="1600">
+                <a:solidFill>
+                  <a:srgbClr val="404040"/>
+                </a:solidFill>
+                <a:latin typeface="Century Gothic"/>
+              </a:rPr>
+              <a:t>despertar la cultura emprendedora y dar a conocer el CIE.</a:t>
             </a:r>
           </a:p>
           <a:p>
-            <a:pPr algn="ctr" hangingPunct="1"/>
+            <a:pPr algn="ctr" hangingPunct="1">
+              <a:spcAft>
+                <a:spcPts val="600"/>
+              </a:spcAft>
+            </a:pPr>
             <a:r>
-              <a:rPr lang="es-CO" sz="2400" b="1" dirty="0">
-                <a:solidFill>
-                  <a:schemeClr val="accent6"/>
-                </a:solidFill>
-                <a:latin typeface="Century Gothic" panose="020B0502020202020204" pitchFamily="34" charset="0"/>
-                <a:cs typeface="Candara"/>
+              <a:rPr b="1" sz="1600">
+                <a:solidFill>
+                  <a:srgbClr val="1E3B7D"/>
+                </a:solidFill>
+                <a:latin typeface="Century Gothic"/>
               </a:rPr>
-              <a:t>•  Actividades: convocatorias, recepción de ideas, vinculación con semilleros.</a:t>
+              <a:t>Actividades: </a:t>
+            </a:r>
+            <a:r>
+              <a:rPr sz="1600">
+                <a:solidFill>
+                  <a:srgbClr val="404040"/>
+                </a:solidFill>
+                <a:latin typeface="Century Gothic"/>
+              </a:rPr>
+              <a:t>charlas y talleres en aulas, ferias, hackathones, retos, cine-foros.</a:t>
             </a:r>
           </a:p>
           <a:p>
-            <a:pPr algn="ctr" hangingPunct="1"/>
+            <a:pPr algn="ctr" hangingPunct="1">
+              <a:spcAft>
+                <a:spcPts val="600"/>
+              </a:spcAft>
+            </a:pPr>
             <a:r>
-              <a:rPr lang="es-CO" sz="2400" b="1" dirty="0">
-                <a:solidFill>
-                  <a:schemeClr val="accent6"/>
-                </a:solidFill>
-                <a:latin typeface="Century Gothic" panose="020B0502020202020204" pitchFamily="34" charset="0"/>
-                <a:cs typeface="Candara"/>
+              <a:rPr b="1" sz="1600">
+                <a:solidFill>
+                  <a:srgbClr val="1E3B7D"/>
+                </a:solidFill>
+                <a:latin typeface="Century Gothic"/>
               </a:rPr>
-              <a:t>•  Entregable: proyecto inscrito con ficha inicial.</a:t>
+              <a:t>Metodologías: </a:t>
+            </a:r>
+            <a:r>
+              <a:rPr sz="1600">
+                <a:solidFill>
+                  <a:srgbClr val="404040"/>
+                </a:solidFill>
+                <a:latin typeface="Century Gothic"/>
+              </a:rPr>
+              <a:t>metodologías activas y casos de éxito (storytelling).</a:t>
+            </a:r>
+          </a:p>
+          <a:p>
+            <a:pPr algn="ctr" hangingPunct="1">
+              <a:spcAft>
+                <a:spcPts val="600"/>
+              </a:spcAft>
+            </a:pPr>
+            <a:r>
+              <a:rPr b="1" sz="1600">
+                <a:solidFill>
+                  <a:srgbClr val="1E3B7D"/>
+                </a:solidFill>
+                <a:latin typeface="Century Gothic"/>
+              </a:rPr>
+              <a:t>Responsables: </a:t>
+            </a:r>
+            <a:r>
+              <a:rPr sz="1600">
+                <a:solidFill>
+                  <a:srgbClr val="404040"/>
+                </a:solidFill>
+                <a:latin typeface="Century Gothic"/>
+              </a:rPr>
+              <a:t>CIE y docentes enlace.</a:t>
+            </a:r>
+          </a:p>
+          <a:p>
+            <a:pPr algn="ctr" hangingPunct="1">
+              <a:spcAft>
+                <a:spcPts val="600"/>
+              </a:spcAft>
+            </a:pPr>
+            <a:r>
+              <a:rPr b="1" sz="1600">
+                <a:solidFill>
+                  <a:srgbClr val="1E3B7D"/>
+                </a:solidFill>
+                <a:latin typeface="Century Gothic"/>
+              </a:rPr>
+              <a:t>Entregable: </a:t>
+            </a:r>
+            <a:r>
+              <a:rPr sz="1600">
+                <a:solidFill>
+                  <a:srgbClr val="404040"/>
+                </a:solidFill>
+                <a:latin typeface="Century Gothic"/>
+              </a:rPr>
+              <a:t>comunidad sensibilizada y base de datos de interesados.</a:t>
+            </a:r>
+          </a:p>
+          <a:p>
+            <a:pPr algn="ctr" hangingPunct="1">
+              <a:spcAft>
+                <a:spcPts val="600"/>
+              </a:spcAft>
+            </a:pPr>
+            <a:r>
+              <a:rPr b="1" sz="1600">
+                <a:solidFill>
+                  <a:srgbClr val="1E3B7D"/>
+                </a:solidFill>
+                <a:latin typeface="Century Gothic"/>
+              </a:rPr>
+              <a:t>Tiempo: </a:t>
+            </a:r>
+            <a:r>
+              <a:rPr sz="1600">
+                <a:solidFill>
+                  <a:srgbClr val="404040"/>
+                </a:solidFill>
+                <a:latin typeface="Century Gothic"/>
+              </a:rPr>
+              <a:t>transversal / continuo.</a:t>
             </a:r>
           </a:p>
         </p:txBody>
@@ -7878,7 +8003,7 @@
                 </a:solidFill>
                 <a:latin typeface="Century Gothic" panose="020B0502020202020204" pitchFamily="34" charset="0"/>
               </a:rPr>
-              <a:t>Fase 3 · Diagnóstico y clasificación</a:t>
+              <a:t>Fase 2 · Identificación e ideación</a:t>
             </a:r>
             <a:endParaRPr kumimoji="0" lang="en-US" sz="4800" b="0" i="0" u="none" strike="noStrike" kern="1200" cap="none" spc="0" normalizeH="0" baseline="0" noProof="0" dirty="0">
               <a:ln>
@@ -7905,8 +8030,8 @@
         </p:nvSpPr>
         <p:spPr>
           <a:xfrm>
-            <a:off x="4796053" y="8498663"/>
-            <a:ext cx="14791894" cy="2000550"/>
+            <a:off x="3200400" y="7589520"/>
+            <a:ext cx="18013680" cy="5669280"/>
           </a:xfrm>
           <a:prstGeom prst="rect">
             <a:avLst/>
@@ -8180,42 +8305,153 @@
             </a:lvl9pPr>
           </a:lstStyle>
           <a:p>
-            <a:pPr algn="ctr" hangingPunct="1"/>
+            <a:pPr algn="ctr" hangingPunct="1">
+              <a:spcAft>
+                <a:spcPts val="600"/>
+              </a:spcAft>
+            </a:pPr>
             <a:r>
-              <a:rPr lang="es-CO" sz="2400" b="1" dirty="0">
-                <a:solidFill>
-                  <a:schemeClr val="accent6"/>
-                </a:solidFill>
-                <a:latin typeface="Century Gothic" panose="020B0502020202020204" pitchFamily="34" charset="0"/>
-                <a:cs typeface="Candara"/>
+              <a:rPr b="1" sz="1600">
+                <a:solidFill>
+                  <a:srgbClr val="1E3B7D"/>
+                </a:solidFill>
+                <a:latin typeface="Century Gothic"/>
               </a:rPr>
-              <a:t>•  Objetivo: valorar el nivel de madurez del proyecto.</a:t>
+              <a:t>Objetivo: </a:t>
+            </a:r>
+            <a:r>
+              <a:rPr sz="1600">
+                <a:solidFill>
+                  <a:srgbClr val="404040"/>
+                </a:solidFill>
+                <a:latin typeface="Century Gothic"/>
+              </a:rPr>
+              <a:t>captar las ideas y ayudarlas a tomar forma inicial.</a:t>
             </a:r>
           </a:p>
           <a:p>
-            <a:pPr algn="ctr" hangingPunct="1"/>
+            <a:pPr algn="ctr" hangingPunct="1">
+              <a:spcAft>
+                <a:spcPts val="600"/>
+              </a:spcAft>
+            </a:pPr>
             <a:r>
-              <a:rPr lang="es-CO" sz="2400" b="1" dirty="0">
-                <a:solidFill>
-                  <a:schemeClr val="accent6"/>
-                </a:solidFill>
-                <a:latin typeface="Century Gothic" panose="020B0502020202020204" pitchFamily="34" charset="0"/>
-                <a:cs typeface="Candara"/>
+              <a:rPr b="1" sz="1600">
+                <a:solidFill>
+                  <a:srgbClr val="1E3B7D"/>
+                </a:solidFill>
+                <a:latin typeface="Century Gothic"/>
               </a:rPr>
-              <a:t>•  Actividades: aplicación de una herramienta de clasificación por etapas.</a:t>
+              <a:t>Actividades: </a:t>
+            </a:r>
+            <a:r>
+              <a:rPr sz="1600">
+                <a:solidFill>
+                  <a:srgbClr val="404040"/>
+                </a:solidFill>
+                <a:latin typeface="Century Gothic"/>
+              </a:rPr>
+              <a:t>convocatorias internas, ideación asistida, vínculo con semilleros.</a:t>
             </a:r>
           </a:p>
           <a:p>
-            <a:pPr algn="ctr" hangingPunct="1"/>
+            <a:pPr algn="ctr" hangingPunct="1">
+              <a:spcAft>
+                <a:spcPts val="600"/>
+              </a:spcAft>
+            </a:pPr>
             <a:r>
-              <a:rPr lang="es-CO" sz="2400" b="1" dirty="0">
-                <a:solidFill>
-                  <a:schemeClr val="accent6"/>
-                </a:solidFill>
-                <a:latin typeface="Century Gothic" panose="020B0502020202020204" pitchFamily="34" charset="0"/>
-                <a:cs typeface="Candara"/>
+              <a:rPr b="1" sz="1600">
+                <a:solidFill>
+                  <a:srgbClr val="1E3B7D"/>
+                </a:solidFill>
+                <a:latin typeface="Century Gothic"/>
               </a:rPr>
-              <a:t>•  Entregable: diagnóstico y ruta personalizada.</a:t>
+              <a:t>Metodologías: </a:t>
+            </a:r>
+            <a:r>
+              <a:rPr sz="1600">
+                <a:solidFill>
+                  <a:srgbClr val="404040"/>
+                </a:solidFill>
+                <a:latin typeface="Century Gothic"/>
+              </a:rPr>
+              <a:t>design thinking (empatía e ideación).</a:t>
+            </a:r>
+          </a:p>
+          <a:p>
+            <a:pPr algn="ctr" hangingPunct="1">
+              <a:spcAft>
+                <a:spcPts val="600"/>
+              </a:spcAft>
+            </a:pPr>
+            <a:r>
+              <a:rPr b="1" sz="1600">
+                <a:solidFill>
+                  <a:srgbClr val="1E3B7D"/>
+                </a:solidFill>
+                <a:latin typeface="Century Gothic"/>
+              </a:rPr>
+              <a:t>Responsables: </a:t>
+            </a:r>
+            <a:r>
+              <a:rPr sz="1600">
+                <a:solidFill>
+                  <a:srgbClr val="404040"/>
+                </a:solidFill>
+                <a:latin typeface="Century Gothic"/>
+              </a:rPr>
+              <a:t>CIE, docente enlace y semilleros.</a:t>
+            </a:r>
+          </a:p>
+          <a:p>
+            <a:pPr algn="ctr" hangingPunct="1">
+              <a:spcAft>
+                <a:spcPts val="600"/>
+              </a:spcAft>
+            </a:pPr>
+            <a:r>
+              <a:rPr b="1" sz="1600">
+                <a:solidFill>
+                  <a:srgbClr val="1E3B7D"/>
+                </a:solidFill>
+                <a:latin typeface="Century Gothic"/>
+              </a:rPr>
+              <a:t>Entregable: </a:t>
+            </a:r>
+            <a:r>
+              <a:rPr sz="1600">
+                <a:solidFill>
+                  <a:srgbClr val="404040"/>
+                </a:solidFill>
+                <a:latin typeface="Century Gothic"/>
+              </a:rPr>
+              <a:t>idea o proyecto inscrito con ficha inicial.</a:t>
+            </a:r>
+          </a:p>
+          <a:p>
+            <a:pPr algn="ctr" hangingPunct="1">
+              <a:spcAft>
+                <a:spcPts val="600"/>
+              </a:spcAft>
+            </a:pPr>
+            <a:r>
+              <a:rPr b="1" sz="1600">
+                <a:solidFill>
+                  <a:srgbClr val="1E3B7D"/>
+                </a:solidFill>
+                <a:latin typeface="Century Gothic"/>
+              </a:rPr>
+              <a:t>Tiempo: </a:t>
+            </a:r>
+            <a:r>
+              <a:rPr sz="1600">
+                <a:solidFill>
+                  <a:srgbClr val="404040"/>
+                </a:solidFill>
+                <a:latin typeface="Century Gothic"/>
+              </a:rPr>
+              <a:t>semanas 1 a 2.</a:t>
             </a:r>
           </a:p>
         </p:txBody>
@@ -8297,7 +8533,7 @@
                 </a:solidFill>
                 <a:latin typeface="Century Gothic" panose="020B0502020202020204" pitchFamily="34" charset="0"/>
               </a:rPr>
-              <a:t>Fase 4 · Formación y preincubación</a:t>
+              <a:t>Fase 3 · Diagnóstico y clasificación</a:t>
             </a:r>
             <a:endParaRPr kumimoji="0" lang="en-US" sz="4800" b="0" i="0" u="none" strike="noStrike" kern="1200" cap="none" spc="0" normalizeH="0" baseline="0" noProof="0" dirty="0">
               <a:ln>
@@ -8324,8 +8560,8 @@
         </p:nvSpPr>
         <p:spPr>
           <a:xfrm>
-            <a:off x="4796053" y="8498663"/>
-            <a:ext cx="14791894" cy="2000550"/>
+            <a:off x="3200400" y="7589520"/>
+            <a:ext cx="18013680" cy="5669280"/>
           </a:xfrm>
           <a:prstGeom prst="rect">
             <a:avLst/>
@@ -8599,42 +8835,153 @@
             </a:lvl9pPr>
           </a:lstStyle>
           <a:p>
-            <a:pPr algn="ctr" hangingPunct="1"/>
+            <a:pPr algn="ctr" hangingPunct="1">
+              <a:spcAft>
+                <a:spcPts val="600"/>
+              </a:spcAft>
+            </a:pPr>
             <a:r>
-              <a:rPr lang="es-CO" sz="2400" b="1" dirty="0">
-                <a:solidFill>
-                  <a:schemeClr val="accent6"/>
-                </a:solidFill>
-                <a:latin typeface="Century Gothic" panose="020B0502020202020204" pitchFamily="34" charset="0"/>
-                <a:cs typeface="Candara"/>
+              <a:rPr b="1" sz="1600">
+                <a:solidFill>
+                  <a:srgbClr val="1E3B7D"/>
+                </a:solidFill>
+                <a:latin typeface="Century Gothic"/>
               </a:rPr>
-              <a:t>•  Objetivo: fortalecer capacidades y validar la propuesta.</a:t>
+              <a:t>Objetivo: </a:t>
+            </a:r>
+            <a:r>
+              <a:rPr sz="1600">
+                <a:solidFill>
+                  <a:srgbClr val="404040"/>
+                </a:solidFill>
+                <a:latin typeface="Century Gothic"/>
+              </a:rPr>
+              <a:t>determinar el nivel de madurez y definir la ruta personalizada.</a:t>
             </a:r>
           </a:p>
           <a:p>
-            <a:pPr algn="ctr" hangingPunct="1"/>
+            <a:pPr algn="ctr" hangingPunct="1">
+              <a:spcAft>
+                <a:spcPts val="600"/>
+              </a:spcAft>
+            </a:pPr>
             <a:r>
-              <a:rPr lang="es-CO" sz="2400" b="1" dirty="0">
-                <a:solidFill>
-                  <a:schemeClr val="accent6"/>
-                </a:solidFill>
-                <a:latin typeface="Century Gothic" panose="020B0502020202020204" pitchFamily="34" charset="0"/>
-                <a:cs typeface="Candara"/>
+              <a:rPr b="1" sz="1600">
+                <a:solidFill>
+                  <a:srgbClr val="1E3B7D"/>
+                </a:solidFill>
+                <a:latin typeface="Century Gothic"/>
               </a:rPr>
-              <a:t>•  Actividades: modelo de negocio (BMC), educación financiera, MVP.</a:t>
+              <a:t>Actividades: </a:t>
+            </a:r>
+            <a:r>
+              <a:rPr sz="1600">
+                <a:solidFill>
+                  <a:srgbClr val="404040"/>
+                </a:solidFill>
+                <a:latin typeface="Century Gothic"/>
+              </a:rPr>
+              <a:t>entrevista y herramienta de clasificación; asignación de mentor.</a:t>
             </a:r>
           </a:p>
           <a:p>
-            <a:pPr algn="ctr" hangingPunct="1"/>
+            <a:pPr algn="ctr" hangingPunct="1">
+              <a:spcAft>
+                <a:spcPts val="600"/>
+              </a:spcAft>
+            </a:pPr>
             <a:r>
-              <a:rPr lang="es-CO" sz="2400" b="1" dirty="0">
-                <a:solidFill>
-                  <a:schemeClr val="accent6"/>
-                </a:solidFill>
-                <a:latin typeface="Century Gothic" panose="020B0502020202020204" pitchFamily="34" charset="0"/>
-                <a:cs typeface="Candara"/>
+              <a:rPr b="1" sz="1600">
+                <a:solidFill>
+                  <a:srgbClr val="1E3B7D"/>
+                </a:solidFill>
+                <a:latin typeface="Century Gothic"/>
               </a:rPr>
-              <a:t>•  Entregable: modelo de negocio validado + MVP.</a:t>
+              <a:t>Metodologías: </a:t>
+            </a:r>
+            <a:r>
+              <a:rPr sz="1600">
+                <a:solidFill>
+                  <a:srgbClr val="404040"/>
+                </a:solidFill>
+                <a:latin typeface="Century Gothic"/>
+              </a:rPr>
+              <a:t>diagnóstico por niveles de madurez.</a:t>
+            </a:r>
+          </a:p>
+          <a:p>
+            <a:pPr algn="ctr" hangingPunct="1">
+              <a:spcAft>
+                <a:spcPts val="600"/>
+              </a:spcAft>
+            </a:pPr>
+            <a:r>
+              <a:rPr b="1" sz="1600">
+                <a:solidFill>
+                  <a:srgbClr val="1E3B7D"/>
+                </a:solidFill>
+                <a:latin typeface="Century Gothic"/>
+              </a:rPr>
+              <a:t>Responsables: </a:t>
+            </a:r>
+            <a:r>
+              <a:rPr sz="1600">
+                <a:solidFill>
+                  <a:srgbClr val="404040"/>
+                </a:solidFill>
+                <a:latin typeface="Century Gothic"/>
+              </a:rPr>
+              <a:t>equipo técnico del CIE.</a:t>
+            </a:r>
+          </a:p>
+          <a:p>
+            <a:pPr algn="ctr" hangingPunct="1">
+              <a:spcAft>
+                <a:spcPts val="600"/>
+              </a:spcAft>
+            </a:pPr>
+            <a:r>
+              <a:rPr b="1" sz="1600">
+                <a:solidFill>
+                  <a:srgbClr val="1E3B7D"/>
+                </a:solidFill>
+                <a:latin typeface="Century Gothic"/>
+              </a:rPr>
+              <a:t>Entregable: </a:t>
+            </a:r>
+            <a:r>
+              <a:rPr sz="1600">
+                <a:solidFill>
+                  <a:srgbClr val="404040"/>
+                </a:solidFill>
+                <a:latin typeface="Century Gothic"/>
+              </a:rPr>
+              <a:t>diagnóstico del proyecto y ruta personalizada.</a:t>
+            </a:r>
+          </a:p>
+          <a:p>
+            <a:pPr algn="ctr" hangingPunct="1">
+              <a:spcAft>
+                <a:spcPts val="600"/>
+              </a:spcAft>
+            </a:pPr>
+            <a:r>
+              <a:rPr b="1" sz="1600">
+                <a:solidFill>
+                  <a:srgbClr val="1E3B7D"/>
+                </a:solidFill>
+                <a:latin typeface="Century Gothic"/>
+              </a:rPr>
+              <a:t>Tiempo: </a:t>
+            </a:r>
+            <a:r>
+              <a:rPr sz="1600">
+                <a:solidFill>
+                  <a:srgbClr val="404040"/>
+                </a:solidFill>
+                <a:latin typeface="Century Gothic"/>
+              </a:rPr>
+              <a:t>semanas 2 a 3.</a:t>
             </a:r>
           </a:p>
         </p:txBody>
@@ -8716,7 +9063,7 @@
                 </a:solidFill>
                 <a:latin typeface="Century Gothic" panose="020B0502020202020204" pitchFamily="34" charset="0"/>
               </a:rPr>
-              <a:t>Fase 5 · Incubación y fortalecimiento</a:t>
+              <a:t>Fase 4 · Formación y preincubación</a:t>
             </a:r>
             <a:endParaRPr kumimoji="0" lang="en-US" sz="4800" b="0" i="0" u="none" strike="noStrike" kern="1200" cap="none" spc="0" normalizeH="0" baseline="0" noProof="0" dirty="0">
               <a:ln>
@@ -8743,8 +9090,8 @@
         </p:nvSpPr>
         <p:spPr>
           <a:xfrm>
-            <a:off x="4796053" y="8498663"/>
-            <a:ext cx="14791894" cy="2000550"/>
+            <a:off x="3200400" y="7589520"/>
+            <a:ext cx="18013680" cy="5669280"/>
           </a:xfrm>
           <a:prstGeom prst="rect">
             <a:avLst/>
@@ -9018,42 +9365,153 @@
             </a:lvl9pPr>
           </a:lstStyle>
           <a:p>
-            <a:pPr algn="ctr" hangingPunct="1"/>
+            <a:pPr algn="ctr" hangingPunct="1">
+              <a:spcAft>
+                <a:spcPts val="600"/>
+              </a:spcAft>
+            </a:pPr>
             <a:r>
-              <a:rPr lang="es-CO" sz="2400" b="1" dirty="0">
-                <a:solidFill>
-                  <a:schemeClr val="accent6"/>
-                </a:solidFill>
-                <a:latin typeface="Century Gothic" panose="020B0502020202020204" pitchFamily="34" charset="0"/>
-                <a:cs typeface="Candara"/>
+              <a:rPr b="1" sz="1600">
+                <a:solidFill>
+                  <a:srgbClr val="1E3B7D"/>
+                </a:solidFill>
+                <a:latin typeface="Century Gothic"/>
               </a:rPr>
-              <a:t>•  Objetivo: poner en marcha y robustecer la iniciativa.</a:t>
+              <a:t>Objetivo: </a:t>
+            </a:r>
+            <a:r>
+              <a:rPr sz="1600">
+                <a:solidFill>
+                  <a:srgbClr val="404040"/>
+                </a:solidFill>
+                <a:latin typeface="Century Gothic"/>
+              </a:rPr>
+              <a:t>fortalecer capacidades y validar la propuesta de valor.</a:t>
             </a:r>
           </a:p>
           <a:p>
-            <a:pPr algn="ctr" hangingPunct="1"/>
+            <a:pPr algn="ctr" hangingPunct="1">
+              <a:spcAft>
+                <a:spcPts val="600"/>
+              </a:spcAft>
+            </a:pPr>
             <a:r>
-              <a:rPr lang="es-CO" sz="2400" b="1" dirty="0">
-                <a:solidFill>
-                  <a:schemeClr val="accent6"/>
-                </a:solidFill>
-                <a:latin typeface="Century Gothic" panose="020B0502020202020204" pitchFamily="34" charset="0"/>
-                <a:cs typeface="Candara"/>
+              <a:rPr b="1" sz="1600">
+                <a:solidFill>
+                  <a:srgbClr val="1E3B7D"/>
+                </a:solidFill>
+                <a:latin typeface="Century Gothic"/>
               </a:rPr>
-              <a:t>•  Actividades: mentorías, branding, transformación digital, asesoría legal y tributaria.</a:t>
+              <a:t>Actividades: </a:t>
+            </a:r>
+            <a:r>
+              <a:rPr sz="1600">
+                <a:solidFill>
+                  <a:srgbClr val="404040"/>
+                </a:solidFill>
+                <a:latin typeface="Century Gothic"/>
+              </a:rPr>
+              <a:t>modelo de negocio (BMC), educación financiera, marketing, MVP.</a:t>
             </a:r>
           </a:p>
           <a:p>
-            <a:pPr algn="ctr" hangingPunct="1"/>
+            <a:pPr algn="ctr" hangingPunct="1">
+              <a:spcAft>
+                <a:spcPts val="600"/>
+              </a:spcAft>
+            </a:pPr>
             <a:r>
-              <a:rPr lang="es-CO" sz="2400" b="1" dirty="0">
-                <a:solidFill>
-                  <a:schemeClr val="accent6"/>
-                </a:solidFill>
-                <a:latin typeface="Century Gothic" panose="020B0502020202020204" pitchFamily="34" charset="0"/>
-                <a:cs typeface="Candara"/>
+              <a:rPr b="1" sz="1600">
+                <a:solidFill>
+                  <a:srgbClr val="1E3B7D"/>
+                </a:solidFill>
+                <a:latin typeface="Century Gothic"/>
               </a:rPr>
-              <a:t>•  Entregable: emprendimiento en operación.</a:t>
+              <a:t>Metodologías: </a:t>
+            </a:r>
+            <a:r>
+              <a:rPr sz="1600">
+                <a:solidFill>
+                  <a:srgbClr val="404040"/>
+                </a:solidFill>
+                <a:latin typeface="Century Gothic"/>
+              </a:rPr>
+              <a:t>Business Model Canvas, Lean Startup, design thinking, MVP.</a:t>
+            </a:r>
+          </a:p>
+          <a:p>
+            <a:pPr algn="ctr" hangingPunct="1">
+              <a:spcAft>
+                <a:spcPts val="600"/>
+              </a:spcAft>
+            </a:pPr>
+            <a:r>
+              <a:rPr b="1" sz="1600">
+                <a:solidFill>
+                  <a:srgbClr val="1E3B7D"/>
+                </a:solidFill>
+                <a:latin typeface="Century Gothic"/>
+              </a:rPr>
+              <a:t>Responsables: </a:t>
+            </a:r>
+            <a:r>
+              <a:rPr sz="1600">
+                <a:solidFill>
+                  <a:srgbClr val="404040"/>
+                </a:solidFill>
+                <a:latin typeface="Century Gothic"/>
+              </a:rPr>
+              <a:t>CIE, mentores y docentes enlace.</a:t>
+            </a:r>
+          </a:p>
+          <a:p>
+            <a:pPr algn="ctr" hangingPunct="1">
+              <a:spcAft>
+                <a:spcPts val="600"/>
+              </a:spcAft>
+            </a:pPr>
+            <a:r>
+              <a:rPr b="1" sz="1600">
+                <a:solidFill>
+                  <a:srgbClr val="1E3B7D"/>
+                </a:solidFill>
+                <a:latin typeface="Century Gothic"/>
+              </a:rPr>
+              <a:t>Entregable: </a:t>
+            </a:r>
+            <a:r>
+              <a:rPr sz="1600">
+                <a:solidFill>
+                  <a:srgbClr val="404040"/>
+                </a:solidFill>
+                <a:latin typeface="Century Gothic"/>
+              </a:rPr>
+              <a:t>modelo de negocio validado y MVP.</a:t>
+            </a:r>
+          </a:p>
+          <a:p>
+            <a:pPr algn="ctr" hangingPunct="1">
+              <a:spcAft>
+                <a:spcPts val="600"/>
+              </a:spcAft>
+            </a:pPr>
+            <a:r>
+              <a:rPr b="1" sz="1600">
+                <a:solidFill>
+                  <a:srgbClr val="1E3B7D"/>
+                </a:solidFill>
+                <a:latin typeface="Century Gothic"/>
+              </a:rPr>
+              <a:t>Tiempo: </a:t>
+            </a:r>
+            <a:r>
+              <a:rPr sz="1600">
+                <a:solidFill>
+                  <a:srgbClr val="404040"/>
+                </a:solidFill>
+                <a:latin typeface="Century Gothic"/>
+              </a:rPr>
+              <a:t>semanas 3 a 8.</a:t>
             </a:r>
           </a:p>
         </p:txBody>
@@ -9135,7 +9593,7 @@
                 </a:solidFill>
                 <a:latin typeface="Century Gothic" panose="020B0502020202020204" pitchFamily="34" charset="0"/>
               </a:rPr>
-              <a:t>Fase 6 · Aceleración, financiación y transferencia</a:t>
+              <a:t>Fase 5 · Incubación y fortalecimiento</a:t>
             </a:r>
             <a:endParaRPr kumimoji="0" lang="en-US" sz="4800" b="0" i="0" u="none" strike="noStrike" kern="1200" cap="none" spc="0" normalizeH="0" baseline="0" noProof="0" dirty="0">
               <a:ln>
@@ -9162,8 +9620,8 @@
         </p:nvSpPr>
         <p:spPr>
           <a:xfrm>
-            <a:off x="4796053" y="8498663"/>
-            <a:ext cx="14791894" cy="2000550"/>
+            <a:off x="3200400" y="7589520"/>
+            <a:ext cx="18013680" cy="5669280"/>
           </a:xfrm>
           <a:prstGeom prst="rect">
             <a:avLst/>
@@ -9437,42 +9895,153 @@
             </a:lvl9pPr>
           </a:lstStyle>
           <a:p>
-            <a:pPr algn="ctr" hangingPunct="1"/>
+            <a:pPr algn="ctr" hangingPunct="1">
+              <a:spcAft>
+                <a:spcPts val="600"/>
+              </a:spcAft>
+            </a:pPr>
             <a:r>
-              <a:rPr lang="es-CO" sz="2400" b="1" dirty="0">
-                <a:solidFill>
-                  <a:schemeClr val="accent6"/>
-                </a:solidFill>
-                <a:latin typeface="Century Gothic" panose="020B0502020202020204" pitchFamily="34" charset="0"/>
-                <a:cs typeface="Candara"/>
+              <a:rPr b="1" sz="1600">
+                <a:solidFill>
+                  <a:srgbClr val="1E3B7D"/>
+                </a:solidFill>
+                <a:latin typeface="Century Gothic"/>
               </a:rPr>
-              <a:t>•  Objetivo: escalar y conectar con el ecosistema.</a:t>
+              <a:t>Objetivo: </a:t>
+            </a:r>
+            <a:r>
+              <a:rPr sz="1600">
+                <a:solidFill>
+                  <a:srgbClr val="404040"/>
+                </a:solidFill>
+                <a:latin typeface="Century Gothic"/>
+              </a:rPr>
+              <a:t>poner en marcha y robustecer el emprendimiento.</a:t>
             </a:r>
           </a:p>
           <a:p>
-            <a:pPr algn="ctr" hangingPunct="1"/>
+            <a:pPr algn="ctr" hangingPunct="1">
+              <a:spcAft>
+                <a:spcPts val="600"/>
+              </a:spcAft>
+            </a:pPr>
             <a:r>
-              <a:rPr lang="es-CO" sz="2400" b="1" dirty="0">
-                <a:solidFill>
-                  <a:schemeClr val="accent6"/>
-                </a:solidFill>
-                <a:latin typeface="Century Gothic" panose="020B0502020202020204" pitchFamily="34" charset="0"/>
-                <a:cs typeface="Candara"/>
+              <a:rPr b="1" sz="1600">
+                <a:solidFill>
+                  <a:srgbClr val="1E3B7D"/>
+                </a:solidFill>
+                <a:latin typeface="Century Gothic"/>
               </a:rPr>
-              <a:t>•  Actividades: convocatorias, capital semilla, propiedad intelectual, spin-offs.</a:t>
+              <a:t>Actividades: </a:t>
+            </a:r>
+            <a:r>
+              <a:rPr sz="1600">
+                <a:solidFill>
+                  <a:srgbClr val="404040"/>
+                </a:solidFill>
+                <a:latin typeface="Century Gothic"/>
+              </a:rPr>
+              <a:t>mentorías, branding, transformación digital, asesoría legal y tributaria.</a:t>
             </a:r>
           </a:p>
           <a:p>
-            <a:pPr algn="ctr" hangingPunct="1"/>
+            <a:pPr algn="ctr" hangingPunct="1">
+              <a:spcAft>
+                <a:spcPts val="600"/>
+              </a:spcAft>
+            </a:pPr>
             <a:r>
-              <a:rPr lang="es-CO" sz="2400" b="1" dirty="0">
-                <a:solidFill>
-                  <a:schemeClr val="accent6"/>
-                </a:solidFill>
-                <a:latin typeface="Century Gothic" panose="020B0502020202020204" pitchFamily="34" charset="0"/>
-                <a:cs typeface="Candara"/>
+              <a:rPr b="1" sz="1600">
+                <a:solidFill>
+                  <a:srgbClr val="1E3B7D"/>
+                </a:solidFill>
+                <a:latin typeface="Century Gothic"/>
               </a:rPr>
-              <a:t>•  Entregable: proyecto conectado a financiación y mercado.</a:t>
+              <a:t>Metodologías: </a:t>
+            </a:r>
+            <a:r>
+              <a:rPr sz="1600">
+                <a:solidFill>
+                  <a:srgbClr val="404040"/>
+                </a:solidFill>
+                <a:latin typeface="Century Gothic"/>
+              </a:rPr>
+              <a:t>mentoría estructurada; herramientas de branding y digitales.</a:t>
+            </a:r>
+          </a:p>
+          <a:p>
+            <a:pPr algn="ctr" hangingPunct="1">
+              <a:spcAft>
+                <a:spcPts val="600"/>
+              </a:spcAft>
+            </a:pPr>
+            <a:r>
+              <a:rPr b="1" sz="1600">
+                <a:solidFill>
+                  <a:srgbClr val="1E3B7D"/>
+                </a:solidFill>
+                <a:latin typeface="Century Gothic"/>
+              </a:rPr>
+              <a:t>Responsables: </a:t>
+            </a:r>
+            <a:r>
+              <a:rPr sz="1600">
+                <a:solidFill>
+                  <a:srgbClr val="404040"/>
+                </a:solidFill>
+                <a:latin typeface="Century Gothic"/>
+              </a:rPr>
+              <a:t>mentores multidisciplinarios y aliados.</a:t>
+            </a:r>
+          </a:p>
+          <a:p>
+            <a:pPr algn="ctr" hangingPunct="1">
+              <a:spcAft>
+                <a:spcPts val="600"/>
+              </a:spcAft>
+            </a:pPr>
+            <a:r>
+              <a:rPr b="1" sz="1600">
+                <a:solidFill>
+                  <a:srgbClr val="1E3B7D"/>
+                </a:solidFill>
+                <a:latin typeface="Century Gothic"/>
+              </a:rPr>
+              <a:t>Entregable: </a:t>
+            </a:r>
+            <a:r>
+              <a:rPr sz="1600">
+                <a:solidFill>
+                  <a:srgbClr val="404040"/>
+                </a:solidFill>
+                <a:latin typeface="Century Gothic"/>
+              </a:rPr>
+              <a:t>emprendimiento en operación con acompañamiento.</a:t>
+            </a:r>
+          </a:p>
+          <a:p>
+            <a:pPr algn="ctr" hangingPunct="1">
+              <a:spcAft>
+                <a:spcPts val="600"/>
+              </a:spcAft>
+            </a:pPr>
+            <a:r>
+              <a:rPr b="1" sz="1600">
+                <a:solidFill>
+                  <a:srgbClr val="1E3B7D"/>
+                </a:solidFill>
+                <a:latin typeface="Century Gothic"/>
+              </a:rPr>
+              <a:t>Tiempo: </a:t>
+            </a:r>
+            <a:r>
+              <a:rPr sz="1600">
+                <a:solidFill>
+                  <a:srgbClr val="404040"/>
+                </a:solidFill>
+                <a:latin typeface="Century Gothic"/>
+              </a:rPr>
+              <a:t>semanas 8 a 14.</a:t>
             </a:r>
           </a:p>
         </p:txBody>
@@ -9554,7 +10123,7 @@
                 </a:solidFill>
                 <a:latin typeface="Century Gothic" panose="020B0502020202020204" pitchFamily="34" charset="0"/>
               </a:rPr>
-              <a:t>Indicadores de seguimiento</a:t>
+              <a:t>Fase 6 · Aceleración, financiación y transferencia</a:t>
             </a:r>
             <a:endParaRPr kumimoji="0" lang="en-US" sz="4800" b="0" i="0" u="none" strike="noStrike" kern="1200" cap="none" spc="0" normalizeH="0" baseline="0" noProof="0" dirty="0">
               <a:ln>
@@ -9581,8 +10150,8 @@
         </p:nvSpPr>
         <p:spPr>
           <a:xfrm>
-            <a:off x="4796053" y="8498663"/>
-            <a:ext cx="14791894" cy="2000550"/>
+            <a:off x="3200400" y="7589520"/>
+            <a:ext cx="18013680" cy="5669280"/>
           </a:xfrm>
           <a:prstGeom prst="rect">
             <a:avLst/>
@@ -9856,68 +10425,128 @@
             </a:lvl9pPr>
           </a:lstStyle>
           <a:p>
-            <a:pPr algn="ctr" hangingPunct="1"/>
+            <a:pPr algn="ctr" hangingPunct="1">
+              <a:spcAft>
+                <a:spcPts val="600"/>
+              </a:spcAft>
+            </a:pPr>
             <a:r>
-              <a:rPr lang="es-CO" sz="2400" b="1" dirty="0">
-                <a:solidFill>
-                  <a:schemeClr val="accent6"/>
-                </a:solidFill>
-                <a:latin typeface="Century Gothic" panose="020B0502020202020204" pitchFamily="34" charset="0"/>
-                <a:cs typeface="Candara"/>
+              <a:rPr b="1" sz="1600">
+                <a:solidFill>
+                  <a:srgbClr val="1E3B7D"/>
+                </a:solidFill>
+                <a:latin typeface="Century Gothic"/>
               </a:rPr>
-              <a:t>•  Personas sensibilizadas por año.</a:t>
+              <a:t>Objetivo: </a:t>
+            </a:r>
+            <a:r>
+              <a:rPr sz="1600">
+                <a:solidFill>
+                  <a:srgbClr val="404040"/>
+                </a:solidFill>
+                <a:latin typeface="Century Gothic"/>
+              </a:rPr>
+              <a:t>escalar y conectar la iniciativa con el ecosistema.</a:t>
             </a:r>
           </a:p>
           <a:p>
-            <a:pPr algn="ctr" hangingPunct="1"/>
+            <a:pPr algn="ctr" hangingPunct="1">
+              <a:spcAft>
+                <a:spcPts val="600"/>
+              </a:spcAft>
+            </a:pPr>
             <a:r>
-              <a:rPr lang="es-CO" sz="2400" b="1" dirty="0">
-                <a:solidFill>
-                  <a:schemeClr val="accent6"/>
-                </a:solidFill>
-                <a:latin typeface="Century Gothic" panose="020B0502020202020204" pitchFamily="34" charset="0"/>
-                <a:cs typeface="Candara"/>
+              <a:rPr b="1" sz="1600">
+                <a:solidFill>
+                  <a:srgbClr val="1E3B7D"/>
+                </a:solidFill>
+                <a:latin typeface="Century Gothic"/>
               </a:rPr>
-              <a:t>•  Proyectos diagnosticados y acompañados por fase.</a:t>
+              <a:t>Actividades: </a:t>
+            </a:r>
+            <a:r>
+              <a:rPr sz="1600">
+                <a:solidFill>
+                  <a:srgbClr val="404040"/>
+                </a:solidFill>
+                <a:latin typeface="Century Gothic"/>
+              </a:rPr>
+              <a:t>ferias y ruedas de negocio, convocatorias y capital semilla, propiedad intelectual, spin-offs.</a:t>
             </a:r>
           </a:p>
           <a:p>
-            <a:pPr algn="ctr" hangingPunct="1"/>
+            <a:pPr algn="ctr" hangingPunct="1">
+              <a:spcAft>
+                <a:spcPts val="600"/>
+              </a:spcAft>
+            </a:pPr>
             <a:r>
-              <a:rPr lang="es-CO" sz="2400" b="1" dirty="0">
-                <a:solidFill>
-                  <a:schemeClr val="accent6"/>
-                </a:solidFill>
-                <a:latin typeface="Century Gothic" panose="020B0502020202020204" pitchFamily="34" charset="0"/>
-                <a:cs typeface="Candara"/>
+              <a:rPr b="1" sz="1600">
+                <a:solidFill>
+                  <a:srgbClr val="1E3B7D"/>
+                </a:solidFill>
+                <a:latin typeface="Century Gothic"/>
               </a:rPr>
-              <a:t>•  % de proyectos vigentes a 3 años (≥3% — meta PDI).</a:t>
+              <a:t>Aliados: </a:t>
+            </a:r>
+            <a:r>
+              <a:rPr sz="1600">
+                <a:solidFill>
+                  <a:srgbClr val="404040"/>
+                </a:solidFill>
+                <a:latin typeface="Century Gothic"/>
+              </a:rPr>
+              <a:t>Cientech (OTRI), Parque Tecnológico del Caribe, CICIT, Cámaras de Comercio, inversionistas.</a:t>
             </a:r>
           </a:p>
           <a:p>
-            <a:pPr algn="ctr" hangingPunct="1"/>
+            <a:pPr algn="ctr" hangingPunct="1">
+              <a:spcAft>
+                <a:spcPts val="600"/>
+              </a:spcAft>
+            </a:pPr>
             <a:r>
-              <a:rPr lang="es-CO" sz="2400" b="1" dirty="0">
-                <a:solidFill>
-                  <a:schemeClr val="accent6"/>
-                </a:solidFill>
-                <a:latin typeface="Century Gothic" panose="020B0502020202020204" pitchFamily="34" charset="0"/>
-                <a:cs typeface="Candara"/>
+              <a:rPr b="1" sz="1600">
+                <a:solidFill>
+                  <a:srgbClr val="1E3B7D"/>
+                </a:solidFill>
+                <a:latin typeface="Century Gothic"/>
               </a:rPr>
-              <a:t>•  Títulos de propiedad intelectual y spin-offs.</a:t>
+              <a:t>Entregable: </a:t>
+            </a:r>
+            <a:r>
+              <a:rPr sz="1600">
+                <a:solidFill>
+                  <a:srgbClr val="404040"/>
+                </a:solidFill>
+                <a:latin typeface="Century Gothic"/>
+              </a:rPr>
+              <a:t>proyecto conectado a financiación y mercado; propiedad intelectual protegida.</a:t>
             </a:r>
           </a:p>
           <a:p>
-            <a:pPr algn="ctr" hangingPunct="1"/>
+            <a:pPr algn="ctr" hangingPunct="1">
+              <a:spcAft>
+                <a:spcPts val="600"/>
+              </a:spcAft>
+            </a:pPr>
             <a:r>
-              <a:rPr lang="es-CO" sz="2400" b="1" dirty="0">
-                <a:solidFill>
-                  <a:schemeClr val="accent6"/>
-                </a:solidFill>
-                <a:latin typeface="Century Gothic" panose="020B0502020202020204" pitchFamily="34" charset="0"/>
-                <a:cs typeface="Candara"/>
+              <a:rPr b="1" sz="1600">
+                <a:solidFill>
+                  <a:srgbClr val="1E3B7D"/>
+                </a:solidFill>
+                <a:latin typeface="Century Gothic"/>
               </a:rPr>
-              <a:t>•  Facultades con docente enlace activo.</a:t>
+              <a:t>Tiempo: </a:t>
+            </a:r>
+            <a:r>
+              <a:rPr sz="1600">
+                <a:solidFill>
+                  <a:srgbClr val="404040"/>
+                </a:solidFill>
+                <a:latin typeface="Century Gothic"/>
+              </a:rPr>
+              <a:t>semana 14 en adelante.</a:t>
             </a:r>
           </a:p>
         </p:txBody>
@@ -9999,6 +10628,451 @@
                 </a:solidFill>
                 <a:latin typeface="Century Gothic" panose="020B0502020202020204" pitchFamily="34" charset="0"/>
               </a:rPr>
+              <a:t>Indicadores de seguimiento</a:t>
+            </a:r>
+            <a:endParaRPr kumimoji="0" lang="en-US" sz="4800" b="0" i="0" u="none" strike="noStrike" kern="1200" cap="none" spc="0" normalizeH="0" baseline="0" noProof="0" dirty="0">
+              <a:ln>
+                <a:noFill/>
+              </a:ln>
+              <a:solidFill>
+                <a:schemeClr val="tx1"/>
+              </a:solidFill>
+              <a:effectLst/>
+              <a:uLnTx/>
+              <a:uFillTx/>
+              <a:latin typeface="Lato Black" panose="020F0A02020204030203" pitchFamily="34" charset="0"/>
+            </a:endParaRPr>
+          </a:p>
+        </p:txBody>
+      </p:sp>
+      <p:sp>
+        <p:nvSpPr>
+          <p:cNvPr id="13" name="Google Shape;139;p19"/>
+          <p:cNvSpPr txBox="1">
+            <a:spLocks/>
+          </p:cNvSpPr>
+          <p:nvPr/>
+        </p:nvSpPr>
+        <p:spPr>
+          <a:xfrm>
+            <a:off x="3200400" y="7589520"/>
+            <a:ext cx="18013680" cy="5486400"/>
+          </a:xfrm>
+          <a:prstGeom prst="rect">
+            <a:avLst/>
+          </a:prstGeom>
+        </p:spPr>
+        <p:txBody>
+          <a:bodyPr spcFirstLastPara="1" wrap="square" lIns="91425" tIns="91425" rIns="91425" bIns="91425" anchor="t" anchorCtr="0">
+            <a:noAutofit/>
+          </a:bodyPr>
+          <a:lstStyle>
+            <a:lvl1pPr marL="0" marR="0" indent="0" algn="just" defTabSz="825500" rtl="0" latinLnBrk="0">
+              <a:lnSpc>
+                <a:spcPct val="120000"/>
+              </a:lnSpc>
+              <a:spcBef>
+                <a:spcPts val="0"/>
+              </a:spcBef>
+              <a:spcAft>
+                <a:spcPts val="0"/>
+              </a:spcAft>
+              <a:buClrTx/>
+              <a:buSzTx/>
+              <a:buFontTx/>
+              <a:buNone/>
+              <a:tabLst/>
+              <a:defRPr sz="2400" b="0" i="0" u="none" strike="noStrike" cap="none" spc="0" baseline="0">
+                <a:ln>
+                  <a:noFill/>
+                </a:ln>
+                <a:solidFill>
+                  <a:srgbClr val="868A8D"/>
+                </a:solidFill>
+                <a:uFillTx/>
+                <a:latin typeface="Montserrat Light"/>
+                <a:ea typeface="Montserrat Light"/>
+                <a:cs typeface="Montserrat Light"/>
+                <a:sym typeface="Montserrat Light"/>
+              </a:defRPr>
+            </a:lvl1pPr>
+            <a:lvl2pPr marL="0" marR="0" indent="228600" algn="just" defTabSz="825500" rtl="0" latinLnBrk="0">
+              <a:lnSpc>
+                <a:spcPct val="120000"/>
+              </a:lnSpc>
+              <a:spcBef>
+                <a:spcPts val="0"/>
+              </a:spcBef>
+              <a:spcAft>
+                <a:spcPts val="0"/>
+              </a:spcAft>
+              <a:buClrTx/>
+              <a:buSzTx/>
+              <a:buFontTx/>
+              <a:buNone/>
+              <a:tabLst/>
+              <a:defRPr sz="2400" b="0" i="0" u="none" strike="noStrike" cap="none" spc="0" baseline="0">
+                <a:ln>
+                  <a:noFill/>
+                </a:ln>
+                <a:solidFill>
+                  <a:srgbClr val="868A8D"/>
+                </a:solidFill>
+                <a:uFillTx/>
+                <a:latin typeface="Montserrat Light"/>
+                <a:ea typeface="Montserrat Light"/>
+                <a:cs typeface="Montserrat Light"/>
+                <a:sym typeface="Montserrat Light"/>
+              </a:defRPr>
+            </a:lvl2pPr>
+            <a:lvl3pPr marL="0" marR="0" indent="457200" algn="just" defTabSz="825500" rtl="0" latinLnBrk="0">
+              <a:lnSpc>
+                <a:spcPct val="120000"/>
+              </a:lnSpc>
+              <a:spcBef>
+                <a:spcPts val="0"/>
+              </a:spcBef>
+              <a:spcAft>
+                <a:spcPts val="0"/>
+              </a:spcAft>
+              <a:buClrTx/>
+              <a:buSzTx/>
+              <a:buFontTx/>
+              <a:buNone/>
+              <a:tabLst/>
+              <a:defRPr sz="2400" b="0" i="0" u="none" strike="noStrike" cap="none" spc="0" baseline="0">
+                <a:ln>
+                  <a:noFill/>
+                </a:ln>
+                <a:solidFill>
+                  <a:srgbClr val="868A8D"/>
+                </a:solidFill>
+                <a:uFillTx/>
+                <a:latin typeface="Montserrat Light"/>
+                <a:ea typeface="Montserrat Light"/>
+                <a:cs typeface="Montserrat Light"/>
+                <a:sym typeface="Montserrat Light"/>
+              </a:defRPr>
+            </a:lvl3pPr>
+            <a:lvl4pPr marL="0" marR="0" indent="685800" algn="just" defTabSz="825500" rtl="0" latinLnBrk="0">
+              <a:lnSpc>
+                <a:spcPct val="120000"/>
+              </a:lnSpc>
+              <a:spcBef>
+                <a:spcPts val="0"/>
+              </a:spcBef>
+              <a:spcAft>
+                <a:spcPts val="0"/>
+              </a:spcAft>
+              <a:buClrTx/>
+              <a:buSzTx/>
+              <a:buFontTx/>
+              <a:buNone/>
+              <a:tabLst/>
+              <a:defRPr sz="2400" b="0" i="0" u="none" strike="noStrike" cap="none" spc="0" baseline="0">
+                <a:ln>
+                  <a:noFill/>
+                </a:ln>
+                <a:solidFill>
+                  <a:srgbClr val="868A8D"/>
+                </a:solidFill>
+                <a:uFillTx/>
+                <a:latin typeface="Montserrat Light"/>
+                <a:ea typeface="Montserrat Light"/>
+                <a:cs typeface="Montserrat Light"/>
+                <a:sym typeface="Montserrat Light"/>
+              </a:defRPr>
+            </a:lvl4pPr>
+            <a:lvl5pPr marL="0" marR="0" indent="914400" algn="just" defTabSz="825500" rtl="0" latinLnBrk="0">
+              <a:lnSpc>
+                <a:spcPct val="120000"/>
+              </a:lnSpc>
+              <a:spcBef>
+                <a:spcPts val="0"/>
+              </a:spcBef>
+              <a:spcAft>
+                <a:spcPts val="0"/>
+              </a:spcAft>
+              <a:buClrTx/>
+              <a:buSzTx/>
+              <a:buFontTx/>
+              <a:buNone/>
+              <a:tabLst/>
+              <a:defRPr sz="2400" b="0" i="0" u="none" strike="noStrike" cap="none" spc="0" baseline="0">
+                <a:ln>
+                  <a:noFill/>
+                </a:ln>
+                <a:solidFill>
+                  <a:srgbClr val="868A8D"/>
+                </a:solidFill>
+                <a:uFillTx/>
+                <a:latin typeface="Montserrat Light"/>
+                <a:ea typeface="Montserrat Light"/>
+                <a:cs typeface="Montserrat Light"/>
+                <a:sym typeface="Montserrat Light"/>
+              </a:defRPr>
+            </a:lvl5pPr>
+            <a:lvl6pPr marL="0" marR="0" indent="1143000" algn="just" defTabSz="825500" rtl="0" latinLnBrk="0">
+              <a:lnSpc>
+                <a:spcPct val="120000"/>
+              </a:lnSpc>
+              <a:spcBef>
+                <a:spcPts val="0"/>
+              </a:spcBef>
+              <a:spcAft>
+                <a:spcPts val="0"/>
+              </a:spcAft>
+              <a:buClrTx/>
+              <a:buSzTx/>
+              <a:buFontTx/>
+              <a:buNone/>
+              <a:tabLst/>
+              <a:defRPr sz="2400" b="0" i="0" u="none" strike="noStrike" cap="none" spc="0" baseline="0">
+                <a:ln>
+                  <a:noFill/>
+                </a:ln>
+                <a:solidFill>
+                  <a:srgbClr val="868A8D"/>
+                </a:solidFill>
+                <a:uFillTx/>
+                <a:latin typeface="Montserrat Light"/>
+                <a:ea typeface="Montserrat Light"/>
+                <a:cs typeface="Montserrat Light"/>
+                <a:sym typeface="Montserrat Light"/>
+              </a:defRPr>
+            </a:lvl6pPr>
+            <a:lvl7pPr marL="0" marR="0" indent="1371600" algn="just" defTabSz="825500" rtl="0" latinLnBrk="0">
+              <a:lnSpc>
+                <a:spcPct val="120000"/>
+              </a:lnSpc>
+              <a:spcBef>
+                <a:spcPts val="0"/>
+              </a:spcBef>
+              <a:spcAft>
+                <a:spcPts val="0"/>
+              </a:spcAft>
+              <a:buClrTx/>
+              <a:buSzTx/>
+              <a:buFontTx/>
+              <a:buNone/>
+              <a:tabLst/>
+              <a:defRPr sz="2400" b="0" i="0" u="none" strike="noStrike" cap="none" spc="0" baseline="0">
+                <a:ln>
+                  <a:noFill/>
+                </a:ln>
+                <a:solidFill>
+                  <a:srgbClr val="868A8D"/>
+                </a:solidFill>
+                <a:uFillTx/>
+                <a:latin typeface="Montserrat Light"/>
+                <a:ea typeface="Montserrat Light"/>
+                <a:cs typeface="Montserrat Light"/>
+                <a:sym typeface="Montserrat Light"/>
+              </a:defRPr>
+            </a:lvl7pPr>
+            <a:lvl8pPr marL="0" marR="0" indent="1600200" algn="just" defTabSz="825500" rtl="0" latinLnBrk="0">
+              <a:lnSpc>
+                <a:spcPct val="120000"/>
+              </a:lnSpc>
+              <a:spcBef>
+                <a:spcPts val="0"/>
+              </a:spcBef>
+              <a:spcAft>
+                <a:spcPts val="0"/>
+              </a:spcAft>
+              <a:buClrTx/>
+              <a:buSzTx/>
+              <a:buFontTx/>
+              <a:buNone/>
+              <a:tabLst/>
+              <a:defRPr sz="2400" b="0" i="0" u="none" strike="noStrike" cap="none" spc="0" baseline="0">
+                <a:ln>
+                  <a:noFill/>
+                </a:ln>
+                <a:solidFill>
+                  <a:srgbClr val="868A8D"/>
+                </a:solidFill>
+                <a:uFillTx/>
+                <a:latin typeface="Montserrat Light"/>
+                <a:ea typeface="Montserrat Light"/>
+                <a:cs typeface="Montserrat Light"/>
+                <a:sym typeface="Montserrat Light"/>
+              </a:defRPr>
+            </a:lvl8pPr>
+            <a:lvl9pPr marL="0" marR="0" indent="1828800" algn="just" defTabSz="825500" rtl="0" latinLnBrk="0">
+              <a:lnSpc>
+                <a:spcPct val="120000"/>
+              </a:lnSpc>
+              <a:spcBef>
+                <a:spcPts val="0"/>
+              </a:spcBef>
+              <a:spcAft>
+                <a:spcPts val="0"/>
+              </a:spcAft>
+              <a:buClrTx/>
+              <a:buSzTx/>
+              <a:buFontTx/>
+              <a:buNone/>
+              <a:tabLst/>
+              <a:defRPr sz="2400" b="0" i="0" u="none" strike="noStrike" cap="none" spc="0" baseline="0">
+                <a:ln>
+                  <a:noFill/>
+                </a:ln>
+                <a:solidFill>
+                  <a:srgbClr val="868A8D"/>
+                </a:solidFill>
+                <a:uFillTx/>
+                <a:latin typeface="Montserrat Light"/>
+                <a:ea typeface="Montserrat Light"/>
+                <a:cs typeface="Montserrat Light"/>
+                <a:sym typeface="Montserrat Light"/>
+              </a:defRPr>
+            </a:lvl9pPr>
+          </a:lstStyle>
+          <a:p>
+            <a:pPr algn="ctr" hangingPunct="1"/>
+            <a:r>
+              <a:rPr lang="es-CO" sz="2000" b="1" dirty="0">
+                <a:solidFill>
+                  <a:schemeClr val="accent6"/>
+                </a:solidFill>
+                <a:latin typeface="Century Gothic" panose="020B0502020202020204" pitchFamily="34" charset="0"/>
+                <a:cs typeface="Candara"/>
+              </a:rPr>
+              <a:t>•  Personas sensibilizadas por año.</a:t>
+            </a:r>
+          </a:p>
+          <a:p>
+            <a:pPr algn="ctr" hangingPunct="1"/>
+            <a:r>
+              <a:rPr lang="es-CO" sz="2000" b="1" dirty="0">
+                <a:solidFill>
+                  <a:schemeClr val="accent6"/>
+                </a:solidFill>
+                <a:latin typeface="Century Gothic" panose="020B0502020202020204" pitchFamily="34" charset="0"/>
+                <a:cs typeface="Candara"/>
+              </a:rPr>
+              <a:t>•  Proyectos diagnosticados y acompañados por fase.</a:t>
+            </a:r>
+          </a:p>
+          <a:p>
+            <a:pPr algn="ctr" hangingPunct="1"/>
+            <a:r>
+              <a:rPr lang="es-CO" sz="2000" b="1" dirty="0">
+                <a:solidFill>
+                  <a:schemeClr val="accent6"/>
+                </a:solidFill>
+                <a:latin typeface="Century Gothic" panose="020B0502020202020204" pitchFamily="34" charset="0"/>
+                <a:cs typeface="Candara"/>
+              </a:rPr>
+              <a:t>•  % de proyectos vigentes a 3 años (≥3% — meta PDI).</a:t>
+            </a:r>
+          </a:p>
+          <a:p>
+            <a:pPr algn="ctr" hangingPunct="1"/>
+            <a:r>
+              <a:rPr lang="es-CO" sz="2000" b="1" dirty="0">
+                <a:solidFill>
+                  <a:schemeClr val="accent6"/>
+                </a:solidFill>
+                <a:latin typeface="Century Gothic" panose="020B0502020202020204" pitchFamily="34" charset="0"/>
+                <a:cs typeface="Candara"/>
+              </a:rPr>
+              <a:t>•  Títulos de propiedad intelectual y spin-offs.</a:t>
+            </a:r>
+          </a:p>
+          <a:p>
+            <a:pPr algn="ctr" hangingPunct="1"/>
+            <a:r>
+              <a:rPr lang="es-CO" sz="2000" b="1" dirty="0">
+                <a:solidFill>
+                  <a:schemeClr val="accent6"/>
+                </a:solidFill>
+                <a:latin typeface="Century Gothic" panose="020B0502020202020204" pitchFamily="34" charset="0"/>
+                <a:cs typeface="Candara"/>
+              </a:rPr>
+              <a:t>•  Facultades con docente enlace activo.</a:t>
+            </a:r>
+          </a:p>
+        </p:txBody>
+      </p:sp>
+    </p:spTree>
+  </p:cSld>
+  <p:clrMapOvr>
+    <a:masterClrMapping/>
+  </p:clrMapOvr>
+</p:sld>
+</file>
+
+<file path=ppt/slides/slide31.xml><?xml version="1.0" encoding="utf-8"?>
+<p:sld xmlns:a="http://schemas.openxmlformats.org/drawingml/2006/main" xmlns:p="http://schemas.openxmlformats.org/presentationml/2006/main" xmlns:r="http://schemas.openxmlformats.org/officeDocument/2006/relationships">
+  <p:cSld>
+    <p:spTree>
+      <p:nvGrpSpPr>
+        <p:cNvPr id="1" name=""/>
+        <p:cNvGrpSpPr/>
+        <p:nvPr/>
+      </p:nvGrpSpPr>
+      <p:grpSpPr/>
+      <p:sp>
+        <p:nvSpPr>
+          <p:cNvPr id="12" name="Rounded Rectangle 8"/>
+          <p:cNvSpPr/>
+          <p:nvPr/>
+        </p:nvSpPr>
+        <p:spPr>
+          <a:xfrm>
+            <a:off x="8066679" y="6138782"/>
+            <a:ext cx="7097853" cy="1412940"/>
+          </a:xfrm>
+          <a:prstGeom prst="roundRect">
+            <a:avLst>
+              <a:gd name="adj" fmla="val 50000"/>
+            </a:avLst>
+          </a:prstGeom>
+          <a:solidFill>
+            <a:srgbClr val="D07137"/>
+          </a:solidFill>
+          <a:ln>
+            <a:noFill/>
+          </a:ln>
+        </p:spPr>
+        <p:style>
+          <a:lnRef idx="2">
+            <a:schemeClr val="accent1">
+              <a:shade val="50000"/>
+            </a:schemeClr>
+          </a:lnRef>
+          <a:fillRef idx="1">
+            <a:schemeClr val="accent1"/>
+          </a:fillRef>
+          <a:effectRef idx="0">
+            <a:schemeClr val="accent1"/>
+          </a:effectRef>
+          <a:fontRef idx="minor">
+            <a:schemeClr val="lt1"/>
+          </a:fontRef>
+        </p:style>
+        <p:txBody>
+          <a:bodyPr rtlCol="0" anchor="ctr"/>
+          <a:lstStyle/>
+          <a:p>
+            <a:pPr lvl="0" algn="ctr" defTabSz="914400" hangingPunct="1">
+              <a:lnSpc>
+                <a:spcPct val="100000"/>
+              </a:lnSpc>
+              <a:defRPr/>
+            </a:pPr>
+            <a:r>
+              <a:rPr lang="pt-BR" sz="5400" b="1" kern="1200" dirty="0">
+                <a:ln w="0">
+                  <a:noFill/>
+                </a:ln>
+                <a:solidFill>
+                  <a:schemeClr val="tx1"/>
+                </a:solidFill>
+                <a:latin typeface="Century Gothic" panose="020B0502020202020204" pitchFamily="34" charset="0"/>
+              </a:rPr>
               <a:t>Articulación con las facultades</a:t>
             </a:r>
             <a:endParaRPr kumimoji="0" lang="en-US" sz="4800" b="0" i="0" u="none" strike="noStrike" kern="1200" cap="none" spc="0" normalizeH="0" baseline="0" noProof="0" dirty="0">
@@ -10026,8 +11100,8 @@
         </p:nvSpPr>
         <p:spPr>
           <a:xfrm>
-            <a:off x="4796053" y="8498663"/>
-            <a:ext cx="14791894" cy="2000550"/>
+            <a:off x="3200400" y="7589520"/>
+            <a:ext cx="18013680" cy="5486400"/>
           </a:xfrm>
           <a:prstGeom prst="rect">
             <a:avLst/>
@@ -10303,7 +11377,7 @@
           <a:p>
             <a:pPr algn="ctr" hangingPunct="1"/>
             <a:r>
-              <a:rPr lang="es-CO" sz="2400" b="1" dirty="0">
+              <a:rPr lang="es-CO" sz="2000" b="1" dirty="0">
                 <a:solidFill>
                   <a:schemeClr val="accent6"/>
                 </a:solidFill>
@@ -10316,7 +11390,7 @@
           <a:p>
             <a:pPr algn="ctr" hangingPunct="1"/>
             <a:r>
-              <a:rPr lang="es-CO" sz="2400" b="1" dirty="0">
+              <a:rPr lang="es-CO" sz="2000" b="1" dirty="0">
                 <a:solidFill>
                   <a:schemeClr val="accent6"/>
                 </a:solidFill>
@@ -10329,7 +11403,7 @@
           <a:p>
             <a:pPr algn="ctr" hangingPunct="1"/>
             <a:r>
-              <a:rPr lang="es-CO" sz="2400" b="1" dirty="0">
+              <a:rPr lang="es-CO" sz="2000" b="1" dirty="0">
                 <a:solidFill>
                   <a:schemeClr val="accent6"/>
                 </a:solidFill>
@@ -10342,7 +11416,7 @@
           <a:p>
             <a:pPr algn="ctr" hangingPunct="1"/>
             <a:r>
-              <a:rPr lang="es-CO" sz="2400" b="1" dirty="0">
+              <a:rPr lang="es-CO" sz="2000" b="1" dirty="0">
                 <a:solidFill>
                   <a:schemeClr val="accent6"/>
                 </a:solidFill>
@@ -10979,7 +12053,7 @@
                 </a:solidFill>
                 <a:latin typeface="Century Gothic" panose="020B0502020202020204" pitchFamily="34" charset="0"/>
               </a:rPr>
-              <a:t>…pese a que el 87,7% manifiesta interés en emprender. El reto no es la motivación: es la visibilidad, el acceso y la articulación con las facultades.</a:t>
+              <a:t>…pese a que el 87,7% manifiesta interés en emprender. Por eso esta guía busca dar a conocer la ruta y facilitar el acceso de toda la comunidad.</a:t>
             </a:r>
           </a:p>
         </p:txBody>

</xml_diff>

<commit_message>
Corregir proporcion: titulo superior, area de contenido amplia y letra mas grande
</commit_message>
<xml_diff>
--- a/Ruta-Emprendimiento-CIE.pptx
+++ b/Ruta-Emprendimiento-CIE.pptx
@@ -5206,7 +5206,7 @@
             <a:p>
               <a:pPr algn="l" hangingPunct="1"/>
               <a:r>
-                <a:rPr lang="es-CO" sz="6000" b="1" dirty="0">
+                <a:rPr lang="es-CO" sz="8000" b="1" dirty="0">
                   <a:solidFill>
                     <a:schemeClr val="tx1"/>
                   </a:solidFill>
@@ -5248,7 +5248,7 @@
             <a:p>
               <a:pPr algn="l" hangingPunct="1"/>
               <a:r>
-                <a:rPr lang="es-CO" sz="2600" dirty="0">
+                <a:rPr lang="es-CO" sz="4000" dirty="0">
                   <a:solidFill>
                     <a:schemeClr val="tx1"/>
                   </a:solidFill>
@@ -5308,7 +5308,7 @@
               </a:lnSpc>
             </a:pPr>
             <a:r>
-              <a:rPr lang="es-ES" sz="2800" b="1" dirty="0">
+              <a:rPr lang="es-ES" sz="3400" b="1" dirty="0">
                 <a:solidFill>
                   <a:schemeClr val="tx1"/>
                 </a:solidFill>
@@ -5325,7 +5325,7 @@
               </a:lnSpc>
             </a:pPr>
             <a:r>
-              <a:rPr lang="es-ES" sz="2000" b="1" dirty="0">
+              <a:rPr lang="es-ES" sz="2600" b="1" dirty="0">
                 <a:solidFill>
                   <a:schemeClr val="tx1"/>
                 </a:solidFill>
@@ -5342,7 +5342,7 @@
               </a:lnSpc>
             </a:pPr>
             <a:r>
-              <a:rPr lang="es-ES" sz="2000" b="1" dirty="0">
+              <a:rPr lang="es-ES" sz="2600" b="1" dirty="0">
                 <a:solidFill>
                   <a:schemeClr val="tx1"/>
                 </a:solidFill>
@@ -5537,8 +5537,8 @@
         </p:nvSpPr>
         <p:spPr>
           <a:xfrm>
-            <a:off x="8066679" y="6138782"/>
-            <a:ext cx="7097853" cy="1412940"/>
+            <a:off x="3017520" y="1097280"/>
+            <a:ext cx="18288000" cy="1737360"/>
           </a:xfrm>
           <a:prstGeom prst="roundRect">
             <a:avLst>
@@ -5579,7 +5579,7 @@
               <a:defRPr/>
             </a:pPr>
             <a:r>
-              <a:rPr lang="pt-BR" sz="5400" b="1" kern="1200" dirty="0">
+              <a:rPr lang="pt-BR" sz="3400" b="1" kern="1200" dirty="0">
                 <a:ln w="0">
                   <a:noFill/>
                 </a:ln>
@@ -5615,8 +5615,8 @@
         </p:nvSpPr>
         <p:spPr>
           <a:xfrm>
-            <a:off x="3200400" y="7589520"/>
-            <a:ext cx="18013680" cy="5486400"/>
+            <a:off x="2194560" y="3657600"/>
+            <a:ext cx="19933920" cy="7863840"/>
           </a:xfrm>
           <a:prstGeom prst="rect">
             <a:avLst/>
@@ -5890,9 +5890,13 @@
             </a:lvl9pPr>
           </a:lstStyle>
           <a:p>
-            <a:pPr algn="ctr" hangingPunct="1"/>
+            <a:pPr algn="l" hangingPunct="1">
+              <a:spcAft>
+                <a:spcPts val="1400"/>
+              </a:spcAft>
+            </a:pPr>
             <a:r>
-              <a:rPr lang="es-CO" sz="2000" b="1" dirty="0">
+              <a:rPr lang="es-CO" sz="3200" b="1" dirty="0">
                 <a:solidFill>
                   <a:schemeClr val="accent6"/>
                 </a:solidFill>
@@ -5903,9 +5907,13 @@
             </a:r>
           </a:p>
           <a:p>
-            <a:pPr algn="ctr" hangingPunct="1"/>
+            <a:pPr algn="l" hangingPunct="1">
+              <a:spcAft>
+                <a:spcPts val="1400"/>
+              </a:spcAft>
+            </a:pPr>
             <a:r>
-              <a:rPr lang="es-CO" sz="2000" b="1" dirty="0">
+              <a:rPr lang="es-CO" sz="3200" b="1" dirty="0">
                 <a:solidFill>
                   <a:schemeClr val="accent6"/>
                 </a:solidFill>
@@ -5916,9 +5924,13 @@
             </a:r>
           </a:p>
           <a:p>
-            <a:pPr algn="ctr" hangingPunct="1"/>
+            <a:pPr algn="l" hangingPunct="1">
+              <a:spcAft>
+                <a:spcPts val="1400"/>
+              </a:spcAft>
+            </a:pPr>
             <a:r>
-              <a:rPr lang="es-CO" sz="2000" b="1" dirty="0">
+              <a:rPr lang="es-CO" sz="3200" b="1" dirty="0">
                 <a:solidFill>
                   <a:schemeClr val="accent6"/>
                 </a:solidFill>
@@ -5929,9 +5941,13 @@
             </a:r>
           </a:p>
           <a:p>
-            <a:pPr algn="ctr" hangingPunct="1"/>
+            <a:pPr algn="l" hangingPunct="1">
+              <a:spcAft>
+                <a:spcPts val="1400"/>
+              </a:spcAft>
+            </a:pPr>
             <a:r>
-              <a:rPr lang="es-CO" sz="2000" b="1" dirty="0">
+              <a:rPr lang="es-CO" sz="3200" b="1" dirty="0">
                 <a:solidFill>
                   <a:schemeClr val="accent6"/>
                 </a:solidFill>
@@ -5969,8 +5985,8 @@
         </p:nvSpPr>
         <p:spPr>
           <a:xfrm>
-            <a:off x="8066679" y="6138782"/>
-            <a:ext cx="7097853" cy="1412940"/>
+            <a:off x="3017520" y="1097280"/>
+            <a:ext cx="18288000" cy="1737360"/>
           </a:xfrm>
           <a:prstGeom prst="roundRect">
             <a:avLst>
@@ -6011,7 +6027,7 @@
               <a:defRPr/>
             </a:pPr>
             <a:r>
-              <a:rPr lang="pt-BR" sz="5400" b="1" kern="1200" dirty="0">
+              <a:rPr lang="pt-BR" sz="3400" b="1" kern="1200" dirty="0">
                 <a:ln w="0">
                   <a:noFill/>
                 </a:ln>
@@ -6047,8 +6063,8 @@
         </p:nvSpPr>
         <p:spPr>
           <a:xfrm>
-            <a:off x="3200400" y="7589520"/>
-            <a:ext cx="18013680" cy="5486400"/>
+            <a:off x="2194560" y="3657600"/>
+            <a:ext cx="19933920" cy="7863840"/>
           </a:xfrm>
           <a:prstGeom prst="rect">
             <a:avLst/>
@@ -6322,9 +6338,13 @@
             </a:lvl9pPr>
           </a:lstStyle>
           <a:p>
-            <a:pPr algn="ctr" hangingPunct="1"/>
+            <a:pPr algn="l" hangingPunct="1">
+              <a:spcAft>
+                <a:spcPts val="1400"/>
+              </a:spcAft>
+            </a:pPr>
             <a:r>
-              <a:rPr lang="es-CO" sz="1900" b="1" dirty="0">
+              <a:rPr lang="es-CO" sz="2800" b="1" dirty="0">
                 <a:solidFill>
                   <a:schemeClr val="accent6"/>
                 </a:solidFill>
@@ -6335,9 +6355,13 @@
             </a:r>
           </a:p>
           <a:p>
-            <a:pPr algn="ctr" hangingPunct="1"/>
+            <a:pPr algn="l" hangingPunct="1">
+              <a:spcAft>
+                <a:spcPts val="1400"/>
+              </a:spcAft>
+            </a:pPr>
             <a:r>
-              <a:rPr lang="es-CO" sz="1900" b="1" dirty="0">
+              <a:rPr lang="es-CO" sz="2800" b="1" dirty="0">
                 <a:solidFill>
                   <a:schemeClr val="accent6"/>
                 </a:solidFill>
@@ -6348,9 +6372,13 @@
             </a:r>
           </a:p>
           <a:p>
-            <a:pPr algn="ctr" hangingPunct="1"/>
+            <a:pPr algn="l" hangingPunct="1">
+              <a:spcAft>
+                <a:spcPts val="1400"/>
+              </a:spcAft>
+            </a:pPr>
             <a:r>
-              <a:rPr lang="es-CO" sz="1900" b="1" dirty="0">
+              <a:rPr lang="es-CO" sz="2800" b="1" dirty="0">
                 <a:solidFill>
                   <a:schemeClr val="accent6"/>
                 </a:solidFill>
@@ -6361,16 +6389,20 @@
             </a:r>
           </a:p>
           <a:p>
-            <a:pPr algn="ctr" hangingPunct="1"/>
+            <a:pPr algn="l" hangingPunct="1">
+              <a:spcAft>
+                <a:spcPts val="1400"/>
+              </a:spcAft>
+            </a:pPr>
             <a:r>
-              <a:rPr lang="es-CO" sz="1900" b="1" dirty="0">
+              <a:rPr lang="es-CO" sz="2800" b="1" dirty="0">
                 <a:solidFill>
                   <a:schemeClr val="accent6"/>
                 </a:solidFill>
                 <a:latin typeface="Century Gothic" panose="020B0502020202020204" pitchFamily="34" charset="0"/>
                 <a:cs typeface="Candara"/>
               </a:rPr>
-              <a:t>•  Metas: política de innovación y emprendimiento; Centro 'UA Emprende' (sostenibilidad ≥3%); 2 spin-off; Parque Tecnológico del Caribe.</a:t>
+              <a:t>•  Metas: política de innovación y emprendimiento; Centro 'UA Emprende' (≥3% sostenibilidad); 2 spin-off; Parque Tecnológico del Caribe.</a:t>
             </a:r>
           </a:p>
         </p:txBody>
@@ -6401,8 +6433,8 @@
         </p:nvSpPr>
         <p:spPr>
           <a:xfrm>
-            <a:off x="8066679" y="6138782"/>
-            <a:ext cx="7097853" cy="1412940"/>
+            <a:off x="3017520" y="1097280"/>
+            <a:ext cx="18288000" cy="1737360"/>
           </a:xfrm>
           <a:prstGeom prst="roundRect">
             <a:avLst>
@@ -6443,7 +6475,7 @@
               <a:defRPr/>
             </a:pPr>
             <a:r>
-              <a:rPr lang="pt-BR" sz="5400" b="1" kern="1200" dirty="0">
+              <a:rPr lang="pt-BR" sz="4000" b="1" kern="1200" dirty="0">
                 <a:ln w="0">
                   <a:noFill/>
                 </a:ln>
@@ -6479,8 +6511,8 @@
         </p:nvSpPr>
         <p:spPr>
           <a:xfrm>
-            <a:off x="3200400" y="7589520"/>
-            <a:ext cx="18013680" cy="5486400"/>
+            <a:off x="2194560" y="3657600"/>
+            <a:ext cx="19933920" cy="7863840"/>
           </a:xfrm>
           <a:prstGeom prst="rect">
             <a:avLst/>
@@ -6754,9 +6786,13 @@
             </a:lvl9pPr>
           </a:lstStyle>
           <a:p>
-            <a:pPr algn="ctr" hangingPunct="1"/>
+            <a:pPr algn="l" hangingPunct="1">
+              <a:spcAft>
+                <a:spcPts val="1400"/>
+              </a:spcAft>
+            </a:pPr>
             <a:r>
-              <a:rPr lang="es-CO" sz="2000" b="1" dirty="0">
+              <a:rPr lang="es-CO" sz="3200" b="1" dirty="0">
                 <a:solidFill>
                   <a:schemeClr val="accent6"/>
                 </a:solidFill>
@@ -6767,9 +6803,13 @@
             </a:r>
           </a:p>
           <a:p>
-            <a:pPr algn="ctr" hangingPunct="1"/>
+            <a:pPr algn="l" hangingPunct="1">
+              <a:spcAft>
+                <a:spcPts val="1400"/>
+              </a:spcAft>
+            </a:pPr>
             <a:r>
-              <a:rPr lang="es-CO" sz="2000" b="1" dirty="0">
+              <a:rPr lang="es-CO" sz="3200" b="1" dirty="0">
                 <a:solidFill>
                   <a:schemeClr val="accent6"/>
                 </a:solidFill>
@@ -6780,9 +6820,13 @@
             </a:r>
           </a:p>
           <a:p>
-            <a:pPr algn="ctr" hangingPunct="1"/>
+            <a:pPr algn="l" hangingPunct="1">
+              <a:spcAft>
+                <a:spcPts val="1400"/>
+              </a:spcAft>
+            </a:pPr>
             <a:r>
-              <a:rPr lang="es-CO" sz="2000" b="1" dirty="0">
+              <a:rPr lang="es-CO" sz="3200" b="1" dirty="0">
                 <a:solidFill>
                   <a:schemeClr val="accent6"/>
                 </a:solidFill>
@@ -6793,9 +6837,13 @@
             </a:r>
           </a:p>
           <a:p>
-            <a:pPr algn="ctr" hangingPunct="1"/>
+            <a:pPr algn="l" hangingPunct="1">
+              <a:spcAft>
+                <a:spcPts val="1400"/>
+              </a:spcAft>
+            </a:pPr>
             <a:r>
-              <a:rPr lang="es-CO" sz="2000" b="1" dirty="0">
+              <a:rPr lang="es-CO" sz="3200" b="1" dirty="0">
                 <a:solidFill>
                   <a:schemeClr val="accent6"/>
                 </a:solidFill>
@@ -6806,9 +6854,13 @@
             </a:r>
           </a:p>
           <a:p>
-            <a:pPr algn="ctr" hangingPunct="1"/>
+            <a:pPr algn="l" hangingPunct="1">
+              <a:spcAft>
+                <a:spcPts val="1400"/>
+              </a:spcAft>
+            </a:pPr>
             <a:r>
-              <a:rPr lang="es-CO" sz="2000" b="1" dirty="0">
+              <a:rPr lang="es-CO" sz="3200" b="1" dirty="0">
                 <a:solidFill>
                   <a:schemeClr val="accent6"/>
                 </a:solidFill>
@@ -6819,9 +6871,13 @@
             </a:r>
           </a:p>
           <a:p>
-            <a:pPr algn="ctr" hangingPunct="1"/>
+            <a:pPr algn="l" hangingPunct="1">
+              <a:spcAft>
+                <a:spcPts val="1400"/>
+              </a:spcAft>
+            </a:pPr>
             <a:r>
-              <a:rPr lang="es-CO" sz="2000" b="1" dirty="0">
+              <a:rPr lang="es-CO" sz="3200" b="1" dirty="0">
                 <a:solidFill>
                   <a:schemeClr val="accent6"/>
                 </a:solidFill>
@@ -6859,8 +6915,8 @@
         </p:nvSpPr>
         <p:spPr>
           <a:xfrm>
-            <a:off x="8066679" y="6138782"/>
-            <a:ext cx="7097853" cy="1412940"/>
+            <a:off x="3017520" y="1097280"/>
+            <a:ext cx="18288000" cy="1737360"/>
           </a:xfrm>
           <a:prstGeom prst="roundRect">
             <a:avLst>
@@ -6901,7 +6957,7 @@
               <a:defRPr/>
             </a:pPr>
             <a:r>
-              <a:rPr lang="pt-BR" sz="5400" b="1" kern="1200" dirty="0">
+              <a:rPr lang="pt-BR" sz="4000" b="1" kern="1200" dirty="0">
                 <a:ln w="0">
                   <a:noFill/>
                 </a:ln>
@@ -6937,8 +6993,8 @@
         </p:nvSpPr>
         <p:spPr>
           <a:xfrm>
-            <a:off x="3200400" y="7589520"/>
-            <a:ext cx="18013680" cy="5486400"/>
+            <a:off x="2194560" y="3657600"/>
+            <a:ext cx="19933920" cy="7863840"/>
           </a:xfrm>
           <a:prstGeom prst="rect">
             <a:avLst/>
@@ -7212,9 +7268,13 @@
             </a:lvl9pPr>
           </a:lstStyle>
           <a:p>
-            <a:pPr algn="ctr" hangingPunct="1"/>
+            <a:pPr algn="l" hangingPunct="1">
+              <a:spcAft>
+                <a:spcPts val="1400"/>
+              </a:spcAft>
+            </a:pPr>
             <a:r>
-              <a:rPr lang="es-CO" sz="2000" b="1" dirty="0">
+              <a:rPr lang="es-CO" sz="3200" b="1" dirty="0">
                 <a:solidFill>
                   <a:schemeClr val="accent6"/>
                 </a:solidFill>
@@ -7225,9 +7285,13 @@
             </a:r>
           </a:p>
           <a:p>
-            <a:pPr algn="ctr" hangingPunct="1"/>
+            <a:pPr algn="l" hangingPunct="1">
+              <a:spcAft>
+                <a:spcPts val="1400"/>
+              </a:spcAft>
+            </a:pPr>
             <a:r>
-              <a:rPr lang="es-CO" sz="2000" b="1" dirty="0">
+              <a:rPr lang="es-CO" sz="3200" b="1" dirty="0">
                 <a:solidFill>
                   <a:schemeClr val="accent6"/>
                 </a:solidFill>
@@ -7238,9 +7302,13 @@
             </a:r>
           </a:p>
           <a:p>
-            <a:pPr algn="ctr" hangingPunct="1"/>
+            <a:pPr algn="l" hangingPunct="1">
+              <a:spcAft>
+                <a:spcPts val="1400"/>
+              </a:spcAft>
+            </a:pPr>
             <a:r>
-              <a:rPr lang="es-CO" sz="2000" b="1" dirty="0">
+              <a:rPr lang="es-CO" sz="3200" b="1" dirty="0">
                 <a:solidFill>
                   <a:schemeClr val="accent6"/>
                 </a:solidFill>
@@ -7251,9 +7319,13 @@
             </a:r>
           </a:p>
           <a:p>
-            <a:pPr algn="ctr" hangingPunct="1"/>
+            <a:pPr algn="l" hangingPunct="1">
+              <a:spcAft>
+                <a:spcPts val="1400"/>
+              </a:spcAft>
+            </a:pPr>
             <a:r>
-              <a:rPr lang="es-CO" sz="2000" b="1" dirty="0">
+              <a:rPr lang="es-CO" sz="3200" b="1" dirty="0">
                 <a:solidFill>
                   <a:schemeClr val="accent6"/>
                 </a:solidFill>
@@ -7264,9 +7336,13 @@
             </a:r>
           </a:p>
           <a:p>
-            <a:pPr algn="ctr" hangingPunct="1"/>
+            <a:pPr algn="l" hangingPunct="1">
+              <a:spcAft>
+                <a:spcPts val="1400"/>
+              </a:spcAft>
+            </a:pPr>
             <a:r>
-              <a:rPr lang="es-CO" sz="2000" b="1" dirty="0">
+              <a:rPr lang="es-CO" sz="3200" b="1" dirty="0">
                 <a:solidFill>
                   <a:schemeClr val="accent6"/>
                 </a:solidFill>
@@ -7304,8 +7380,8 @@
         </p:nvSpPr>
         <p:spPr>
           <a:xfrm>
-            <a:off x="8066679" y="6138782"/>
-            <a:ext cx="7097853" cy="1412940"/>
+            <a:off x="3017520" y="1097280"/>
+            <a:ext cx="18288000" cy="1737360"/>
           </a:xfrm>
           <a:prstGeom prst="roundRect">
             <a:avLst>
@@ -7346,7 +7422,7 @@
               <a:defRPr/>
             </a:pPr>
             <a:r>
-              <a:rPr lang="pt-BR" sz="5400" b="1" kern="1200" dirty="0">
+              <a:rPr lang="pt-BR" sz="4000" b="1" kern="1200" dirty="0">
                 <a:ln w="0">
                   <a:noFill/>
                 </a:ln>
@@ -7388,8 +7464,8 @@
         </p:blipFill>
         <p:spPr>
           <a:xfrm>
-            <a:off x="6142611" y="7315200"/>
-            <a:ext cx="12101825" cy="5852160"/>
+            <a:off x="4062610" y="3840480"/>
+            <a:ext cx="16261828" cy="7863840"/>
           </a:xfrm>
           <a:prstGeom prst="rect">
             <a:avLst/>
@@ -7422,8 +7498,8 @@
         </p:nvSpPr>
         <p:spPr>
           <a:xfrm>
-            <a:off x="8066679" y="6138782"/>
-            <a:ext cx="7097853" cy="1412940"/>
+            <a:off x="3017520" y="1097280"/>
+            <a:ext cx="18288000" cy="1737360"/>
           </a:xfrm>
           <a:prstGeom prst="roundRect">
             <a:avLst>
@@ -7464,7 +7540,7 @@
               <a:defRPr/>
             </a:pPr>
             <a:r>
-              <a:rPr lang="pt-BR" sz="5400" b="1" kern="1200" dirty="0">
+              <a:rPr lang="pt-BR" sz="4000" b="1" kern="1200" dirty="0">
                 <a:ln w="0">
                   <a:noFill/>
                 </a:ln>
@@ -7500,8 +7576,8 @@
         </p:nvSpPr>
         <p:spPr>
           <a:xfrm>
-            <a:off x="3200400" y="7589520"/>
-            <a:ext cx="18013680" cy="5669280"/>
+            <a:off x="2194560" y="3657600"/>
+            <a:ext cx="19933920" cy="7863840"/>
           </a:xfrm>
           <a:prstGeom prst="rect">
             <a:avLst/>
@@ -7775,13 +7851,13 @@
             </a:lvl9pPr>
           </a:lstStyle>
           <a:p>
-            <a:pPr algn="ctr" hangingPunct="1">
-              <a:spcAft>
-                <a:spcPts val="600"/>
+            <a:pPr algn="l" hangingPunct="1">
+              <a:spcAft>
+                <a:spcPts val="1200"/>
               </a:spcAft>
             </a:pPr>
             <a:r>
-              <a:rPr b="1" sz="1600">
+              <a:rPr b="1" sz="2800">
                 <a:solidFill>
                   <a:srgbClr val="1E3B7D"/>
                 </a:solidFill>
@@ -7790,7 +7866,7 @@
               <a:t>Objetivo: </a:t>
             </a:r>
             <a:r>
-              <a:rPr sz="1600">
+              <a:rPr sz="2800">
                 <a:solidFill>
                   <a:srgbClr val="404040"/>
                 </a:solidFill>
@@ -7800,13 +7876,13 @@
             </a:r>
           </a:p>
           <a:p>
-            <a:pPr algn="ctr" hangingPunct="1">
-              <a:spcAft>
-                <a:spcPts val="600"/>
+            <a:pPr algn="l" hangingPunct="1">
+              <a:spcAft>
+                <a:spcPts val="1200"/>
               </a:spcAft>
             </a:pPr>
             <a:r>
-              <a:rPr b="1" sz="1600">
+              <a:rPr b="1" sz="2800">
                 <a:solidFill>
                   <a:srgbClr val="1E3B7D"/>
                 </a:solidFill>
@@ -7815,7 +7891,7 @@
               <a:t>Actividades: </a:t>
             </a:r>
             <a:r>
-              <a:rPr sz="1600">
+              <a:rPr sz="2800">
                 <a:solidFill>
                   <a:srgbClr val="404040"/>
                 </a:solidFill>
@@ -7825,13 +7901,13 @@
             </a:r>
           </a:p>
           <a:p>
-            <a:pPr algn="ctr" hangingPunct="1">
-              <a:spcAft>
-                <a:spcPts val="600"/>
+            <a:pPr algn="l" hangingPunct="1">
+              <a:spcAft>
+                <a:spcPts val="1200"/>
               </a:spcAft>
             </a:pPr>
             <a:r>
-              <a:rPr b="1" sz="1600">
+              <a:rPr b="1" sz="2800">
                 <a:solidFill>
                   <a:srgbClr val="1E3B7D"/>
                 </a:solidFill>
@@ -7840,7 +7916,7 @@
               <a:t>Metodologías: </a:t>
             </a:r>
             <a:r>
-              <a:rPr sz="1600">
+              <a:rPr sz="2800">
                 <a:solidFill>
                   <a:srgbClr val="404040"/>
                 </a:solidFill>
@@ -7850,13 +7926,13 @@
             </a:r>
           </a:p>
           <a:p>
-            <a:pPr algn="ctr" hangingPunct="1">
-              <a:spcAft>
-                <a:spcPts val="600"/>
+            <a:pPr algn="l" hangingPunct="1">
+              <a:spcAft>
+                <a:spcPts val="1200"/>
               </a:spcAft>
             </a:pPr>
             <a:r>
-              <a:rPr b="1" sz="1600">
+              <a:rPr b="1" sz="2800">
                 <a:solidFill>
                   <a:srgbClr val="1E3B7D"/>
                 </a:solidFill>
@@ -7865,7 +7941,7 @@
               <a:t>Responsables: </a:t>
             </a:r>
             <a:r>
-              <a:rPr sz="1600">
+              <a:rPr sz="2800">
                 <a:solidFill>
                   <a:srgbClr val="404040"/>
                 </a:solidFill>
@@ -7875,13 +7951,13 @@
             </a:r>
           </a:p>
           <a:p>
-            <a:pPr algn="ctr" hangingPunct="1">
-              <a:spcAft>
-                <a:spcPts val="600"/>
+            <a:pPr algn="l" hangingPunct="1">
+              <a:spcAft>
+                <a:spcPts val="1200"/>
               </a:spcAft>
             </a:pPr>
             <a:r>
-              <a:rPr b="1" sz="1600">
+              <a:rPr b="1" sz="2800">
                 <a:solidFill>
                   <a:srgbClr val="1E3B7D"/>
                 </a:solidFill>
@@ -7890,7 +7966,7 @@
               <a:t>Entregable: </a:t>
             </a:r>
             <a:r>
-              <a:rPr sz="1600">
+              <a:rPr sz="2800">
                 <a:solidFill>
                   <a:srgbClr val="404040"/>
                 </a:solidFill>
@@ -7900,13 +7976,13 @@
             </a:r>
           </a:p>
           <a:p>
-            <a:pPr algn="ctr" hangingPunct="1">
-              <a:spcAft>
-                <a:spcPts val="600"/>
+            <a:pPr algn="l" hangingPunct="1">
+              <a:spcAft>
+                <a:spcPts val="1200"/>
               </a:spcAft>
             </a:pPr>
             <a:r>
-              <a:rPr b="1" sz="1600">
+              <a:rPr b="1" sz="2800">
                 <a:solidFill>
                   <a:srgbClr val="1E3B7D"/>
                 </a:solidFill>
@@ -7915,7 +7991,7 @@
               <a:t>Tiempo: </a:t>
             </a:r>
             <a:r>
-              <a:rPr sz="1600">
+              <a:rPr sz="2800">
                 <a:solidFill>
                   <a:srgbClr val="404040"/>
                 </a:solidFill>
@@ -7952,8 +8028,8 @@
         </p:nvSpPr>
         <p:spPr>
           <a:xfrm>
-            <a:off x="8066679" y="6138782"/>
-            <a:ext cx="7097853" cy="1412940"/>
+            <a:off x="3017520" y="1097280"/>
+            <a:ext cx="18288000" cy="1737360"/>
           </a:xfrm>
           <a:prstGeom prst="roundRect">
             <a:avLst>
@@ -7994,7 +8070,7 @@
               <a:defRPr/>
             </a:pPr>
             <a:r>
-              <a:rPr lang="pt-BR" sz="5400" b="1" kern="1200" dirty="0">
+              <a:rPr lang="pt-BR" sz="3400" b="1" kern="1200" dirty="0">
                 <a:ln w="0">
                   <a:noFill/>
                 </a:ln>
@@ -8030,8 +8106,8 @@
         </p:nvSpPr>
         <p:spPr>
           <a:xfrm>
-            <a:off x="3200400" y="7589520"/>
-            <a:ext cx="18013680" cy="5669280"/>
+            <a:off x="2194560" y="3657600"/>
+            <a:ext cx="19933920" cy="7863840"/>
           </a:xfrm>
           <a:prstGeom prst="rect">
             <a:avLst/>
@@ -8305,13 +8381,13 @@
             </a:lvl9pPr>
           </a:lstStyle>
           <a:p>
-            <a:pPr algn="ctr" hangingPunct="1">
-              <a:spcAft>
-                <a:spcPts val="600"/>
+            <a:pPr algn="l" hangingPunct="1">
+              <a:spcAft>
+                <a:spcPts val="1200"/>
               </a:spcAft>
             </a:pPr>
             <a:r>
-              <a:rPr b="1" sz="1600">
+              <a:rPr b="1" sz="2800">
                 <a:solidFill>
                   <a:srgbClr val="1E3B7D"/>
                 </a:solidFill>
@@ -8320,7 +8396,7 @@
               <a:t>Objetivo: </a:t>
             </a:r>
             <a:r>
-              <a:rPr sz="1600">
+              <a:rPr sz="2800">
                 <a:solidFill>
                   <a:srgbClr val="404040"/>
                 </a:solidFill>
@@ -8330,13 +8406,13 @@
             </a:r>
           </a:p>
           <a:p>
-            <a:pPr algn="ctr" hangingPunct="1">
-              <a:spcAft>
-                <a:spcPts val="600"/>
+            <a:pPr algn="l" hangingPunct="1">
+              <a:spcAft>
+                <a:spcPts val="1200"/>
               </a:spcAft>
             </a:pPr>
             <a:r>
-              <a:rPr b="1" sz="1600">
+              <a:rPr b="1" sz="2800">
                 <a:solidFill>
                   <a:srgbClr val="1E3B7D"/>
                 </a:solidFill>
@@ -8345,7 +8421,7 @@
               <a:t>Actividades: </a:t>
             </a:r>
             <a:r>
-              <a:rPr sz="1600">
+              <a:rPr sz="2800">
                 <a:solidFill>
                   <a:srgbClr val="404040"/>
                 </a:solidFill>
@@ -8355,13 +8431,13 @@
             </a:r>
           </a:p>
           <a:p>
-            <a:pPr algn="ctr" hangingPunct="1">
-              <a:spcAft>
-                <a:spcPts val="600"/>
+            <a:pPr algn="l" hangingPunct="1">
+              <a:spcAft>
+                <a:spcPts val="1200"/>
               </a:spcAft>
             </a:pPr>
             <a:r>
-              <a:rPr b="1" sz="1600">
+              <a:rPr b="1" sz="2800">
                 <a:solidFill>
                   <a:srgbClr val="1E3B7D"/>
                 </a:solidFill>
@@ -8370,7 +8446,7 @@
               <a:t>Metodologías: </a:t>
             </a:r>
             <a:r>
-              <a:rPr sz="1600">
+              <a:rPr sz="2800">
                 <a:solidFill>
                   <a:srgbClr val="404040"/>
                 </a:solidFill>
@@ -8380,13 +8456,13 @@
             </a:r>
           </a:p>
           <a:p>
-            <a:pPr algn="ctr" hangingPunct="1">
-              <a:spcAft>
-                <a:spcPts val="600"/>
+            <a:pPr algn="l" hangingPunct="1">
+              <a:spcAft>
+                <a:spcPts val="1200"/>
               </a:spcAft>
             </a:pPr>
             <a:r>
-              <a:rPr b="1" sz="1600">
+              <a:rPr b="1" sz="2800">
                 <a:solidFill>
                   <a:srgbClr val="1E3B7D"/>
                 </a:solidFill>
@@ -8395,7 +8471,7 @@
               <a:t>Responsables: </a:t>
             </a:r>
             <a:r>
-              <a:rPr sz="1600">
+              <a:rPr sz="2800">
                 <a:solidFill>
                   <a:srgbClr val="404040"/>
                 </a:solidFill>
@@ -8405,13 +8481,13 @@
             </a:r>
           </a:p>
           <a:p>
-            <a:pPr algn="ctr" hangingPunct="1">
-              <a:spcAft>
-                <a:spcPts val="600"/>
+            <a:pPr algn="l" hangingPunct="1">
+              <a:spcAft>
+                <a:spcPts val="1200"/>
               </a:spcAft>
             </a:pPr>
             <a:r>
-              <a:rPr b="1" sz="1600">
+              <a:rPr b="1" sz="2800">
                 <a:solidFill>
                   <a:srgbClr val="1E3B7D"/>
                 </a:solidFill>
@@ -8420,7 +8496,7 @@
               <a:t>Entregable: </a:t>
             </a:r>
             <a:r>
-              <a:rPr sz="1600">
+              <a:rPr sz="2800">
                 <a:solidFill>
                   <a:srgbClr val="404040"/>
                 </a:solidFill>
@@ -8430,13 +8506,13 @@
             </a:r>
           </a:p>
           <a:p>
-            <a:pPr algn="ctr" hangingPunct="1">
-              <a:spcAft>
-                <a:spcPts val="600"/>
+            <a:pPr algn="l" hangingPunct="1">
+              <a:spcAft>
+                <a:spcPts val="1200"/>
               </a:spcAft>
             </a:pPr>
             <a:r>
-              <a:rPr b="1" sz="1600">
+              <a:rPr b="1" sz="2800">
                 <a:solidFill>
                   <a:srgbClr val="1E3B7D"/>
                 </a:solidFill>
@@ -8445,7 +8521,7 @@
               <a:t>Tiempo: </a:t>
             </a:r>
             <a:r>
-              <a:rPr sz="1600">
+              <a:rPr sz="2800">
                 <a:solidFill>
                   <a:srgbClr val="404040"/>
                 </a:solidFill>
@@ -8482,8 +8558,8 @@
         </p:nvSpPr>
         <p:spPr>
           <a:xfrm>
-            <a:off x="8066679" y="6138782"/>
-            <a:ext cx="7097853" cy="1412940"/>
+            <a:off x="3017520" y="1097280"/>
+            <a:ext cx="18288000" cy="1737360"/>
           </a:xfrm>
           <a:prstGeom prst="roundRect">
             <a:avLst>
@@ -8524,7 +8600,7 @@
               <a:defRPr/>
             </a:pPr>
             <a:r>
-              <a:rPr lang="pt-BR" sz="5400" b="1" kern="1200" dirty="0">
+              <a:rPr lang="pt-BR" sz="3400" b="1" kern="1200" dirty="0">
                 <a:ln w="0">
                   <a:noFill/>
                 </a:ln>
@@ -8560,8 +8636,8 @@
         </p:nvSpPr>
         <p:spPr>
           <a:xfrm>
-            <a:off x="3200400" y="7589520"/>
-            <a:ext cx="18013680" cy="5669280"/>
+            <a:off x="2194560" y="3657600"/>
+            <a:ext cx="19933920" cy="7863840"/>
           </a:xfrm>
           <a:prstGeom prst="rect">
             <a:avLst/>
@@ -8835,13 +8911,13 @@
             </a:lvl9pPr>
           </a:lstStyle>
           <a:p>
-            <a:pPr algn="ctr" hangingPunct="1">
-              <a:spcAft>
-                <a:spcPts val="600"/>
+            <a:pPr algn="l" hangingPunct="1">
+              <a:spcAft>
+                <a:spcPts val="1200"/>
               </a:spcAft>
             </a:pPr>
             <a:r>
-              <a:rPr b="1" sz="1600">
+              <a:rPr b="1" sz="2800">
                 <a:solidFill>
                   <a:srgbClr val="1E3B7D"/>
                 </a:solidFill>
@@ -8850,7 +8926,7 @@
               <a:t>Objetivo: </a:t>
             </a:r>
             <a:r>
-              <a:rPr sz="1600">
+              <a:rPr sz="2800">
                 <a:solidFill>
                   <a:srgbClr val="404040"/>
                 </a:solidFill>
@@ -8860,13 +8936,13 @@
             </a:r>
           </a:p>
           <a:p>
-            <a:pPr algn="ctr" hangingPunct="1">
-              <a:spcAft>
-                <a:spcPts val="600"/>
+            <a:pPr algn="l" hangingPunct="1">
+              <a:spcAft>
+                <a:spcPts val="1200"/>
               </a:spcAft>
             </a:pPr>
             <a:r>
-              <a:rPr b="1" sz="1600">
+              <a:rPr b="1" sz="2800">
                 <a:solidFill>
                   <a:srgbClr val="1E3B7D"/>
                 </a:solidFill>
@@ -8875,7 +8951,7 @@
               <a:t>Actividades: </a:t>
             </a:r>
             <a:r>
-              <a:rPr sz="1600">
+              <a:rPr sz="2800">
                 <a:solidFill>
                   <a:srgbClr val="404040"/>
                 </a:solidFill>
@@ -8885,13 +8961,13 @@
             </a:r>
           </a:p>
           <a:p>
-            <a:pPr algn="ctr" hangingPunct="1">
-              <a:spcAft>
-                <a:spcPts val="600"/>
+            <a:pPr algn="l" hangingPunct="1">
+              <a:spcAft>
+                <a:spcPts val="1200"/>
               </a:spcAft>
             </a:pPr>
             <a:r>
-              <a:rPr b="1" sz="1600">
+              <a:rPr b="1" sz="2800">
                 <a:solidFill>
                   <a:srgbClr val="1E3B7D"/>
                 </a:solidFill>
@@ -8900,7 +8976,7 @@
               <a:t>Metodologías: </a:t>
             </a:r>
             <a:r>
-              <a:rPr sz="1600">
+              <a:rPr sz="2800">
                 <a:solidFill>
                   <a:srgbClr val="404040"/>
                 </a:solidFill>
@@ -8910,13 +8986,13 @@
             </a:r>
           </a:p>
           <a:p>
-            <a:pPr algn="ctr" hangingPunct="1">
-              <a:spcAft>
-                <a:spcPts val="600"/>
+            <a:pPr algn="l" hangingPunct="1">
+              <a:spcAft>
+                <a:spcPts val="1200"/>
               </a:spcAft>
             </a:pPr>
             <a:r>
-              <a:rPr b="1" sz="1600">
+              <a:rPr b="1" sz="2800">
                 <a:solidFill>
                   <a:srgbClr val="1E3B7D"/>
                 </a:solidFill>
@@ -8925,7 +9001,7 @@
               <a:t>Responsables: </a:t>
             </a:r>
             <a:r>
-              <a:rPr sz="1600">
+              <a:rPr sz="2800">
                 <a:solidFill>
                   <a:srgbClr val="404040"/>
                 </a:solidFill>
@@ -8935,13 +9011,13 @@
             </a:r>
           </a:p>
           <a:p>
-            <a:pPr algn="ctr" hangingPunct="1">
-              <a:spcAft>
-                <a:spcPts val="600"/>
+            <a:pPr algn="l" hangingPunct="1">
+              <a:spcAft>
+                <a:spcPts val="1200"/>
               </a:spcAft>
             </a:pPr>
             <a:r>
-              <a:rPr b="1" sz="1600">
+              <a:rPr b="1" sz="2800">
                 <a:solidFill>
                   <a:srgbClr val="1E3B7D"/>
                 </a:solidFill>
@@ -8950,7 +9026,7 @@
               <a:t>Entregable: </a:t>
             </a:r>
             <a:r>
-              <a:rPr sz="1600">
+              <a:rPr sz="2800">
                 <a:solidFill>
                   <a:srgbClr val="404040"/>
                 </a:solidFill>
@@ -8960,13 +9036,13 @@
             </a:r>
           </a:p>
           <a:p>
-            <a:pPr algn="ctr" hangingPunct="1">
-              <a:spcAft>
-                <a:spcPts val="600"/>
+            <a:pPr algn="l" hangingPunct="1">
+              <a:spcAft>
+                <a:spcPts val="1200"/>
               </a:spcAft>
             </a:pPr>
             <a:r>
-              <a:rPr b="1" sz="1600">
+              <a:rPr b="1" sz="2800">
                 <a:solidFill>
                   <a:srgbClr val="1E3B7D"/>
                 </a:solidFill>
@@ -8975,7 +9051,7 @@
               <a:t>Tiempo: </a:t>
             </a:r>
             <a:r>
-              <a:rPr sz="1600">
+              <a:rPr sz="2800">
                 <a:solidFill>
                   <a:srgbClr val="404040"/>
                 </a:solidFill>
@@ -9012,8 +9088,8 @@
         </p:nvSpPr>
         <p:spPr>
           <a:xfrm>
-            <a:off x="8066679" y="6138782"/>
-            <a:ext cx="7097853" cy="1412940"/>
+            <a:off x="3017520" y="1097280"/>
+            <a:ext cx="18288000" cy="1737360"/>
           </a:xfrm>
           <a:prstGeom prst="roundRect">
             <a:avLst>
@@ -9054,7 +9130,7 @@
               <a:defRPr/>
             </a:pPr>
             <a:r>
-              <a:rPr lang="pt-BR" sz="5400" b="1" kern="1200" dirty="0">
+              <a:rPr lang="pt-BR" sz="3400" b="1" kern="1200" dirty="0">
                 <a:ln w="0">
                   <a:noFill/>
                 </a:ln>
@@ -9090,8 +9166,8 @@
         </p:nvSpPr>
         <p:spPr>
           <a:xfrm>
-            <a:off x="3200400" y="7589520"/>
-            <a:ext cx="18013680" cy="5669280"/>
+            <a:off x="2194560" y="3657600"/>
+            <a:ext cx="19933920" cy="7863840"/>
           </a:xfrm>
           <a:prstGeom prst="rect">
             <a:avLst/>
@@ -9365,13 +9441,13 @@
             </a:lvl9pPr>
           </a:lstStyle>
           <a:p>
-            <a:pPr algn="ctr" hangingPunct="1">
-              <a:spcAft>
-                <a:spcPts val="600"/>
+            <a:pPr algn="l" hangingPunct="1">
+              <a:spcAft>
+                <a:spcPts val="1200"/>
               </a:spcAft>
             </a:pPr>
             <a:r>
-              <a:rPr b="1" sz="1600">
+              <a:rPr b="1" sz="2800">
                 <a:solidFill>
                   <a:srgbClr val="1E3B7D"/>
                 </a:solidFill>
@@ -9380,7 +9456,7 @@
               <a:t>Objetivo: </a:t>
             </a:r>
             <a:r>
-              <a:rPr sz="1600">
+              <a:rPr sz="2800">
                 <a:solidFill>
                   <a:srgbClr val="404040"/>
                 </a:solidFill>
@@ -9390,13 +9466,13 @@
             </a:r>
           </a:p>
           <a:p>
-            <a:pPr algn="ctr" hangingPunct="1">
-              <a:spcAft>
-                <a:spcPts val="600"/>
+            <a:pPr algn="l" hangingPunct="1">
+              <a:spcAft>
+                <a:spcPts val="1200"/>
               </a:spcAft>
             </a:pPr>
             <a:r>
-              <a:rPr b="1" sz="1600">
+              <a:rPr b="1" sz="2800">
                 <a:solidFill>
                   <a:srgbClr val="1E3B7D"/>
                 </a:solidFill>
@@ -9405,7 +9481,7 @@
               <a:t>Actividades: </a:t>
             </a:r>
             <a:r>
-              <a:rPr sz="1600">
+              <a:rPr sz="2800">
                 <a:solidFill>
                   <a:srgbClr val="404040"/>
                 </a:solidFill>
@@ -9415,13 +9491,13 @@
             </a:r>
           </a:p>
           <a:p>
-            <a:pPr algn="ctr" hangingPunct="1">
-              <a:spcAft>
-                <a:spcPts val="600"/>
+            <a:pPr algn="l" hangingPunct="1">
+              <a:spcAft>
+                <a:spcPts val="1200"/>
               </a:spcAft>
             </a:pPr>
             <a:r>
-              <a:rPr b="1" sz="1600">
+              <a:rPr b="1" sz="2800">
                 <a:solidFill>
                   <a:srgbClr val="1E3B7D"/>
                 </a:solidFill>
@@ -9430,7 +9506,7 @@
               <a:t>Metodologías: </a:t>
             </a:r>
             <a:r>
-              <a:rPr sz="1600">
+              <a:rPr sz="2800">
                 <a:solidFill>
                   <a:srgbClr val="404040"/>
                 </a:solidFill>
@@ -9440,13 +9516,13 @@
             </a:r>
           </a:p>
           <a:p>
-            <a:pPr algn="ctr" hangingPunct="1">
-              <a:spcAft>
-                <a:spcPts val="600"/>
+            <a:pPr algn="l" hangingPunct="1">
+              <a:spcAft>
+                <a:spcPts val="1200"/>
               </a:spcAft>
             </a:pPr>
             <a:r>
-              <a:rPr b="1" sz="1600">
+              <a:rPr b="1" sz="2800">
                 <a:solidFill>
                   <a:srgbClr val="1E3B7D"/>
                 </a:solidFill>
@@ -9455,7 +9531,7 @@
               <a:t>Responsables: </a:t>
             </a:r>
             <a:r>
-              <a:rPr sz="1600">
+              <a:rPr sz="2800">
                 <a:solidFill>
                   <a:srgbClr val="404040"/>
                 </a:solidFill>
@@ -9465,13 +9541,13 @@
             </a:r>
           </a:p>
           <a:p>
-            <a:pPr algn="ctr" hangingPunct="1">
-              <a:spcAft>
-                <a:spcPts val="600"/>
+            <a:pPr algn="l" hangingPunct="1">
+              <a:spcAft>
+                <a:spcPts val="1200"/>
               </a:spcAft>
             </a:pPr>
             <a:r>
-              <a:rPr b="1" sz="1600">
+              <a:rPr b="1" sz="2800">
                 <a:solidFill>
                   <a:srgbClr val="1E3B7D"/>
                 </a:solidFill>
@@ -9480,7 +9556,7 @@
               <a:t>Entregable: </a:t>
             </a:r>
             <a:r>
-              <a:rPr sz="1600">
+              <a:rPr sz="2800">
                 <a:solidFill>
                   <a:srgbClr val="404040"/>
                 </a:solidFill>
@@ -9490,13 +9566,13 @@
             </a:r>
           </a:p>
           <a:p>
-            <a:pPr algn="ctr" hangingPunct="1">
-              <a:spcAft>
-                <a:spcPts val="600"/>
+            <a:pPr algn="l" hangingPunct="1">
+              <a:spcAft>
+                <a:spcPts val="1200"/>
               </a:spcAft>
             </a:pPr>
             <a:r>
-              <a:rPr b="1" sz="1600">
+              <a:rPr b="1" sz="2800">
                 <a:solidFill>
                   <a:srgbClr val="1E3B7D"/>
                 </a:solidFill>
@@ -9505,7 +9581,7 @@
               <a:t>Tiempo: </a:t>
             </a:r>
             <a:r>
-              <a:rPr sz="1600">
+              <a:rPr sz="2800">
                 <a:solidFill>
                   <a:srgbClr val="404040"/>
                 </a:solidFill>
@@ -9542,8 +9618,8 @@
         </p:nvSpPr>
         <p:spPr>
           <a:xfrm>
-            <a:off x="8066679" y="6138782"/>
-            <a:ext cx="7097853" cy="1412940"/>
+            <a:off x="3017520" y="1097280"/>
+            <a:ext cx="18288000" cy="1737360"/>
           </a:xfrm>
           <a:prstGeom prst="roundRect">
             <a:avLst>
@@ -9584,7 +9660,7 @@
               <a:defRPr/>
             </a:pPr>
             <a:r>
-              <a:rPr lang="pt-BR" sz="5400" b="1" kern="1200" dirty="0">
+              <a:rPr lang="pt-BR" sz="3400" b="1" kern="1200" dirty="0">
                 <a:ln w="0">
                   <a:noFill/>
                 </a:ln>
@@ -9620,8 +9696,8 @@
         </p:nvSpPr>
         <p:spPr>
           <a:xfrm>
-            <a:off x="3200400" y="7589520"/>
-            <a:ext cx="18013680" cy="5669280"/>
+            <a:off x="2194560" y="3657600"/>
+            <a:ext cx="19933920" cy="7863840"/>
           </a:xfrm>
           <a:prstGeom prst="rect">
             <a:avLst/>
@@ -9895,13 +9971,13 @@
             </a:lvl9pPr>
           </a:lstStyle>
           <a:p>
-            <a:pPr algn="ctr" hangingPunct="1">
-              <a:spcAft>
-                <a:spcPts val="600"/>
+            <a:pPr algn="l" hangingPunct="1">
+              <a:spcAft>
+                <a:spcPts val="1200"/>
               </a:spcAft>
             </a:pPr>
             <a:r>
-              <a:rPr b="1" sz="1600">
+              <a:rPr b="1" sz="2800">
                 <a:solidFill>
                   <a:srgbClr val="1E3B7D"/>
                 </a:solidFill>
@@ -9910,7 +9986,7 @@
               <a:t>Objetivo: </a:t>
             </a:r>
             <a:r>
-              <a:rPr sz="1600">
+              <a:rPr sz="2800">
                 <a:solidFill>
                   <a:srgbClr val="404040"/>
                 </a:solidFill>
@@ -9920,13 +9996,13 @@
             </a:r>
           </a:p>
           <a:p>
-            <a:pPr algn="ctr" hangingPunct="1">
-              <a:spcAft>
-                <a:spcPts val="600"/>
+            <a:pPr algn="l" hangingPunct="1">
+              <a:spcAft>
+                <a:spcPts val="1200"/>
               </a:spcAft>
             </a:pPr>
             <a:r>
-              <a:rPr b="1" sz="1600">
+              <a:rPr b="1" sz="2800">
                 <a:solidFill>
                   <a:srgbClr val="1E3B7D"/>
                 </a:solidFill>
@@ -9935,7 +10011,7 @@
               <a:t>Actividades: </a:t>
             </a:r>
             <a:r>
-              <a:rPr sz="1600">
+              <a:rPr sz="2800">
                 <a:solidFill>
                   <a:srgbClr val="404040"/>
                 </a:solidFill>
@@ -9945,13 +10021,13 @@
             </a:r>
           </a:p>
           <a:p>
-            <a:pPr algn="ctr" hangingPunct="1">
-              <a:spcAft>
-                <a:spcPts val="600"/>
+            <a:pPr algn="l" hangingPunct="1">
+              <a:spcAft>
+                <a:spcPts val="1200"/>
               </a:spcAft>
             </a:pPr>
             <a:r>
-              <a:rPr b="1" sz="1600">
+              <a:rPr b="1" sz="2800">
                 <a:solidFill>
                   <a:srgbClr val="1E3B7D"/>
                 </a:solidFill>
@@ -9960,7 +10036,7 @@
               <a:t>Metodologías: </a:t>
             </a:r>
             <a:r>
-              <a:rPr sz="1600">
+              <a:rPr sz="2800">
                 <a:solidFill>
                   <a:srgbClr val="404040"/>
                 </a:solidFill>
@@ -9970,13 +10046,13 @@
             </a:r>
           </a:p>
           <a:p>
-            <a:pPr algn="ctr" hangingPunct="1">
-              <a:spcAft>
-                <a:spcPts val="600"/>
+            <a:pPr algn="l" hangingPunct="1">
+              <a:spcAft>
+                <a:spcPts val="1200"/>
               </a:spcAft>
             </a:pPr>
             <a:r>
-              <a:rPr b="1" sz="1600">
+              <a:rPr b="1" sz="2800">
                 <a:solidFill>
                   <a:srgbClr val="1E3B7D"/>
                 </a:solidFill>
@@ -9985,7 +10061,7 @@
               <a:t>Responsables: </a:t>
             </a:r>
             <a:r>
-              <a:rPr sz="1600">
+              <a:rPr sz="2800">
                 <a:solidFill>
                   <a:srgbClr val="404040"/>
                 </a:solidFill>
@@ -9995,13 +10071,13 @@
             </a:r>
           </a:p>
           <a:p>
-            <a:pPr algn="ctr" hangingPunct="1">
-              <a:spcAft>
-                <a:spcPts val="600"/>
+            <a:pPr algn="l" hangingPunct="1">
+              <a:spcAft>
+                <a:spcPts val="1200"/>
               </a:spcAft>
             </a:pPr>
             <a:r>
-              <a:rPr b="1" sz="1600">
+              <a:rPr b="1" sz="2800">
                 <a:solidFill>
                   <a:srgbClr val="1E3B7D"/>
                 </a:solidFill>
@@ -10010,7 +10086,7 @@
               <a:t>Entregable: </a:t>
             </a:r>
             <a:r>
-              <a:rPr sz="1600">
+              <a:rPr sz="2800">
                 <a:solidFill>
                   <a:srgbClr val="404040"/>
                 </a:solidFill>
@@ -10020,13 +10096,13 @@
             </a:r>
           </a:p>
           <a:p>
-            <a:pPr algn="ctr" hangingPunct="1">
-              <a:spcAft>
-                <a:spcPts val="600"/>
+            <a:pPr algn="l" hangingPunct="1">
+              <a:spcAft>
+                <a:spcPts val="1200"/>
               </a:spcAft>
             </a:pPr>
             <a:r>
-              <a:rPr b="1" sz="1600">
+              <a:rPr b="1" sz="2800">
                 <a:solidFill>
                   <a:srgbClr val="1E3B7D"/>
                 </a:solidFill>
@@ -10035,7 +10111,7 @@
               <a:t>Tiempo: </a:t>
             </a:r>
             <a:r>
-              <a:rPr sz="1600">
+              <a:rPr sz="2800">
                 <a:solidFill>
                   <a:srgbClr val="404040"/>
                 </a:solidFill>
@@ -10072,8 +10148,8 @@
         </p:nvSpPr>
         <p:spPr>
           <a:xfrm>
-            <a:off x="8066679" y="6138782"/>
-            <a:ext cx="7097853" cy="1412940"/>
+            <a:off x="3017520" y="1097280"/>
+            <a:ext cx="18288000" cy="1737360"/>
           </a:xfrm>
           <a:prstGeom prst="roundRect">
             <a:avLst>
@@ -10114,7 +10190,7 @@
               <a:defRPr/>
             </a:pPr>
             <a:r>
-              <a:rPr lang="pt-BR" sz="5400" b="1" kern="1200" dirty="0">
+              <a:rPr lang="pt-BR" sz="3000" b="1" kern="1200" dirty="0">
                 <a:ln w="0">
                   <a:noFill/>
                 </a:ln>
@@ -10150,8 +10226,8 @@
         </p:nvSpPr>
         <p:spPr>
           <a:xfrm>
-            <a:off x="3200400" y="7589520"/>
-            <a:ext cx="18013680" cy="5669280"/>
+            <a:off x="2194560" y="3657600"/>
+            <a:ext cx="19933920" cy="7863840"/>
           </a:xfrm>
           <a:prstGeom prst="rect">
             <a:avLst/>
@@ -10425,13 +10501,13 @@
             </a:lvl9pPr>
           </a:lstStyle>
           <a:p>
-            <a:pPr algn="ctr" hangingPunct="1">
-              <a:spcAft>
-                <a:spcPts val="600"/>
+            <a:pPr algn="l" hangingPunct="1">
+              <a:spcAft>
+                <a:spcPts val="1200"/>
               </a:spcAft>
             </a:pPr>
             <a:r>
-              <a:rPr b="1" sz="1600">
+              <a:rPr b="1" sz="2800">
                 <a:solidFill>
                   <a:srgbClr val="1E3B7D"/>
                 </a:solidFill>
@@ -10440,7 +10516,7 @@
               <a:t>Objetivo: </a:t>
             </a:r>
             <a:r>
-              <a:rPr sz="1600">
+              <a:rPr sz="2800">
                 <a:solidFill>
                   <a:srgbClr val="404040"/>
                 </a:solidFill>
@@ -10450,13 +10526,13 @@
             </a:r>
           </a:p>
           <a:p>
-            <a:pPr algn="ctr" hangingPunct="1">
-              <a:spcAft>
-                <a:spcPts val="600"/>
+            <a:pPr algn="l" hangingPunct="1">
+              <a:spcAft>
+                <a:spcPts val="1200"/>
               </a:spcAft>
             </a:pPr>
             <a:r>
-              <a:rPr b="1" sz="1600">
+              <a:rPr b="1" sz="2800">
                 <a:solidFill>
                   <a:srgbClr val="1E3B7D"/>
                 </a:solidFill>
@@ -10465,23 +10541,23 @@
               <a:t>Actividades: </a:t>
             </a:r>
             <a:r>
-              <a:rPr sz="1600">
+              <a:rPr sz="2800">
                 <a:solidFill>
                   <a:srgbClr val="404040"/>
                 </a:solidFill>
                 <a:latin typeface="Century Gothic"/>
               </a:rPr>
-              <a:t>ferias y ruedas de negocio, convocatorias y capital semilla, propiedad intelectual, spin-offs.</a:t>
+              <a:t>ferias y ruedas de negocio, convocatorias, capital semilla, spin-offs.</a:t>
             </a:r>
           </a:p>
           <a:p>
-            <a:pPr algn="ctr" hangingPunct="1">
-              <a:spcAft>
-                <a:spcPts val="600"/>
+            <a:pPr algn="l" hangingPunct="1">
+              <a:spcAft>
+                <a:spcPts val="1200"/>
               </a:spcAft>
             </a:pPr>
             <a:r>
-              <a:rPr b="1" sz="1600">
+              <a:rPr b="1" sz="2800">
                 <a:solidFill>
                   <a:srgbClr val="1E3B7D"/>
                 </a:solidFill>
@@ -10490,7 +10566,7 @@
               <a:t>Aliados: </a:t>
             </a:r>
             <a:r>
-              <a:rPr sz="1600">
+              <a:rPr sz="2800">
                 <a:solidFill>
                   <a:srgbClr val="404040"/>
                 </a:solidFill>
@@ -10500,13 +10576,13 @@
             </a:r>
           </a:p>
           <a:p>
-            <a:pPr algn="ctr" hangingPunct="1">
-              <a:spcAft>
-                <a:spcPts val="600"/>
+            <a:pPr algn="l" hangingPunct="1">
+              <a:spcAft>
+                <a:spcPts val="1200"/>
               </a:spcAft>
             </a:pPr>
             <a:r>
-              <a:rPr b="1" sz="1600">
+              <a:rPr b="1" sz="2800">
                 <a:solidFill>
                   <a:srgbClr val="1E3B7D"/>
                 </a:solidFill>
@@ -10515,7 +10591,7 @@
               <a:t>Entregable: </a:t>
             </a:r>
             <a:r>
-              <a:rPr sz="1600">
+              <a:rPr sz="2800">
                 <a:solidFill>
                   <a:srgbClr val="404040"/>
                 </a:solidFill>
@@ -10525,13 +10601,13 @@
             </a:r>
           </a:p>
           <a:p>
-            <a:pPr algn="ctr" hangingPunct="1">
-              <a:spcAft>
-                <a:spcPts val="600"/>
+            <a:pPr algn="l" hangingPunct="1">
+              <a:spcAft>
+                <a:spcPts val="1200"/>
               </a:spcAft>
             </a:pPr>
             <a:r>
-              <a:rPr b="1" sz="1600">
+              <a:rPr b="1" sz="2800">
                 <a:solidFill>
                   <a:srgbClr val="1E3B7D"/>
                 </a:solidFill>
@@ -10540,7 +10616,7 @@
               <a:t>Tiempo: </a:t>
             </a:r>
             <a:r>
-              <a:rPr sz="1600">
+              <a:rPr sz="2800">
                 <a:solidFill>
                   <a:srgbClr val="404040"/>
                 </a:solidFill>
@@ -10577,8 +10653,8 @@
         </p:nvSpPr>
         <p:spPr>
           <a:xfrm>
-            <a:off x="8066679" y="6138782"/>
-            <a:ext cx="7097853" cy="1412940"/>
+            <a:off x="3017520" y="1097280"/>
+            <a:ext cx="18288000" cy="1737360"/>
           </a:xfrm>
           <a:prstGeom prst="roundRect">
             <a:avLst>
@@ -10619,7 +10695,7 @@
               <a:defRPr/>
             </a:pPr>
             <a:r>
-              <a:rPr lang="pt-BR" sz="5400" b="1" kern="1200" dirty="0">
+              <a:rPr lang="pt-BR" sz="4000" b="1" kern="1200" dirty="0">
                 <a:ln w="0">
                   <a:noFill/>
                 </a:ln>
@@ -10655,8 +10731,8 @@
         </p:nvSpPr>
         <p:spPr>
           <a:xfrm>
-            <a:off x="3200400" y="7589520"/>
-            <a:ext cx="18013680" cy="5486400"/>
+            <a:off x="2194560" y="3657600"/>
+            <a:ext cx="19933920" cy="7863840"/>
           </a:xfrm>
           <a:prstGeom prst="rect">
             <a:avLst/>
@@ -10930,9 +11006,13 @@
             </a:lvl9pPr>
           </a:lstStyle>
           <a:p>
-            <a:pPr algn="ctr" hangingPunct="1"/>
+            <a:pPr algn="l" hangingPunct="1">
+              <a:spcAft>
+                <a:spcPts val="1400"/>
+              </a:spcAft>
+            </a:pPr>
             <a:r>
-              <a:rPr lang="es-CO" sz="2000" b="1" dirty="0">
+              <a:rPr lang="es-CO" sz="3200" b="1" dirty="0">
                 <a:solidFill>
                   <a:schemeClr val="accent6"/>
                 </a:solidFill>
@@ -10943,9 +11023,13 @@
             </a:r>
           </a:p>
           <a:p>
-            <a:pPr algn="ctr" hangingPunct="1"/>
+            <a:pPr algn="l" hangingPunct="1">
+              <a:spcAft>
+                <a:spcPts val="1400"/>
+              </a:spcAft>
+            </a:pPr>
             <a:r>
-              <a:rPr lang="es-CO" sz="2000" b="1" dirty="0">
+              <a:rPr lang="es-CO" sz="3200" b="1" dirty="0">
                 <a:solidFill>
                   <a:schemeClr val="accent6"/>
                 </a:solidFill>
@@ -10956,9 +11040,13 @@
             </a:r>
           </a:p>
           <a:p>
-            <a:pPr algn="ctr" hangingPunct="1"/>
+            <a:pPr algn="l" hangingPunct="1">
+              <a:spcAft>
+                <a:spcPts val="1400"/>
+              </a:spcAft>
+            </a:pPr>
             <a:r>
-              <a:rPr lang="es-CO" sz="2000" b="1" dirty="0">
+              <a:rPr lang="es-CO" sz="3200" b="1" dirty="0">
                 <a:solidFill>
                   <a:schemeClr val="accent6"/>
                 </a:solidFill>
@@ -10969,9 +11057,13 @@
             </a:r>
           </a:p>
           <a:p>
-            <a:pPr algn="ctr" hangingPunct="1"/>
+            <a:pPr algn="l" hangingPunct="1">
+              <a:spcAft>
+                <a:spcPts val="1400"/>
+              </a:spcAft>
+            </a:pPr>
             <a:r>
-              <a:rPr lang="es-CO" sz="2000" b="1" dirty="0">
+              <a:rPr lang="es-CO" sz="3200" b="1" dirty="0">
                 <a:solidFill>
                   <a:schemeClr val="accent6"/>
                 </a:solidFill>
@@ -10982,9 +11074,13 @@
             </a:r>
           </a:p>
           <a:p>
-            <a:pPr algn="ctr" hangingPunct="1"/>
+            <a:pPr algn="l" hangingPunct="1">
+              <a:spcAft>
+                <a:spcPts val="1400"/>
+              </a:spcAft>
+            </a:pPr>
             <a:r>
-              <a:rPr lang="es-CO" sz="2000" b="1" dirty="0">
+              <a:rPr lang="es-CO" sz="3200" b="1" dirty="0">
                 <a:solidFill>
                   <a:schemeClr val="accent6"/>
                 </a:solidFill>
@@ -11022,8 +11118,8 @@
         </p:nvSpPr>
         <p:spPr>
           <a:xfrm>
-            <a:off x="8066679" y="6138782"/>
-            <a:ext cx="7097853" cy="1412940"/>
+            <a:off x="3017520" y="1097280"/>
+            <a:ext cx="18288000" cy="1737360"/>
           </a:xfrm>
           <a:prstGeom prst="roundRect">
             <a:avLst>
@@ -11064,7 +11160,7 @@
               <a:defRPr/>
             </a:pPr>
             <a:r>
-              <a:rPr lang="pt-BR" sz="5400" b="1" kern="1200" dirty="0">
+              <a:rPr lang="pt-BR" sz="3400" b="1" kern="1200" dirty="0">
                 <a:ln w="0">
                   <a:noFill/>
                 </a:ln>
@@ -11100,8 +11196,8 @@
         </p:nvSpPr>
         <p:spPr>
           <a:xfrm>
-            <a:off x="3200400" y="7589520"/>
-            <a:ext cx="18013680" cy="5486400"/>
+            <a:off x="2194560" y="3657600"/>
+            <a:ext cx="19933920" cy="7863840"/>
           </a:xfrm>
           <a:prstGeom prst="rect">
             <a:avLst/>
@@ -11375,9 +11471,13 @@
             </a:lvl9pPr>
           </a:lstStyle>
           <a:p>
-            <a:pPr algn="ctr" hangingPunct="1"/>
+            <a:pPr algn="l" hangingPunct="1">
+              <a:spcAft>
+                <a:spcPts val="1400"/>
+              </a:spcAft>
+            </a:pPr>
             <a:r>
-              <a:rPr lang="es-CO" sz="2000" b="1" dirty="0">
+              <a:rPr lang="es-CO" sz="3200" b="1" dirty="0">
                 <a:solidFill>
                   <a:schemeClr val="accent6"/>
                 </a:solidFill>
@@ -11388,9 +11488,13 @@
             </a:r>
           </a:p>
           <a:p>
-            <a:pPr algn="ctr" hangingPunct="1"/>
+            <a:pPr algn="l" hangingPunct="1">
+              <a:spcAft>
+                <a:spcPts val="1400"/>
+              </a:spcAft>
+            </a:pPr>
             <a:r>
-              <a:rPr lang="es-CO" sz="2000" b="1" dirty="0">
+              <a:rPr lang="es-CO" sz="3200" b="1" dirty="0">
                 <a:solidFill>
                   <a:schemeClr val="accent6"/>
                 </a:solidFill>
@@ -11401,9 +11505,13 @@
             </a:r>
           </a:p>
           <a:p>
-            <a:pPr algn="ctr" hangingPunct="1"/>
+            <a:pPr algn="l" hangingPunct="1">
+              <a:spcAft>
+                <a:spcPts val="1400"/>
+              </a:spcAft>
+            </a:pPr>
             <a:r>
-              <a:rPr lang="es-CO" sz="2000" b="1" dirty="0">
+              <a:rPr lang="es-CO" sz="3200" b="1" dirty="0">
                 <a:solidFill>
                   <a:schemeClr val="accent6"/>
                 </a:solidFill>
@@ -11414,9 +11522,13 @@
             </a:r>
           </a:p>
           <a:p>
-            <a:pPr algn="ctr" hangingPunct="1"/>
+            <a:pPr algn="l" hangingPunct="1">
+              <a:spcAft>
+                <a:spcPts val="1400"/>
+              </a:spcAft>
+            </a:pPr>
             <a:r>
-              <a:rPr lang="es-CO" sz="2000" b="1" dirty="0">
+              <a:rPr lang="es-CO" sz="3200" b="1" dirty="0">
                 <a:solidFill>
                   <a:schemeClr val="accent6"/>
                 </a:solidFill>
@@ -11744,7 +11856,7 @@
               </a:lnSpc>
             </a:pPr>
             <a:r>
-              <a:rPr lang="es-CO" b="1" dirty="0" sz="4800">
+              <a:rPr lang="es-CO" b="1" dirty="0" sz="6400">
                 <a:solidFill>
                   <a:schemeClr val="tx1"/>
                 </a:solidFill>
@@ -12047,13 +12159,13 @@
               </a:lnSpc>
             </a:pPr>
             <a:r>
-              <a:rPr lang="es-ES" sz="2800" dirty="0">
+              <a:rPr lang="es-ES" sz="3400" dirty="0">
                 <a:solidFill>
                   <a:schemeClr val="tx1"/>
                 </a:solidFill>
                 <a:latin typeface="Century Gothic" panose="020B0502020202020204" pitchFamily="34" charset="0"/>
               </a:rPr>
-              <a:t>…pese a que el 87,7% manifiesta interés en emprender. Por eso esta guía busca dar a conocer la ruta y facilitar el acceso de toda la comunidad.</a:t>
+              <a:t>…pese a que el 87,7% manifiesta interés en emprender. Esta guía busca dar a conocer la ruta y facilitar el acceso de toda la comunidad.</a:t>
             </a:r>
           </a:p>
         </p:txBody>

</xml_diff>

<commit_message>
Enriquecer guia PPTX: agenda, divisor de seccion, insignias de fase y slide de acceso
</commit_message>
<xml_diff>
--- a/Ruta-Emprendimiento-CIE.pptx
+++ b/Ruta-Emprendimiento-CIE.pptx
@@ -12,20 +12,23 @@
   </p:handoutMasterIdLst>
   <p:sldIdLst>
     <p:sldId id="626" r:id="rId2"/>
+    <p:sldId id="659" r:id="rId38"/>
     <p:sldId id="648" r:id="rId27"/>
     <p:sldId id="631" r:id="rId7"/>
     <p:sldId id="649" r:id="rId28"/>
     <p:sldId id="650" r:id="rId29"/>
     <p:sldId id="651" r:id="rId30"/>
     <p:sldId id="652" r:id="rId31"/>
+    <p:sldId id="660" r:id="rId39"/>
     <p:sldId id="653" r:id="rId32"/>
     <p:sldId id="654" r:id="rId33"/>
     <p:sldId id="655" r:id="rId34"/>
     <p:sldId id="656" r:id="rId35"/>
     <p:sldId id="657" r:id="rId36"/>
     <p:sldId id="658" r:id="rId37"/>
-    <p:sldId id="659" r:id="rId38"/>
-    <p:sldId id="660" r:id="rId39"/>
+    <p:sldId id="661" r:id="rId40"/>
+    <p:sldId id="662" r:id="rId41"/>
+    <p:sldId id="663" r:id="rId42"/>
     <p:sldId id="580" r:id="rId18"/>
   </p:sldIdLst>
   <p:sldSz cx="24384000" cy="13716000"/>
@@ -8002,6 +8005,60 @@
           </a:p>
         </p:txBody>
       </p:sp>
+      <p:sp>
+        <p:nvSpPr>
+          <p:cNvPr id="14" name="Oval 13"/>
+          <p:cNvSpPr/>
+          <p:nvPr/>
+        </p:nvSpPr>
+        <p:spPr>
+          <a:xfrm>
+            <a:off x="914400" y="1051560"/>
+            <a:ext cx="1828800" cy="1828800"/>
+          </a:xfrm>
+          <a:prstGeom prst="ellipse">
+            <a:avLst/>
+          </a:prstGeom>
+          <a:solidFill>
+            <a:srgbClr val="1E3B7D"/>
+          </a:solidFill>
+          <a:ln w="25400">
+            <a:solidFill>
+              <a:srgbClr val="FFFFFF"/>
+            </a:solidFill>
+          </a:ln>
+        </p:spPr>
+        <p:style>
+          <a:lnRef idx="1">
+            <a:schemeClr val="accent1"/>
+          </a:lnRef>
+          <a:fillRef idx="3">
+            <a:schemeClr val="accent1"/>
+          </a:fillRef>
+          <a:effectRef idx="2">
+            <a:schemeClr val="accent1"/>
+          </a:effectRef>
+          <a:fontRef idx="minor">
+            <a:schemeClr val="lt1"/>
+          </a:fontRef>
+        </p:style>
+        <p:txBody>
+          <a:bodyPr rtlCol="0" anchor="ctr"/>
+          <a:lstStyle/>
+          <a:p>
+            <a:pPr algn="ctr"/>
+            <a:r>
+              <a:rPr sz="6000" b="1">
+                <a:solidFill>
+                  <a:srgbClr val="FFFFFF"/>
+                </a:solidFill>
+                <a:latin typeface="Century Gothic"/>
+              </a:rPr>
+              <a:t>1</a:t>
+            </a:r>
+          </a:p>
+        </p:txBody>
+      </p:sp>
     </p:spTree>
   </p:cSld>
   <p:clrMapOvr>
@@ -8528,6 +8585,60 @@
                 <a:latin typeface="Century Gothic"/>
               </a:rPr>
               <a:t>semanas 1 a 2.</a:t>
+            </a:r>
+          </a:p>
+        </p:txBody>
+      </p:sp>
+      <p:sp>
+        <p:nvSpPr>
+          <p:cNvPr id="14" name="Oval 13"/>
+          <p:cNvSpPr/>
+          <p:nvPr/>
+        </p:nvSpPr>
+        <p:spPr>
+          <a:xfrm>
+            <a:off x="914400" y="1051560"/>
+            <a:ext cx="1828800" cy="1828800"/>
+          </a:xfrm>
+          <a:prstGeom prst="ellipse">
+            <a:avLst/>
+          </a:prstGeom>
+          <a:solidFill>
+            <a:srgbClr val="1E3B7D"/>
+          </a:solidFill>
+          <a:ln w="25400">
+            <a:solidFill>
+              <a:srgbClr val="FFFFFF"/>
+            </a:solidFill>
+          </a:ln>
+        </p:spPr>
+        <p:style>
+          <a:lnRef idx="1">
+            <a:schemeClr val="accent1"/>
+          </a:lnRef>
+          <a:fillRef idx="3">
+            <a:schemeClr val="accent1"/>
+          </a:fillRef>
+          <a:effectRef idx="2">
+            <a:schemeClr val="accent1"/>
+          </a:effectRef>
+          <a:fontRef idx="minor">
+            <a:schemeClr val="lt1"/>
+          </a:fontRef>
+        </p:style>
+        <p:txBody>
+          <a:bodyPr rtlCol="0" anchor="ctr"/>
+          <a:lstStyle/>
+          <a:p>
+            <a:pPr algn="ctr"/>
+            <a:r>
+              <a:rPr sz="6000" b="1">
+                <a:solidFill>
+                  <a:srgbClr val="FFFFFF"/>
+                </a:solidFill>
+                <a:latin typeface="Century Gothic"/>
+              </a:rPr>
+              <a:t>2</a:t>
             </a:r>
           </a:p>
         </p:txBody>
@@ -9062,6 +9173,60 @@
           </a:p>
         </p:txBody>
       </p:sp>
+      <p:sp>
+        <p:nvSpPr>
+          <p:cNvPr id="14" name="Oval 13"/>
+          <p:cNvSpPr/>
+          <p:nvPr/>
+        </p:nvSpPr>
+        <p:spPr>
+          <a:xfrm>
+            <a:off x="914400" y="1051560"/>
+            <a:ext cx="1828800" cy="1828800"/>
+          </a:xfrm>
+          <a:prstGeom prst="ellipse">
+            <a:avLst/>
+          </a:prstGeom>
+          <a:solidFill>
+            <a:srgbClr val="1E3B7D"/>
+          </a:solidFill>
+          <a:ln w="25400">
+            <a:solidFill>
+              <a:srgbClr val="FFFFFF"/>
+            </a:solidFill>
+          </a:ln>
+        </p:spPr>
+        <p:style>
+          <a:lnRef idx="1">
+            <a:schemeClr val="accent1"/>
+          </a:lnRef>
+          <a:fillRef idx="3">
+            <a:schemeClr val="accent1"/>
+          </a:fillRef>
+          <a:effectRef idx="2">
+            <a:schemeClr val="accent1"/>
+          </a:effectRef>
+          <a:fontRef idx="minor">
+            <a:schemeClr val="lt1"/>
+          </a:fontRef>
+        </p:style>
+        <p:txBody>
+          <a:bodyPr rtlCol="0" anchor="ctr"/>
+          <a:lstStyle/>
+          <a:p>
+            <a:pPr algn="ctr"/>
+            <a:r>
+              <a:rPr sz="6000" b="1">
+                <a:solidFill>
+                  <a:srgbClr val="FFFFFF"/>
+                </a:solidFill>
+                <a:latin typeface="Century Gothic"/>
+              </a:rPr>
+              <a:t>3</a:t>
+            </a:r>
+          </a:p>
+        </p:txBody>
+      </p:sp>
     </p:spTree>
   </p:cSld>
   <p:clrMapOvr>
@@ -9588,6 +9753,60 @@
                 <a:latin typeface="Century Gothic"/>
               </a:rPr>
               <a:t>semanas 3 a 8.</a:t>
+            </a:r>
+          </a:p>
+        </p:txBody>
+      </p:sp>
+      <p:sp>
+        <p:nvSpPr>
+          <p:cNvPr id="14" name="Oval 13"/>
+          <p:cNvSpPr/>
+          <p:nvPr/>
+        </p:nvSpPr>
+        <p:spPr>
+          <a:xfrm>
+            <a:off x="914400" y="1051560"/>
+            <a:ext cx="1828800" cy="1828800"/>
+          </a:xfrm>
+          <a:prstGeom prst="ellipse">
+            <a:avLst/>
+          </a:prstGeom>
+          <a:solidFill>
+            <a:srgbClr val="1E3B7D"/>
+          </a:solidFill>
+          <a:ln w="25400">
+            <a:solidFill>
+              <a:srgbClr val="FFFFFF"/>
+            </a:solidFill>
+          </a:ln>
+        </p:spPr>
+        <p:style>
+          <a:lnRef idx="1">
+            <a:schemeClr val="accent1"/>
+          </a:lnRef>
+          <a:fillRef idx="3">
+            <a:schemeClr val="accent1"/>
+          </a:fillRef>
+          <a:effectRef idx="2">
+            <a:schemeClr val="accent1"/>
+          </a:effectRef>
+          <a:fontRef idx="minor">
+            <a:schemeClr val="lt1"/>
+          </a:fontRef>
+        </p:style>
+        <p:txBody>
+          <a:bodyPr rtlCol="0" anchor="ctr"/>
+          <a:lstStyle/>
+          <a:p>
+            <a:pPr algn="ctr"/>
+            <a:r>
+              <a:rPr sz="6000" b="1">
+                <a:solidFill>
+                  <a:srgbClr val="FFFFFF"/>
+                </a:solidFill>
+                <a:latin typeface="Century Gothic"/>
+              </a:rPr>
+              <a:t>4</a:t>
             </a:r>
           </a:p>
         </p:txBody>
@@ -10122,6 +10341,60 @@
           </a:p>
         </p:txBody>
       </p:sp>
+      <p:sp>
+        <p:nvSpPr>
+          <p:cNvPr id="14" name="Oval 13"/>
+          <p:cNvSpPr/>
+          <p:nvPr/>
+        </p:nvSpPr>
+        <p:spPr>
+          <a:xfrm>
+            <a:off x="914400" y="1051560"/>
+            <a:ext cx="1828800" cy="1828800"/>
+          </a:xfrm>
+          <a:prstGeom prst="ellipse">
+            <a:avLst/>
+          </a:prstGeom>
+          <a:solidFill>
+            <a:srgbClr val="1E3B7D"/>
+          </a:solidFill>
+          <a:ln w="25400">
+            <a:solidFill>
+              <a:srgbClr val="FFFFFF"/>
+            </a:solidFill>
+          </a:ln>
+        </p:spPr>
+        <p:style>
+          <a:lnRef idx="1">
+            <a:schemeClr val="accent1"/>
+          </a:lnRef>
+          <a:fillRef idx="3">
+            <a:schemeClr val="accent1"/>
+          </a:fillRef>
+          <a:effectRef idx="2">
+            <a:schemeClr val="accent1"/>
+          </a:effectRef>
+          <a:fontRef idx="minor">
+            <a:schemeClr val="lt1"/>
+          </a:fontRef>
+        </p:style>
+        <p:txBody>
+          <a:bodyPr rtlCol="0" anchor="ctr"/>
+          <a:lstStyle/>
+          <a:p>
+            <a:pPr algn="ctr"/>
+            <a:r>
+              <a:rPr sz="6000" b="1">
+                <a:solidFill>
+                  <a:srgbClr val="FFFFFF"/>
+                </a:solidFill>
+                <a:latin typeface="Century Gothic"/>
+              </a:rPr>
+              <a:t>5</a:t>
+            </a:r>
+          </a:p>
+        </p:txBody>
+      </p:sp>
     </p:spTree>
   </p:cSld>
   <p:clrMapOvr>
@@ -10623,6 +10896,60 @@
                 <a:latin typeface="Century Gothic"/>
               </a:rPr>
               <a:t>semana 14 en adelante.</a:t>
+            </a:r>
+          </a:p>
+        </p:txBody>
+      </p:sp>
+      <p:sp>
+        <p:nvSpPr>
+          <p:cNvPr id="14" name="Oval 13"/>
+          <p:cNvSpPr/>
+          <p:nvPr/>
+        </p:nvSpPr>
+        <p:spPr>
+          <a:xfrm>
+            <a:off x="914400" y="1051560"/>
+            <a:ext cx="1828800" cy="1828800"/>
+          </a:xfrm>
+          <a:prstGeom prst="ellipse">
+            <a:avLst/>
+          </a:prstGeom>
+          <a:solidFill>
+            <a:srgbClr val="1E3B7D"/>
+          </a:solidFill>
+          <a:ln w="25400">
+            <a:solidFill>
+              <a:srgbClr val="FFFFFF"/>
+            </a:solidFill>
+          </a:ln>
+        </p:spPr>
+        <p:style>
+          <a:lnRef idx="1">
+            <a:schemeClr val="accent1"/>
+          </a:lnRef>
+          <a:fillRef idx="3">
+            <a:schemeClr val="accent1"/>
+          </a:fillRef>
+          <a:effectRef idx="2">
+            <a:schemeClr val="accent1"/>
+          </a:effectRef>
+          <a:fontRef idx="minor">
+            <a:schemeClr val="lt1"/>
+          </a:fontRef>
+        </p:style>
+        <p:txBody>
+          <a:bodyPr rtlCol="0" anchor="ctr"/>
+          <a:lstStyle/>
+          <a:p>
+            <a:pPr algn="ctr"/>
+            <a:r>
+              <a:rPr sz="6000" b="1">
+                <a:solidFill>
+                  <a:srgbClr val="FFFFFF"/>
+                </a:solidFill>
+                <a:latin typeface="Century Gothic"/>
+              </a:rPr>
+              <a:t>6</a:t>
             </a:r>
           </a:p>
         </p:txBody>
@@ -10704,7 +11031,7 @@
                 </a:solidFill>
                 <a:latin typeface="Century Gothic" panose="020B0502020202020204" pitchFamily="34" charset="0"/>
               </a:rPr>
-              <a:t>Indicadores de seguimiento</a:t>
+              <a:t>Contenido de la guía</a:t>
             </a:r>
             <a:endParaRPr kumimoji="0" lang="en-US" sz="4800" b="0" i="0" u="none" strike="noStrike" kern="1200" cap="none" spc="0" normalizeH="0" baseline="0" noProof="0" dirty="0">
               <a:ln>
@@ -11019,7 +11346,7 @@
                 <a:latin typeface="Century Gothic" panose="020B0502020202020204" pitchFamily="34" charset="0"/>
                 <a:cs typeface="Candara"/>
               </a:rPr>
-              <a:t>•  Personas sensibilizadas por año.</a:t>
+              <a:t>•  ¿Qué es la ruta y a quién está dirigida?</a:t>
             </a:r>
           </a:p>
           <a:p>
@@ -11036,7 +11363,7 @@
                 <a:latin typeface="Century Gothic" panose="020B0502020202020204" pitchFamily="34" charset="0"/>
                 <a:cs typeface="Candara"/>
               </a:rPr>
-              <a:t>•  Proyectos diagnosticados y acompañados por fase.</a:t>
+              <a:t>•  Por qué la necesitamos: el diagnóstico.</a:t>
             </a:r>
           </a:p>
           <a:p>
@@ -11053,7 +11380,7 @@
                 <a:latin typeface="Century Gothic" panose="020B0502020202020204" pitchFamily="34" charset="0"/>
                 <a:cs typeface="Candara"/>
               </a:rPr>
-              <a:t>•  % de proyectos vigentes a 3 años (≥3% — meta PDI).</a:t>
+              <a:t>•  Fundamento institucional (PDI 2022-2031).</a:t>
             </a:r>
           </a:p>
           <a:p>
@@ -11070,7 +11397,7 @@
                 <a:latin typeface="Century Gothic" panose="020B0502020202020204" pitchFamily="34" charset="0"/>
                 <a:cs typeface="Candara"/>
               </a:rPr>
-              <a:t>•  Títulos de propiedad intelectual y spin-offs.</a:t>
+              <a:t>•  Principios, actores y esquema general.</a:t>
             </a:r>
           </a:p>
           <a:p>
@@ -11087,7 +11414,24 @@
                 <a:latin typeface="Century Gothic" panose="020B0502020202020204" pitchFamily="34" charset="0"/>
                 <a:cs typeface="Candara"/>
               </a:rPr>
-              <a:t>•  Facultades con docente enlace activo.</a:t>
+              <a:t>•  Las 6 fases de la ruta, paso a paso.</a:t>
+            </a:r>
+          </a:p>
+          <a:p>
+            <a:pPr algn="l" hangingPunct="1">
+              <a:spcAft>
+                <a:spcPts val="1400"/>
+              </a:spcAft>
+            </a:pPr>
+            <a:r>
+              <a:rPr lang="es-CO" sz="3200" b="1" dirty="0">
+                <a:solidFill>
+                  <a:schemeClr val="accent6"/>
+                </a:solidFill>
+                <a:latin typeface="Century Gothic" panose="020B0502020202020204" pitchFamily="34" charset="0"/>
+                <a:cs typeface="Candara"/>
+              </a:rPr>
+              <a:t>•  Indicadores, articulación y cómo acceder al CIE.</a:t>
             </a:r>
           </a:p>
         </p:txBody>
@@ -11101,6 +11445,629 @@
 </file>
 
 <file path=ppt/slides/slide31.xml><?xml version="1.0" encoding="utf-8"?>
+<p:sld xmlns:a="http://schemas.openxmlformats.org/drawingml/2006/main" xmlns:p="http://schemas.openxmlformats.org/presentationml/2006/main" xmlns:r="http://schemas.openxmlformats.org/officeDocument/2006/relationships">
+  <p:cSld>
+    <p:spTree>
+      <p:nvGrpSpPr>
+        <p:cNvPr id="1" name=""/>
+        <p:cNvGrpSpPr/>
+        <p:nvPr/>
+      </p:nvGrpSpPr>
+      <p:grpSpPr/>
+      <p:sp>
+        <p:nvSpPr>
+          <p:cNvPr id="2" name="Google Shape;234;p28"/>
+          <p:cNvSpPr txBox="1">
+            <a:spLocks/>
+          </p:cNvSpPr>
+          <p:nvPr/>
+        </p:nvSpPr>
+        <p:spPr>
+          <a:xfrm>
+            <a:off x="3731714" y="4777893"/>
+            <a:ext cx="16341340" cy="2192170"/>
+          </a:xfrm>
+          <a:prstGeom prst="rect">
+            <a:avLst/>
+          </a:prstGeom>
+        </p:spPr>
+        <p:txBody>
+          <a:bodyPr spcFirstLastPara="1" wrap="square" lIns="91425" tIns="91425" rIns="91425" bIns="91425" anchor="b" anchorCtr="0">
+            <a:noAutofit/>
+          </a:bodyPr>
+          <a:lstStyle>
+            <a:lvl1pPr marL="0" marR="0" indent="0" algn="l" defTabSz="825500" rtl="0" latinLnBrk="0">
+              <a:lnSpc>
+                <a:spcPct val="80000"/>
+              </a:lnSpc>
+              <a:spcBef>
+                <a:spcPts val="0"/>
+              </a:spcBef>
+              <a:spcAft>
+                <a:spcPts val="0"/>
+              </a:spcAft>
+              <a:buClrTx/>
+              <a:buSzTx/>
+              <a:buFontTx/>
+              <a:buNone/>
+              <a:tabLst/>
+              <a:defRPr sz="9600" b="0" i="0" u="none" strike="noStrike" cap="all" spc="0" baseline="12500">
+                <a:ln>
+                  <a:noFill/>
+                </a:ln>
+                <a:solidFill>
+                  <a:srgbClr val="17222C"/>
+                </a:solidFill>
+                <a:uFillTx/>
+                <a:latin typeface="+mn-lt"/>
+                <a:ea typeface="+mn-ea"/>
+                <a:cs typeface="+mn-cs"/>
+                <a:sym typeface="Montserrat-Bold"/>
+              </a:defRPr>
+            </a:lvl1pPr>
+            <a:lvl2pPr marL="0" marR="0" indent="228600" algn="l" defTabSz="825500" rtl="0" latinLnBrk="0">
+              <a:lnSpc>
+                <a:spcPct val="80000"/>
+              </a:lnSpc>
+              <a:spcBef>
+                <a:spcPts val="0"/>
+              </a:spcBef>
+              <a:spcAft>
+                <a:spcPts val="0"/>
+              </a:spcAft>
+              <a:buClrTx/>
+              <a:buSzTx/>
+              <a:buFontTx/>
+              <a:buNone/>
+              <a:tabLst/>
+              <a:defRPr sz="9600" b="0" i="0" u="none" strike="noStrike" cap="all" spc="0" baseline="12500">
+                <a:ln>
+                  <a:noFill/>
+                </a:ln>
+                <a:solidFill>
+                  <a:srgbClr val="17222C"/>
+                </a:solidFill>
+                <a:uFillTx/>
+                <a:latin typeface="+mn-lt"/>
+                <a:ea typeface="+mn-ea"/>
+                <a:cs typeface="+mn-cs"/>
+                <a:sym typeface="Montserrat-Bold"/>
+              </a:defRPr>
+            </a:lvl2pPr>
+            <a:lvl3pPr marL="0" marR="0" indent="457200" algn="l" defTabSz="825500" rtl="0" latinLnBrk="0">
+              <a:lnSpc>
+                <a:spcPct val="80000"/>
+              </a:lnSpc>
+              <a:spcBef>
+                <a:spcPts val="0"/>
+              </a:spcBef>
+              <a:spcAft>
+                <a:spcPts val="0"/>
+              </a:spcAft>
+              <a:buClrTx/>
+              <a:buSzTx/>
+              <a:buFontTx/>
+              <a:buNone/>
+              <a:tabLst/>
+              <a:defRPr sz="9600" b="0" i="0" u="none" strike="noStrike" cap="all" spc="0" baseline="12500">
+                <a:ln>
+                  <a:noFill/>
+                </a:ln>
+                <a:solidFill>
+                  <a:srgbClr val="17222C"/>
+                </a:solidFill>
+                <a:uFillTx/>
+                <a:latin typeface="+mn-lt"/>
+                <a:ea typeface="+mn-ea"/>
+                <a:cs typeface="+mn-cs"/>
+                <a:sym typeface="Montserrat-Bold"/>
+              </a:defRPr>
+            </a:lvl3pPr>
+            <a:lvl4pPr marL="0" marR="0" indent="685800" algn="l" defTabSz="825500" rtl="0" latinLnBrk="0">
+              <a:lnSpc>
+                <a:spcPct val="80000"/>
+              </a:lnSpc>
+              <a:spcBef>
+                <a:spcPts val="0"/>
+              </a:spcBef>
+              <a:spcAft>
+                <a:spcPts val="0"/>
+              </a:spcAft>
+              <a:buClrTx/>
+              <a:buSzTx/>
+              <a:buFontTx/>
+              <a:buNone/>
+              <a:tabLst/>
+              <a:defRPr sz="9600" b="0" i="0" u="none" strike="noStrike" cap="all" spc="0" baseline="12500">
+                <a:ln>
+                  <a:noFill/>
+                </a:ln>
+                <a:solidFill>
+                  <a:srgbClr val="17222C"/>
+                </a:solidFill>
+                <a:uFillTx/>
+                <a:latin typeface="+mn-lt"/>
+                <a:ea typeface="+mn-ea"/>
+                <a:cs typeface="+mn-cs"/>
+                <a:sym typeface="Montserrat-Bold"/>
+              </a:defRPr>
+            </a:lvl4pPr>
+            <a:lvl5pPr marL="0" marR="0" indent="914400" algn="l" defTabSz="825500" rtl="0" latinLnBrk="0">
+              <a:lnSpc>
+                <a:spcPct val="80000"/>
+              </a:lnSpc>
+              <a:spcBef>
+                <a:spcPts val="0"/>
+              </a:spcBef>
+              <a:spcAft>
+                <a:spcPts val="0"/>
+              </a:spcAft>
+              <a:buClrTx/>
+              <a:buSzTx/>
+              <a:buFontTx/>
+              <a:buNone/>
+              <a:tabLst/>
+              <a:defRPr sz="9600" b="0" i="0" u="none" strike="noStrike" cap="all" spc="0" baseline="12500">
+                <a:ln>
+                  <a:noFill/>
+                </a:ln>
+                <a:solidFill>
+                  <a:srgbClr val="17222C"/>
+                </a:solidFill>
+                <a:uFillTx/>
+                <a:latin typeface="+mn-lt"/>
+                <a:ea typeface="+mn-ea"/>
+                <a:cs typeface="+mn-cs"/>
+                <a:sym typeface="Montserrat-Bold"/>
+              </a:defRPr>
+            </a:lvl5pPr>
+            <a:lvl6pPr marL="0" marR="0" indent="1143000" algn="l" defTabSz="825500" rtl="0" latinLnBrk="0">
+              <a:lnSpc>
+                <a:spcPct val="80000"/>
+              </a:lnSpc>
+              <a:spcBef>
+                <a:spcPts val="0"/>
+              </a:spcBef>
+              <a:spcAft>
+                <a:spcPts val="0"/>
+              </a:spcAft>
+              <a:buClrTx/>
+              <a:buSzTx/>
+              <a:buFontTx/>
+              <a:buNone/>
+              <a:tabLst/>
+              <a:defRPr sz="9600" b="0" i="0" u="none" strike="noStrike" cap="all" spc="0" baseline="12500">
+                <a:ln>
+                  <a:noFill/>
+                </a:ln>
+                <a:solidFill>
+                  <a:srgbClr val="17222C"/>
+                </a:solidFill>
+                <a:uFillTx/>
+                <a:latin typeface="+mn-lt"/>
+                <a:ea typeface="+mn-ea"/>
+                <a:cs typeface="+mn-cs"/>
+                <a:sym typeface="Montserrat-Bold"/>
+              </a:defRPr>
+            </a:lvl6pPr>
+            <a:lvl7pPr marL="0" marR="0" indent="1371600" algn="l" defTabSz="825500" rtl="0" latinLnBrk="0">
+              <a:lnSpc>
+                <a:spcPct val="80000"/>
+              </a:lnSpc>
+              <a:spcBef>
+                <a:spcPts val="0"/>
+              </a:spcBef>
+              <a:spcAft>
+                <a:spcPts val="0"/>
+              </a:spcAft>
+              <a:buClrTx/>
+              <a:buSzTx/>
+              <a:buFontTx/>
+              <a:buNone/>
+              <a:tabLst/>
+              <a:defRPr sz="9600" b="0" i="0" u="none" strike="noStrike" cap="all" spc="0" baseline="12500">
+                <a:ln>
+                  <a:noFill/>
+                </a:ln>
+                <a:solidFill>
+                  <a:srgbClr val="17222C"/>
+                </a:solidFill>
+                <a:uFillTx/>
+                <a:latin typeface="+mn-lt"/>
+                <a:ea typeface="+mn-ea"/>
+                <a:cs typeface="+mn-cs"/>
+                <a:sym typeface="Montserrat-Bold"/>
+              </a:defRPr>
+            </a:lvl7pPr>
+            <a:lvl8pPr marL="0" marR="0" indent="1600200" algn="l" defTabSz="825500" rtl="0" latinLnBrk="0">
+              <a:lnSpc>
+                <a:spcPct val="80000"/>
+              </a:lnSpc>
+              <a:spcBef>
+                <a:spcPts val="0"/>
+              </a:spcBef>
+              <a:spcAft>
+                <a:spcPts val="0"/>
+              </a:spcAft>
+              <a:buClrTx/>
+              <a:buSzTx/>
+              <a:buFontTx/>
+              <a:buNone/>
+              <a:tabLst/>
+              <a:defRPr sz="9600" b="0" i="0" u="none" strike="noStrike" cap="all" spc="0" baseline="12500">
+                <a:ln>
+                  <a:noFill/>
+                </a:ln>
+                <a:solidFill>
+                  <a:srgbClr val="17222C"/>
+                </a:solidFill>
+                <a:uFillTx/>
+                <a:latin typeface="+mn-lt"/>
+                <a:ea typeface="+mn-ea"/>
+                <a:cs typeface="+mn-cs"/>
+                <a:sym typeface="Montserrat-Bold"/>
+              </a:defRPr>
+            </a:lvl8pPr>
+            <a:lvl9pPr marL="0" marR="0" indent="1828800" algn="l" defTabSz="825500" rtl="0" latinLnBrk="0">
+              <a:lnSpc>
+                <a:spcPct val="80000"/>
+              </a:lnSpc>
+              <a:spcBef>
+                <a:spcPts val="0"/>
+              </a:spcBef>
+              <a:spcAft>
+                <a:spcPts val="0"/>
+              </a:spcAft>
+              <a:buClrTx/>
+              <a:buSzTx/>
+              <a:buFontTx/>
+              <a:buNone/>
+              <a:tabLst/>
+              <a:defRPr sz="9600" b="0" i="0" u="none" strike="noStrike" cap="all" spc="0" baseline="12500">
+                <a:ln>
+                  <a:noFill/>
+                </a:ln>
+                <a:solidFill>
+                  <a:srgbClr val="17222C"/>
+                </a:solidFill>
+                <a:uFillTx/>
+                <a:latin typeface="+mn-lt"/>
+                <a:ea typeface="+mn-ea"/>
+                <a:cs typeface="+mn-cs"/>
+                <a:sym typeface="Montserrat-Bold"/>
+              </a:defRPr>
+            </a:lvl9pPr>
+          </a:lstStyle>
+          <a:p>
+            <a:pPr algn="ctr" hangingPunct="1">
+              <a:lnSpc>
+                <a:spcPct val="100000"/>
+              </a:lnSpc>
+            </a:pPr>
+            <a:r>
+              <a:rPr lang="es-CO" b="1" dirty="0" sz="6000">
+                <a:solidFill>
+                  <a:schemeClr val="tx1"/>
+                </a:solidFill>
+                <a:latin typeface="Century Gothic" panose="020B0502020202020204" pitchFamily="34" charset="0"/>
+                <a:cs typeface="Candara"/>
+              </a:rPr>
+              <a:t>Las 6 fases de la ruta</a:t>
+            </a:r>
+          </a:p>
+        </p:txBody>
+      </p:sp>
+      <p:sp>
+        <p:nvSpPr>
+          <p:cNvPr id="3" name="Google Shape;235;p28"/>
+          <p:cNvSpPr txBox="1">
+            <a:spLocks/>
+          </p:cNvSpPr>
+          <p:nvPr/>
+        </p:nvSpPr>
+        <p:spPr>
+          <a:xfrm>
+            <a:off x="3387220" y="7842022"/>
+            <a:ext cx="17030329" cy="2267076"/>
+          </a:xfrm>
+          <a:prstGeom prst="rect">
+            <a:avLst/>
+          </a:prstGeom>
+        </p:spPr>
+        <p:txBody>
+          <a:bodyPr spcFirstLastPara="1" wrap="square" lIns="91425" tIns="91425" rIns="91425" bIns="91425" anchor="t" anchorCtr="0">
+            <a:noAutofit/>
+          </a:bodyPr>
+          <a:lstStyle>
+            <a:lvl1pPr marL="0" marR="0" indent="0" algn="just" defTabSz="825500" rtl="0" latinLnBrk="0">
+              <a:lnSpc>
+                <a:spcPct val="120000"/>
+              </a:lnSpc>
+              <a:spcBef>
+                <a:spcPts val="0"/>
+              </a:spcBef>
+              <a:spcAft>
+                <a:spcPts val="0"/>
+              </a:spcAft>
+              <a:buClrTx/>
+              <a:buSzTx/>
+              <a:buFontTx/>
+              <a:buNone/>
+              <a:tabLst/>
+              <a:defRPr sz="2400" b="0" i="0" u="none" strike="noStrike" cap="none" spc="0" baseline="0">
+                <a:ln>
+                  <a:noFill/>
+                </a:ln>
+                <a:solidFill>
+                  <a:srgbClr val="868A8D"/>
+                </a:solidFill>
+                <a:uFillTx/>
+                <a:latin typeface="Montserrat Light"/>
+                <a:ea typeface="Montserrat Light"/>
+                <a:cs typeface="Montserrat Light"/>
+                <a:sym typeface="Montserrat Light"/>
+              </a:defRPr>
+            </a:lvl1pPr>
+            <a:lvl2pPr marL="0" marR="0" indent="228600" algn="just" defTabSz="825500" rtl="0" latinLnBrk="0">
+              <a:lnSpc>
+                <a:spcPct val="120000"/>
+              </a:lnSpc>
+              <a:spcBef>
+                <a:spcPts val="0"/>
+              </a:spcBef>
+              <a:spcAft>
+                <a:spcPts val="0"/>
+              </a:spcAft>
+              <a:buClrTx/>
+              <a:buSzTx/>
+              <a:buFontTx/>
+              <a:buNone/>
+              <a:tabLst/>
+              <a:defRPr sz="2400" b="0" i="0" u="none" strike="noStrike" cap="none" spc="0" baseline="0">
+                <a:ln>
+                  <a:noFill/>
+                </a:ln>
+                <a:solidFill>
+                  <a:srgbClr val="868A8D"/>
+                </a:solidFill>
+                <a:uFillTx/>
+                <a:latin typeface="Montserrat Light"/>
+                <a:ea typeface="Montserrat Light"/>
+                <a:cs typeface="Montserrat Light"/>
+                <a:sym typeface="Montserrat Light"/>
+              </a:defRPr>
+            </a:lvl2pPr>
+            <a:lvl3pPr marL="0" marR="0" indent="457200" algn="just" defTabSz="825500" rtl="0" latinLnBrk="0">
+              <a:lnSpc>
+                <a:spcPct val="120000"/>
+              </a:lnSpc>
+              <a:spcBef>
+                <a:spcPts val="0"/>
+              </a:spcBef>
+              <a:spcAft>
+                <a:spcPts val="0"/>
+              </a:spcAft>
+              <a:buClrTx/>
+              <a:buSzTx/>
+              <a:buFontTx/>
+              <a:buNone/>
+              <a:tabLst/>
+              <a:defRPr sz="2400" b="0" i="0" u="none" strike="noStrike" cap="none" spc="0" baseline="0">
+                <a:ln>
+                  <a:noFill/>
+                </a:ln>
+                <a:solidFill>
+                  <a:srgbClr val="868A8D"/>
+                </a:solidFill>
+                <a:uFillTx/>
+                <a:latin typeface="Montserrat Light"/>
+                <a:ea typeface="Montserrat Light"/>
+                <a:cs typeface="Montserrat Light"/>
+                <a:sym typeface="Montserrat Light"/>
+              </a:defRPr>
+            </a:lvl3pPr>
+            <a:lvl4pPr marL="0" marR="0" indent="685800" algn="just" defTabSz="825500" rtl="0" latinLnBrk="0">
+              <a:lnSpc>
+                <a:spcPct val="120000"/>
+              </a:lnSpc>
+              <a:spcBef>
+                <a:spcPts val="0"/>
+              </a:spcBef>
+              <a:spcAft>
+                <a:spcPts val="0"/>
+              </a:spcAft>
+              <a:buClrTx/>
+              <a:buSzTx/>
+              <a:buFontTx/>
+              <a:buNone/>
+              <a:tabLst/>
+              <a:defRPr sz="2400" b="0" i="0" u="none" strike="noStrike" cap="none" spc="0" baseline="0">
+                <a:ln>
+                  <a:noFill/>
+                </a:ln>
+                <a:solidFill>
+                  <a:srgbClr val="868A8D"/>
+                </a:solidFill>
+                <a:uFillTx/>
+                <a:latin typeface="Montserrat Light"/>
+                <a:ea typeface="Montserrat Light"/>
+                <a:cs typeface="Montserrat Light"/>
+                <a:sym typeface="Montserrat Light"/>
+              </a:defRPr>
+            </a:lvl4pPr>
+            <a:lvl5pPr marL="0" marR="0" indent="914400" algn="just" defTabSz="825500" rtl="0" latinLnBrk="0">
+              <a:lnSpc>
+                <a:spcPct val="120000"/>
+              </a:lnSpc>
+              <a:spcBef>
+                <a:spcPts val="0"/>
+              </a:spcBef>
+              <a:spcAft>
+                <a:spcPts val="0"/>
+              </a:spcAft>
+              <a:buClrTx/>
+              <a:buSzTx/>
+              <a:buFontTx/>
+              <a:buNone/>
+              <a:tabLst/>
+              <a:defRPr sz="2400" b="0" i="0" u="none" strike="noStrike" cap="none" spc="0" baseline="0">
+                <a:ln>
+                  <a:noFill/>
+                </a:ln>
+                <a:solidFill>
+                  <a:srgbClr val="868A8D"/>
+                </a:solidFill>
+                <a:uFillTx/>
+                <a:latin typeface="Montserrat Light"/>
+                <a:ea typeface="Montserrat Light"/>
+                <a:cs typeface="Montserrat Light"/>
+                <a:sym typeface="Montserrat Light"/>
+              </a:defRPr>
+            </a:lvl5pPr>
+            <a:lvl6pPr marL="0" marR="0" indent="1143000" algn="just" defTabSz="825500" rtl="0" latinLnBrk="0">
+              <a:lnSpc>
+                <a:spcPct val="120000"/>
+              </a:lnSpc>
+              <a:spcBef>
+                <a:spcPts val="0"/>
+              </a:spcBef>
+              <a:spcAft>
+                <a:spcPts val="0"/>
+              </a:spcAft>
+              <a:buClrTx/>
+              <a:buSzTx/>
+              <a:buFontTx/>
+              <a:buNone/>
+              <a:tabLst/>
+              <a:defRPr sz="2400" b="0" i="0" u="none" strike="noStrike" cap="none" spc="0" baseline="0">
+                <a:ln>
+                  <a:noFill/>
+                </a:ln>
+                <a:solidFill>
+                  <a:srgbClr val="868A8D"/>
+                </a:solidFill>
+                <a:uFillTx/>
+                <a:latin typeface="Montserrat Light"/>
+                <a:ea typeface="Montserrat Light"/>
+                <a:cs typeface="Montserrat Light"/>
+                <a:sym typeface="Montserrat Light"/>
+              </a:defRPr>
+            </a:lvl6pPr>
+            <a:lvl7pPr marL="0" marR="0" indent="1371600" algn="just" defTabSz="825500" rtl="0" latinLnBrk="0">
+              <a:lnSpc>
+                <a:spcPct val="120000"/>
+              </a:lnSpc>
+              <a:spcBef>
+                <a:spcPts val="0"/>
+              </a:spcBef>
+              <a:spcAft>
+                <a:spcPts val="0"/>
+              </a:spcAft>
+              <a:buClrTx/>
+              <a:buSzTx/>
+              <a:buFontTx/>
+              <a:buNone/>
+              <a:tabLst/>
+              <a:defRPr sz="2400" b="0" i="0" u="none" strike="noStrike" cap="none" spc="0" baseline="0">
+                <a:ln>
+                  <a:noFill/>
+                </a:ln>
+                <a:solidFill>
+                  <a:srgbClr val="868A8D"/>
+                </a:solidFill>
+                <a:uFillTx/>
+                <a:latin typeface="Montserrat Light"/>
+                <a:ea typeface="Montserrat Light"/>
+                <a:cs typeface="Montserrat Light"/>
+                <a:sym typeface="Montserrat Light"/>
+              </a:defRPr>
+            </a:lvl7pPr>
+            <a:lvl8pPr marL="0" marR="0" indent="1600200" algn="just" defTabSz="825500" rtl="0" latinLnBrk="0">
+              <a:lnSpc>
+                <a:spcPct val="120000"/>
+              </a:lnSpc>
+              <a:spcBef>
+                <a:spcPts val="0"/>
+              </a:spcBef>
+              <a:spcAft>
+                <a:spcPts val="0"/>
+              </a:spcAft>
+              <a:buClrTx/>
+              <a:buSzTx/>
+              <a:buFontTx/>
+              <a:buNone/>
+              <a:tabLst/>
+              <a:defRPr sz="2400" b="0" i="0" u="none" strike="noStrike" cap="none" spc="0" baseline="0">
+                <a:ln>
+                  <a:noFill/>
+                </a:ln>
+                <a:solidFill>
+                  <a:srgbClr val="868A8D"/>
+                </a:solidFill>
+                <a:uFillTx/>
+                <a:latin typeface="Montserrat Light"/>
+                <a:ea typeface="Montserrat Light"/>
+                <a:cs typeface="Montserrat Light"/>
+                <a:sym typeface="Montserrat Light"/>
+              </a:defRPr>
+            </a:lvl8pPr>
+            <a:lvl9pPr marL="0" marR="0" indent="1828800" algn="just" defTabSz="825500" rtl="0" latinLnBrk="0">
+              <a:lnSpc>
+                <a:spcPct val="120000"/>
+              </a:lnSpc>
+              <a:spcBef>
+                <a:spcPts val="0"/>
+              </a:spcBef>
+              <a:spcAft>
+                <a:spcPts val="0"/>
+              </a:spcAft>
+              <a:buClrTx/>
+              <a:buSzTx/>
+              <a:buFontTx/>
+              <a:buNone/>
+              <a:tabLst/>
+              <a:defRPr sz="2400" b="0" i="0" u="none" strike="noStrike" cap="none" spc="0" baseline="0">
+                <a:ln>
+                  <a:noFill/>
+                </a:ln>
+                <a:solidFill>
+                  <a:srgbClr val="868A8D"/>
+                </a:solidFill>
+                <a:uFillTx/>
+                <a:latin typeface="Montserrat Light"/>
+                <a:ea typeface="Montserrat Light"/>
+                <a:cs typeface="Montserrat Light"/>
+                <a:sym typeface="Montserrat Light"/>
+              </a:defRPr>
+            </a:lvl9pPr>
+          </a:lstStyle>
+          <a:p>
+            <a:pPr marL="114300" algn="ctr" hangingPunct="1">
+              <a:lnSpc>
+                <a:spcPct val="100000"/>
+              </a:lnSpc>
+            </a:pPr>
+            <a:r>
+              <a:rPr lang="es-ES" sz="3000" dirty="0">
+                <a:solidFill>
+                  <a:schemeClr val="tx1"/>
+                </a:solidFill>
+                <a:latin typeface="Century Gothic" panose="020B0502020202020204" pitchFamily="34" charset="0"/>
+              </a:rPr>
+              <a:t>De la idea al mercado: un acompañamiento por etapas</a:t>
+            </a:r>
+          </a:p>
+        </p:txBody>
+      </p:sp>
+    </p:spTree>
+  </p:cSld>
+  <p:clrMapOvr>
+    <a:masterClrMapping/>
+  </p:clrMapOvr>
+</p:sld>
+</file>
+
+<file path=ppt/slides/slide32.xml><?xml version="1.0" encoding="utf-8"?>
 <p:sld xmlns:a="http://schemas.openxmlformats.org/drawingml/2006/main" xmlns:p="http://schemas.openxmlformats.org/presentationml/2006/main" xmlns:r="http://schemas.openxmlformats.org/officeDocument/2006/relationships">
   <p:cSld>
     <p:spTree>
@@ -11160,6 +12127,471 @@
               <a:defRPr/>
             </a:pPr>
             <a:r>
+              <a:rPr lang="pt-BR" sz="4000" b="1" kern="1200" dirty="0">
+                <a:ln w="0">
+                  <a:noFill/>
+                </a:ln>
+                <a:solidFill>
+                  <a:schemeClr val="tx1"/>
+                </a:solidFill>
+                <a:latin typeface="Century Gothic" panose="020B0502020202020204" pitchFamily="34" charset="0"/>
+              </a:rPr>
+              <a:t>Indicadores de seguimiento</a:t>
+            </a:r>
+            <a:endParaRPr kumimoji="0" lang="en-US" sz="4800" b="0" i="0" u="none" strike="noStrike" kern="1200" cap="none" spc="0" normalizeH="0" baseline="0" noProof="0" dirty="0">
+              <a:ln>
+                <a:noFill/>
+              </a:ln>
+              <a:solidFill>
+                <a:schemeClr val="tx1"/>
+              </a:solidFill>
+              <a:effectLst/>
+              <a:uLnTx/>
+              <a:uFillTx/>
+              <a:latin typeface="Lato Black" panose="020F0A02020204030203" pitchFamily="34" charset="0"/>
+            </a:endParaRPr>
+          </a:p>
+        </p:txBody>
+      </p:sp>
+      <p:sp>
+        <p:nvSpPr>
+          <p:cNvPr id="13" name="Google Shape;139;p19"/>
+          <p:cNvSpPr txBox="1">
+            <a:spLocks/>
+          </p:cNvSpPr>
+          <p:nvPr/>
+        </p:nvSpPr>
+        <p:spPr>
+          <a:xfrm>
+            <a:off x="2194560" y="3657600"/>
+            <a:ext cx="19933920" cy="7863840"/>
+          </a:xfrm>
+          <a:prstGeom prst="rect">
+            <a:avLst/>
+          </a:prstGeom>
+        </p:spPr>
+        <p:txBody>
+          <a:bodyPr spcFirstLastPara="1" wrap="square" lIns="91425" tIns="91425" rIns="91425" bIns="91425" anchor="t" anchorCtr="0">
+            <a:noAutofit/>
+          </a:bodyPr>
+          <a:lstStyle>
+            <a:lvl1pPr marL="0" marR="0" indent="0" algn="just" defTabSz="825500" rtl="0" latinLnBrk="0">
+              <a:lnSpc>
+                <a:spcPct val="120000"/>
+              </a:lnSpc>
+              <a:spcBef>
+                <a:spcPts val="0"/>
+              </a:spcBef>
+              <a:spcAft>
+                <a:spcPts val="0"/>
+              </a:spcAft>
+              <a:buClrTx/>
+              <a:buSzTx/>
+              <a:buFontTx/>
+              <a:buNone/>
+              <a:tabLst/>
+              <a:defRPr sz="2400" b="0" i="0" u="none" strike="noStrike" cap="none" spc="0" baseline="0">
+                <a:ln>
+                  <a:noFill/>
+                </a:ln>
+                <a:solidFill>
+                  <a:srgbClr val="868A8D"/>
+                </a:solidFill>
+                <a:uFillTx/>
+                <a:latin typeface="Montserrat Light"/>
+                <a:ea typeface="Montserrat Light"/>
+                <a:cs typeface="Montserrat Light"/>
+                <a:sym typeface="Montserrat Light"/>
+              </a:defRPr>
+            </a:lvl1pPr>
+            <a:lvl2pPr marL="0" marR="0" indent="228600" algn="just" defTabSz="825500" rtl="0" latinLnBrk="0">
+              <a:lnSpc>
+                <a:spcPct val="120000"/>
+              </a:lnSpc>
+              <a:spcBef>
+                <a:spcPts val="0"/>
+              </a:spcBef>
+              <a:spcAft>
+                <a:spcPts val="0"/>
+              </a:spcAft>
+              <a:buClrTx/>
+              <a:buSzTx/>
+              <a:buFontTx/>
+              <a:buNone/>
+              <a:tabLst/>
+              <a:defRPr sz="2400" b="0" i="0" u="none" strike="noStrike" cap="none" spc="0" baseline="0">
+                <a:ln>
+                  <a:noFill/>
+                </a:ln>
+                <a:solidFill>
+                  <a:srgbClr val="868A8D"/>
+                </a:solidFill>
+                <a:uFillTx/>
+                <a:latin typeface="Montserrat Light"/>
+                <a:ea typeface="Montserrat Light"/>
+                <a:cs typeface="Montserrat Light"/>
+                <a:sym typeface="Montserrat Light"/>
+              </a:defRPr>
+            </a:lvl2pPr>
+            <a:lvl3pPr marL="0" marR="0" indent="457200" algn="just" defTabSz="825500" rtl="0" latinLnBrk="0">
+              <a:lnSpc>
+                <a:spcPct val="120000"/>
+              </a:lnSpc>
+              <a:spcBef>
+                <a:spcPts val="0"/>
+              </a:spcBef>
+              <a:spcAft>
+                <a:spcPts val="0"/>
+              </a:spcAft>
+              <a:buClrTx/>
+              <a:buSzTx/>
+              <a:buFontTx/>
+              <a:buNone/>
+              <a:tabLst/>
+              <a:defRPr sz="2400" b="0" i="0" u="none" strike="noStrike" cap="none" spc="0" baseline="0">
+                <a:ln>
+                  <a:noFill/>
+                </a:ln>
+                <a:solidFill>
+                  <a:srgbClr val="868A8D"/>
+                </a:solidFill>
+                <a:uFillTx/>
+                <a:latin typeface="Montserrat Light"/>
+                <a:ea typeface="Montserrat Light"/>
+                <a:cs typeface="Montserrat Light"/>
+                <a:sym typeface="Montserrat Light"/>
+              </a:defRPr>
+            </a:lvl3pPr>
+            <a:lvl4pPr marL="0" marR="0" indent="685800" algn="just" defTabSz="825500" rtl="0" latinLnBrk="0">
+              <a:lnSpc>
+                <a:spcPct val="120000"/>
+              </a:lnSpc>
+              <a:spcBef>
+                <a:spcPts val="0"/>
+              </a:spcBef>
+              <a:spcAft>
+                <a:spcPts val="0"/>
+              </a:spcAft>
+              <a:buClrTx/>
+              <a:buSzTx/>
+              <a:buFontTx/>
+              <a:buNone/>
+              <a:tabLst/>
+              <a:defRPr sz="2400" b="0" i="0" u="none" strike="noStrike" cap="none" spc="0" baseline="0">
+                <a:ln>
+                  <a:noFill/>
+                </a:ln>
+                <a:solidFill>
+                  <a:srgbClr val="868A8D"/>
+                </a:solidFill>
+                <a:uFillTx/>
+                <a:latin typeface="Montserrat Light"/>
+                <a:ea typeface="Montserrat Light"/>
+                <a:cs typeface="Montserrat Light"/>
+                <a:sym typeface="Montserrat Light"/>
+              </a:defRPr>
+            </a:lvl4pPr>
+            <a:lvl5pPr marL="0" marR="0" indent="914400" algn="just" defTabSz="825500" rtl="0" latinLnBrk="0">
+              <a:lnSpc>
+                <a:spcPct val="120000"/>
+              </a:lnSpc>
+              <a:spcBef>
+                <a:spcPts val="0"/>
+              </a:spcBef>
+              <a:spcAft>
+                <a:spcPts val="0"/>
+              </a:spcAft>
+              <a:buClrTx/>
+              <a:buSzTx/>
+              <a:buFontTx/>
+              <a:buNone/>
+              <a:tabLst/>
+              <a:defRPr sz="2400" b="0" i="0" u="none" strike="noStrike" cap="none" spc="0" baseline="0">
+                <a:ln>
+                  <a:noFill/>
+                </a:ln>
+                <a:solidFill>
+                  <a:srgbClr val="868A8D"/>
+                </a:solidFill>
+                <a:uFillTx/>
+                <a:latin typeface="Montserrat Light"/>
+                <a:ea typeface="Montserrat Light"/>
+                <a:cs typeface="Montserrat Light"/>
+                <a:sym typeface="Montserrat Light"/>
+              </a:defRPr>
+            </a:lvl5pPr>
+            <a:lvl6pPr marL="0" marR="0" indent="1143000" algn="just" defTabSz="825500" rtl="0" latinLnBrk="0">
+              <a:lnSpc>
+                <a:spcPct val="120000"/>
+              </a:lnSpc>
+              <a:spcBef>
+                <a:spcPts val="0"/>
+              </a:spcBef>
+              <a:spcAft>
+                <a:spcPts val="0"/>
+              </a:spcAft>
+              <a:buClrTx/>
+              <a:buSzTx/>
+              <a:buFontTx/>
+              <a:buNone/>
+              <a:tabLst/>
+              <a:defRPr sz="2400" b="0" i="0" u="none" strike="noStrike" cap="none" spc="0" baseline="0">
+                <a:ln>
+                  <a:noFill/>
+                </a:ln>
+                <a:solidFill>
+                  <a:srgbClr val="868A8D"/>
+                </a:solidFill>
+                <a:uFillTx/>
+                <a:latin typeface="Montserrat Light"/>
+                <a:ea typeface="Montserrat Light"/>
+                <a:cs typeface="Montserrat Light"/>
+                <a:sym typeface="Montserrat Light"/>
+              </a:defRPr>
+            </a:lvl6pPr>
+            <a:lvl7pPr marL="0" marR="0" indent="1371600" algn="just" defTabSz="825500" rtl="0" latinLnBrk="0">
+              <a:lnSpc>
+                <a:spcPct val="120000"/>
+              </a:lnSpc>
+              <a:spcBef>
+                <a:spcPts val="0"/>
+              </a:spcBef>
+              <a:spcAft>
+                <a:spcPts val="0"/>
+              </a:spcAft>
+              <a:buClrTx/>
+              <a:buSzTx/>
+              <a:buFontTx/>
+              <a:buNone/>
+              <a:tabLst/>
+              <a:defRPr sz="2400" b="0" i="0" u="none" strike="noStrike" cap="none" spc="0" baseline="0">
+                <a:ln>
+                  <a:noFill/>
+                </a:ln>
+                <a:solidFill>
+                  <a:srgbClr val="868A8D"/>
+                </a:solidFill>
+                <a:uFillTx/>
+                <a:latin typeface="Montserrat Light"/>
+                <a:ea typeface="Montserrat Light"/>
+                <a:cs typeface="Montserrat Light"/>
+                <a:sym typeface="Montserrat Light"/>
+              </a:defRPr>
+            </a:lvl7pPr>
+            <a:lvl8pPr marL="0" marR="0" indent="1600200" algn="just" defTabSz="825500" rtl="0" latinLnBrk="0">
+              <a:lnSpc>
+                <a:spcPct val="120000"/>
+              </a:lnSpc>
+              <a:spcBef>
+                <a:spcPts val="0"/>
+              </a:spcBef>
+              <a:spcAft>
+                <a:spcPts val="0"/>
+              </a:spcAft>
+              <a:buClrTx/>
+              <a:buSzTx/>
+              <a:buFontTx/>
+              <a:buNone/>
+              <a:tabLst/>
+              <a:defRPr sz="2400" b="0" i="0" u="none" strike="noStrike" cap="none" spc="0" baseline="0">
+                <a:ln>
+                  <a:noFill/>
+                </a:ln>
+                <a:solidFill>
+                  <a:srgbClr val="868A8D"/>
+                </a:solidFill>
+                <a:uFillTx/>
+                <a:latin typeface="Montserrat Light"/>
+                <a:ea typeface="Montserrat Light"/>
+                <a:cs typeface="Montserrat Light"/>
+                <a:sym typeface="Montserrat Light"/>
+              </a:defRPr>
+            </a:lvl8pPr>
+            <a:lvl9pPr marL="0" marR="0" indent="1828800" algn="just" defTabSz="825500" rtl="0" latinLnBrk="0">
+              <a:lnSpc>
+                <a:spcPct val="120000"/>
+              </a:lnSpc>
+              <a:spcBef>
+                <a:spcPts val="0"/>
+              </a:spcBef>
+              <a:spcAft>
+                <a:spcPts val="0"/>
+              </a:spcAft>
+              <a:buClrTx/>
+              <a:buSzTx/>
+              <a:buFontTx/>
+              <a:buNone/>
+              <a:tabLst/>
+              <a:defRPr sz="2400" b="0" i="0" u="none" strike="noStrike" cap="none" spc="0" baseline="0">
+                <a:ln>
+                  <a:noFill/>
+                </a:ln>
+                <a:solidFill>
+                  <a:srgbClr val="868A8D"/>
+                </a:solidFill>
+                <a:uFillTx/>
+                <a:latin typeface="Montserrat Light"/>
+                <a:ea typeface="Montserrat Light"/>
+                <a:cs typeface="Montserrat Light"/>
+                <a:sym typeface="Montserrat Light"/>
+              </a:defRPr>
+            </a:lvl9pPr>
+          </a:lstStyle>
+          <a:p>
+            <a:pPr algn="l" hangingPunct="1">
+              <a:spcAft>
+                <a:spcPts val="1400"/>
+              </a:spcAft>
+            </a:pPr>
+            <a:r>
+              <a:rPr lang="es-CO" sz="3200" b="1" dirty="0">
+                <a:solidFill>
+                  <a:schemeClr val="accent6"/>
+                </a:solidFill>
+                <a:latin typeface="Century Gothic" panose="020B0502020202020204" pitchFamily="34" charset="0"/>
+                <a:cs typeface="Candara"/>
+              </a:rPr>
+              <a:t>•  Personas sensibilizadas por año.</a:t>
+            </a:r>
+          </a:p>
+          <a:p>
+            <a:pPr algn="l" hangingPunct="1">
+              <a:spcAft>
+                <a:spcPts val="1400"/>
+              </a:spcAft>
+            </a:pPr>
+            <a:r>
+              <a:rPr lang="es-CO" sz="3200" b="1" dirty="0">
+                <a:solidFill>
+                  <a:schemeClr val="accent6"/>
+                </a:solidFill>
+                <a:latin typeface="Century Gothic" panose="020B0502020202020204" pitchFamily="34" charset="0"/>
+                <a:cs typeface="Candara"/>
+              </a:rPr>
+              <a:t>•  Proyectos diagnosticados y acompañados por fase.</a:t>
+            </a:r>
+          </a:p>
+          <a:p>
+            <a:pPr algn="l" hangingPunct="1">
+              <a:spcAft>
+                <a:spcPts val="1400"/>
+              </a:spcAft>
+            </a:pPr>
+            <a:r>
+              <a:rPr lang="es-CO" sz="3200" b="1" dirty="0">
+                <a:solidFill>
+                  <a:schemeClr val="accent6"/>
+                </a:solidFill>
+                <a:latin typeface="Century Gothic" panose="020B0502020202020204" pitchFamily="34" charset="0"/>
+                <a:cs typeface="Candara"/>
+              </a:rPr>
+              <a:t>•  % de proyectos vigentes a 3 años (≥3% — meta PDI).</a:t>
+            </a:r>
+          </a:p>
+          <a:p>
+            <a:pPr algn="l" hangingPunct="1">
+              <a:spcAft>
+                <a:spcPts val="1400"/>
+              </a:spcAft>
+            </a:pPr>
+            <a:r>
+              <a:rPr lang="es-CO" sz="3200" b="1" dirty="0">
+                <a:solidFill>
+                  <a:schemeClr val="accent6"/>
+                </a:solidFill>
+                <a:latin typeface="Century Gothic" panose="020B0502020202020204" pitchFamily="34" charset="0"/>
+                <a:cs typeface="Candara"/>
+              </a:rPr>
+              <a:t>•  Títulos de propiedad intelectual y spin-offs.</a:t>
+            </a:r>
+          </a:p>
+          <a:p>
+            <a:pPr algn="l" hangingPunct="1">
+              <a:spcAft>
+                <a:spcPts val="1400"/>
+              </a:spcAft>
+            </a:pPr>
+            <a:r>
+              <a:rPr lang="es-CO" sz="3200" b="1" dirty="0">
+                <a:solidFill>
+                  <a:schemeClr val="accent6"/>
+                </a:solidFill>
+                <a:latin typeface="Century Gothic" panose="020B0502020202020204" pitchFamily="34" charset="0"/>
+                <a:cs typeface="Candara"/>
+              </a:rPr>
+              <a:t>•  Facultades con docente enlace activo.</a:t>
+            </a:r>
+          </a:p>
+        </p:txBody>
+      </p:sp>
+    </p:spTree>
+  </p:cSld>
+  <p:clrMapOvr>
+    <a:masterClrMapping/>
+  </p:clrMapOvr>
+</p:sld>
+</file>
+
+<file path=ppt/slides/slide33.xml><?xml version="1.0" encoding="utf-8"?>
+<p:sld xmlns:a="http://schemas.openxmlformats.org/drawingml/2006/main" xmlns:p="http://schemas.openxmlformats.org/presentationml/2006/main" xmlns:r="http://schemas.openxmlformats.org/officeDocument/2006/relationships">
+  <p:cSld>
+    <p:spTree>
+      <p:nvGrpSpPr>
+        <p:cNvPr id="1" name=""/>
+        <p:cNvGrpSpPr/>
+        <p:nvPr/>
+      </p:nvGrpSpPr>
+      <p:grpSpPr/>
+      <p:sp>
+        <p:nvSpPr>
+          <p:cNvPr id="12" name="Rounded Rectangle 8"/>
+          <p:cNvSpPr/>
+          <p:nvPr/>
+        </p:nvSpPr>
+        <p:spPr>
+          <a:xfrm>
+            <a:off x="3017520" y="1097280"/>
+            <a:ext cx="18288000" cy="1737360"/>
+          </a:xfrm>
+          <a:prstGeom prst="roundRect">
+            <a:avLst>
+              <a:gd name="adj" fmla="val 50000"/>
+            </a:avLst>
+          </a:prstGeom>
+          <a:solidFill>
+            <a:srgbClr val="D07137"/>
+          </a:solidFill>
+          <a:ln>
+            <a:noFill/>
+          </a:ln>
+        </p:spPr>
+        <p:style>
+          <a:lnRef idx="2">
+            <a:schemeClr val="accent1">
+              <a:shade val="50000"/>
+            </a:schemeClr>
+          </a:lnRef>
+          <a:fillRef idx="1">
+            <a:schemeClr val="accent1"/>
+          </a:fillRef>
+          <a:effectRef idx="0">
+            <a:schemeClr val="accent1"/>
+          </a:effectRef>
+          <a:fontRef idx="minor">
+            <a:schemeClr val="lt1"/>
+          </a:fontRef>
+        </p:style>
+        <p:txBody>
+          <a:bodyPr rtlCol="0" anchor="ctr"/>
+          <a:lstStyle/>
+          <a:p>
+            <a:pPr lvl="0" algn="ctr" defTabSz="914400" hangingPunct="1">
+              <a:lnSpc>
+                <a:spcPct val="100000"/>
+              </a:lnSpc>
+              <a:defRPr/>
+            </a:pPr>
+            <a:r>
               <a:rPr lang="pt-BR" sz="3400" b="1" kern="1200" dirty="0">
                 <a:ln w="0">
                   <a:noFill/>
@@ -11536,6 +12968,471 @@
                 <a:cs typeface="Candara"/>
               </a:rPr>
               <a:t>•  Difusión segmentada: correo institucional + WhatsApp.</a:t>
+            </a:r>
+          </a:p>
+        </p:txBody>
+      </p:sp>
+    </p:spTree>
+  </p:cSld>
+  <p:clrMapOvr>
+    <a:masterClrMapping/>
+  </p:clrMapOvr>
+</p:sld>
+</file>
+
+<file path=ppt/slides/slide34.xml><?xml version="1.0" encoding="utf-8"?>
+<p:sld xmlns:a="http://schemas.openxmlformats.org/drawingml/2006/main" xmlns:p="http://schemas.openxmlformats.org/presentationml/2006/main" xmlns:r="http://schemas.openxmlformats.org/officeDocument/2006/relationships">
+  <p:cSld>
+    <p:spTree>
+      <p:nvGrpSpPr>
+        <p:cNvPr id="1" name=""/>
+        <p:cNvGrpSpPr/>
+        <p:nvPr/>
+      </p:nvGrpSpPr>
+      <p:grpSpPr/>
+      <p:sp>
+        <p:nvSpPr>
+          <p:cNvPr id="12" name="Rounded Rectangle 8"/>
+          <p:cNvSpPr/>
+          <p:nvPr/>
+        </p:nvSpPr>
+        <p:spPr>
+          <a:xfrm>
+            <a:off x="3017520" y="1097280"/>
+            <a:ext cx="18288000" cy="1737360"/>
+          </a:xfrm>
+          <a:prstGeom prst="roundRect">
+            <a:avLst>
+              <a:gd name="adj" fmla="val 50000"/>
+            </a:avLst>
+          </a:prstGeom>
+          <a:solidFill>
+            <a:srgbClr val="D07137"/>
+          </a:solidFill>
+          <a:ln>
+            <a:noFill/>
+          </a:ln>
+        </p:spPr>
+        <p:style>
+          <a:lnRef idx="2">
+            <a:schemeClr val="accent1">
+              <a:shade val="50000"/>
+            </a:schemeClr>
+          </a:lnRef>
+          <a:fillRef idx="1">
+            <a:schemeClr val="accent1"/>
+          </a:fillRef>
+          <a:effectRef idx="0">
+            <a:schemeClr val="accent1"/>
+          </a:effectRef>
+          <a:fontRef idx="minor">
+            <a:schemeClr val="lt1"/>
+          </a:fontRef>
+        </p:style>
+        <p:txBody>
+          <a:bodyPr rtlCol="0" anchor="ctr"/>
+          <a:lstStyle/>
+          <a:p>
+            <a:pPr lvl="0" algn="ctr" defTabSz="914400" hangingPunct="1">
+              <a:lnSpc>
+                <a:spcPct val="100000"/>
+              </a:lnSpc>
+              <a:defRPr/>
+            </a:pPr>
+            <a:r>
+              <a:rPr lang="pt-BR" sz="4000" b="1" kern="1200" dirty="0">
+                <a:ln w="0">
+                  <a:noFill/>
+                </a:ln>
+                <a:solidFill>
+                  <a:schemeClr val="tx1"/>
+                </a:solidFill>
+                <a:latin typeface="Century Gothic" panose="020B0502020202020204" pitchFamily="34" charset="0"/>
+              </a:rPr>
+              <a:t>¿Cómo acceder al CIE?</a:t>
+            </a:r>
+            <a:endParaRPr kumimoji="0" lang="en-US" sz="4800" b="0" i="0" u="none" strike="noStrike" kern="1200" cap="none" spc="0" normalizeH="0" baseline="0" noProof="0" dirty="0">
+              <a:ln>
+                <a:noFill/>
+              </a:ln>
+              <a:solidFill>
+                <a:schemeClr val="tx1"/>
+              </a:solidFill>
+              <a:effectLst/>
+              <a:uLnTx/>
+              <a:uFillTx/>
+              <a:latin typeface="Lato Black" panose="020F0A02020204030203" pitchFamily="34" charset="0"/>
+            </a:endParaRPr>
+          </a:p>
+        </p:txBody>
+      </p:sp>
+      <p:sp>
+        <p:nvSpPr>
+          <p:cNvPr id="13" name="Google Shape;139;p19"/>
+          <p:cNvSpPr txBox="1">
+            <a:spLocks/>
+          </p:cNvSpPr>
+          <p:nvPr/>
+        </p:nvSpPr>
+        <p:spPr>
+          <a:xfrm>
+            <a:off x="2194560" y="3657600"/>
+            <a:ext cx="19933920" cy="7863840"/>
+          </a:xfrm>
+          <a:prstGeom prst="rect">
+            <a:avLst/>
+          </a:prstGeom>
+        </p:spPr>
+        <p:txBody>
+          <a:bodyPr spcFirstLastPara="1" wrap="square" lIns="91425" tIns="91425" rIns="91425" bIns="91425" anchor="t" anchorCtr="0">
+            <a:noAutofit/>
+          </a:bodyPr>
+          <a:lstStyle>
+            <a:lvl1pPr marL="0" marR="0" indent="0" algn="just" defTabSz="825500" rtl="0" latinLnBrk="0">
+              <a:lnSpc>
+                <a:spcPct val="120000"/>
+              </a:lnSpc>
+              <a:spcBef>
+                <a:spcPts val="0"/>
+              </a:spcBef>
+              <a:spcAft>
+                <a:spcPts val="0"/>
+              </a:spcAft>
+              <a:buClrTx/>
+              <a:buSzTx/>
+              <a:buFontTx/>
+              <a:buNone/>
+              <a:tabLst/>
+              <a:defRPr sz="2400" b="0" i="0" u="none" strike="noStrike" cap="none" spc="0" baseline="0">
+                <a:ln>
+                  <a:noFill/>
+                </a:ln>
+                <a:solidFill>
+                  <a:srgbClr val="868A8D"/>
+                </a:solidFill>
+                <a:uFillTx/>
+                <a:latin typeface="Montserrat Light"/>
+                <a:ea typeface="Montserrat Light"/>
+                <a:cs typeface="Montserrat Light"/>
+                <a:sym typeface="Montserrat Light"/>
+              </a:defRPr>
+            </a:lvl1pPr>
+            <a:lvl2pPr marL="0" marR="0" indent="228600" algn="just" defTabSz="825500" rtl="0" latinLnBrk="0">
+              <a:lnSpc>
+                <a:spcPct val="120000"/>
+              </a:lnSpc>
+              <a:spcBef>
+                <a:spcPts val="0"/>
+              </a:spcBef>
+              <a:spcAft>
+                <a:spcPts val="0"/>
+              </a:spcAft>
+              <a:buClrTx/>
+              <a:buSzTx/>
+              <a:buFontTx/>
+              <a:buNone/>
+              <a:tabLst/>
+              <a:defRPr sz="2400" b="0" i="0" u="none" strike="noStrike" cap="none" spc="0" baseline="0">
+                <a:ln>
+                  <a:noFill/>
+                </a:ln>
+                <a:solidFill>
+                  <a:srgbClr val="868A8D"/>
+                </a:solidFill>
+                <a:uFillTx/>
+                <a:latin typeface="Montserrat Light"/>
+                <a:ea typeface="Montserrat Light"/>
+                <a:cs typeface="Montserrat Light"/>
+                <a:sym typeface="Montserrat Light"/>
+              </a:defRPr>
+            </a:lvl2pPr>
+            <a:lvl3pPr marL="0" marR="0" indent="457200" algn="just" defTabSz="825500" rtl="0" latinLnBrk="0">
+              <a:lnSpc>
+                <a:spcPct val="120000"/>
+              </a:lnSpc>
+              <a:spcBef>
+                <a:spcPts val="0"/>
+              </a:spcBef>
+              <a:spcAft>
+                <a:spcPts val="0"/>
+              </a:spcAft>
+              <a:buClrTx/>
+              <a:buSzTx/>
+              <a:buFontTx/>
+              <a:buNone/>
+              <a:tabLst/>
+              <a:defRPr sz="2400" b="0" i="0" u="none" strike="noStrike" cap="none" spc="0" baseline="0">
+                <a:ln>
+                  <a:noFill/>
+                </a:ln>
+                <a:solidFill>
+                  <a:srgbClr val="868A8D"/>
+                </a:solidFill>
+                <a:uFillTx/>
+                <a:latin typeface="Montserrat Light"/>
+                <a:ea typeface="Montserrat Light"/>
+                <a:cs typeface="Montserrat Light"/>
+                <a:sym typeface="Montserrat Light"/>
+              </a:defRPr>
+            </a:lvl3pPr>
+            <a:lvl4pPr marL="0" marR="0" indent="685800" algn="just" defTabSz="825500" rtl="0" latinLnBrk="0">
+              <a:lnSpc>
+                <a:spcPct val="120000"/>
+              </a:lnSpc>
+              <a:spcBef>
+                <a:spcPts val="0"/>
+              </a:spcBef>
+              <a:spcAft>
+                <a:spcPts val="0"/>
+              </a:spcAft>
+              <a:buClrTx/>
+              <a:buSzTx/>
+              <a:buFontTx/>
+              <a:buNone/>
+              <a:tabLst/>
+              <a:defRPr sz="2400" b="0" i="0" u="none" strike="noStrike" cap="none" spc="0" baseline="0">
+                <a:ln>
+                  <a:noFill/>
+                </a:ln>
+                <a:solidFill>
+                  <a:srgbClr val="868A8D"/>
+                </a:solidFill>
+                <a:uFillTx/>
+                <a:latin typeface="Montserrat Light"/>
+                <a:ea typeface="Montserrat Light"/>
+                <a:cs typeface="Montserrat Light"/>
+                <a:sym typeface="Montserrat Light"/>
+              </a:defRPr>
+            </a:lvl4pPr>
+            <a:lvl5pPr marL="0" marR="0" indent="914400" algn="just" defTabSz="825500" rtl="0" latinLnBrk="0">
+              <a:lnSpc>
+                <a:spcPct val="120000"/>
+              </a:lnSpc>
+              <a:spcBef>
+                <a:spcPts val="0"/>
+              </a:spcBef>
+              <a:spcAft>
+                <a:spcPts val="0"/>
+              </a:spcAft>
+              <a:buClrTx/>
+              <a:buSzTx/>
+              <a:buFontTx/>
+              <a:buNone/>
+              <a:tabLst/>
+              <a:defRPr sz="2400" b="0" i="0" u="none" strike="noStrike" cap="none" spc="0" baseline="0">
+                <a:ln>
+                  <a:noFill/>
+                </a:ln>
+                <a:solidFill>
+                  <a:srgbClr val="868A8D"/>
+                </a:solidFill>
+                <a:uFillTx/>
+                <a:latin typeface="Montserrat Light"/>
+                <a:ea typeface="Montserrat Light"/>
+                <a:cs typeface="Montserrat Light"/>
+                <a:sym typeface="Montserrat Light"/>
+              </a:defRPr>
+            </a:lvl5pPr>
+            <a:lvl6pPr marL="0" marR="0" indent="1143000" algn="just" defTabSz="825500" rtl="0" latinLnBrk="0">
+              <a:lnSpc>
+                <a:spcPct val="120000"/>
+              </a:lnSpc>
+              <a:spcBef>
+                <a:spcPts val="0"/>
+              </a:spcBef>
+              <a:spcAft>
+                <a:spcPts val="0"/>
+              </a:spcAft>
+              <a:buClrTx/>
+              <a:buSzTx/>
+              <a:buFontTx/>
+              <a:buNone/>
+              <a:tabLst/>
+              <a:defRPr sz="2400" b="0" i="0" u="none" strike="noStrike" cap="none" spc="0" baseline="0">
+                <a:ln>
+                  <a:noFill/>
+                </a:ln>
+                <a:solidFill>
+                  <a:srgbClr val="868A8D"/>
+                </a:solidFill>
+                <a:uFillTx/>
+                <a:latin typeface="Montserrat Light"/>
+                <a:ea typeface="Montserrat Light"/>
+                <a:cs typeface="Montserrat Light"/>
+                <a:sym typeface="Montserrat Light"/>
+              </a:defRPr>
+            </a:lvl6pPr>
+            <a:lvl7pPr marL="0" marR="0" indent="1371600" algn="just" defTabSz="825500" rtl="0" latinLnBrk="0">
+              <a:lnSpc>
+                <a:spcPct val="120000"/>
+              </a:lnSpc>
+              <a:spcBef>
+                <a:spcPts val="0"/>
+              </a:spcBef>
+              <a:spcAft>
+                <a:spcPts val="0"/>
+              </a:spcAft>
+              <a:buClrTx/>
+              <a:buSzTx/>
+              <a:buFontTx/>
+              <a:buNone/>
+              <a:tabLst/>
+              <a:defRPr sz="2400" b="0" i="0" u="none" strike="noStrike" cap="none" spc="0" baseline="0">
+                <a:ln>
+                  <a:noFill/>
+                </a:ln>
+                <a:solidFill>
+                  <a:srgbClr val="868A8D"/>
+                </a:solidFill>
+                <a:uFillTx/>
+                <a:latin typeface="Montserrat Light"/>
+                <a:ea typeface="Montserrat Light"/>
+                <a:cs typeface="Montserrat Light"/>
+                <a:sym typeface="Montserrat Light"/>
+              </a:defRPr>
+            </a:lvl7pPr>
+            <a:lvl8pPr marL="0" marR="0" indent="1600200" algn="just" defTabSz="825500" rtl="0" latinLnBrk="0">
+              <a:lnSpc>
+                <a:spcPct val="120000"/>
+              </a:lnSpc>
+              <a:spcBef>
+                <a:spcPts val="0"/>
+              </a:spcBef>
+              <a:spcAft>
+                <a:spcPts val="0"/>
+              </a:spcAft>
+              <a:buClrTx/>
+              <a:buSzTx/>
+              <a:buFontTx/>
+              <a:buNone/>
+              <a:tabLst/>
+              <a:defRPr sz="2400" b="0" i="0" u="none" strike="noStrike" cap="none" spc="0" baseline="0">
+                <a:ln>
+                  <a:noFill/>
+                </a:ln>
+                <a:solidFill>
+                  <a:srgbClr val="868A8D"/>
+                </a:solidFill>
+                <a:uFillTx/>
+                <a:latin typeface="Montserrat Light"/>
+                <a:ea typeface="Montserrat Light"/>
+                <a:cs typeface="Montserrat Light"/>
+                <a:sym typeface="Montserrat Light"/>
+              </a:defRPr>
+            </a:lvl8pPr>
+            <a:lvl9pPr marL="0" marR="0" indent="1828800" algn="just" defTabSz="825500" rtl="0" latinLnBrk="0">
+              <a:lnSpc>
+                <a:spcPct val="120000"/>
+              </a:lnSpc>
+              <a:spcBef>
+                <a:spcPts val="0"/>
+              </a:spcBef>
+              <a:spcAft>
+                <a:spcPts val="0"/>
+              </a:spcAft>
+              <a:buClrTx/>
+              <a:buSzTx/>
+              <a:buFontTx/>
+              <a:buNone/>
+              <a:tabLst/>
+              <a:defRPr sz="2400" b="0" i="0" u="none" strike="noStrike" cap="none" spc="0" baseline="0">
+                <a:ln>
+                  <a:noFill/>
+                </a:ln>
+                <a:solidFill>
+                  <a:srgbClr val="868A8D"/>
+                </a:solidFill>
+                <a:uFillTx/>
+                <a:latin typeface="Montserrat Light"/>
+                <a:ea typeface="Montserrat Light"/>
+                <a:cs typeface="Montserrat Light"/>
+                <a:sym typeface="Montserrat Light"/>
+              </a:defRPr>
+            </a:lvl9pPr>
+          </a:lstStyle>
+          <a:p>
+            <a:pPr algn="l" hangingPunct="1">
+              <a:spcAft>
+                <a:spcPts val="1400"/>
+              </a:spcAft>
+            </a:pPr>
+            <a:r>
+              <a:rPr lang="es-CO" sz="3000" b="1" dirty="0">
+                <a:solidFill>
+                  <a:schemeClr val="accent6"/>
+                </a:solidFill>
+                <a:latin typeface="Century Gothic" panose="020B0502020202020204" pitchFamily="34" charset="0"/>
+                <a:cs typeface="Candara"/>
+              </a:rPr>
+              <a:t>•  Acércate al Centro de Innovación y Emprendimiento (CIE).</a:t>
+            </a:r>
+          </a:p>
+          <a:p>
+            <a:pPr algn="l" hangingPunct="1">
+              <a:spcAft>
+                <a:spcPts val="1400"/>
+              </a:spcAft>
+            </a:pPr>
+            <a:r>
+              <a:rPr lang="es-CO" sz="3000" b="1" dirty="0">
+                <a:solidFill>
+                  <a:schemeClr val="accent6"/>
+                </a:solidFill>
+                <a:latin typeface="Century Gothic" panose="020B0502020202020204" pitchFamily="34" charset="0"/>
+                <a:cs typeface="Candara"/>
+              </a:rPr>
+              <a:t>•  Mantente atento a las convocatorias y actividades (correo institucional y WhatsApp).</a:t>
+            </a:r>
+          </a:p>
+          <a:p>
+            <a:pPr algn="l" hangingPunct="1">
+              <a:spcAft>
+                <a:spcPts val="1400"/>
+              </a:spcAft>
+            </a:pPr>
+            <a:r>
+              <a:rPr lang="es-CO" sz="3000" b="1" dirty="0">
+                <a:solidFill>
+                  <a:schemeClr val="accent6"/>
+                </a:solidFill>
+                <a:latin typeface="Century Gothic" panose="020B0502020202020204" pitchFamily="34" charset="0"/>
+                <a:cs typeface="Candara"/>
+              </a:rPr>
+              <a:t>•  Consulta al docente enlace de tu facultad.</a:t>
+            </a:r>
+          </a:p>
+          <a:p>
+            <a:pPr algn="l" hangingPunct="1">
+              <a:spcAft>
+                <a:spcPts val="1400"/>
+              </a:spcAft>
+            </a:pPr>
+            <a:r>
+              <a:rPr lang="es-CO" sz="3000" b="1" dirty="0">
+                <a:solidFill>
+                  <a:schemeClr val="accent6"/>
+                </a:solidFill>
+                <a:latin typeface="Century Gothic" panose="020B0502020202020204" pitchFamily="34" charset="0"/>
+                <a:cs typeface="Candara"/>
+              </a:rPr>
+              <a:t>•  Inscribe tu idea: el CIE la ubicará en la fase según su nivel de madurez.</a:t>
+            </a:r>
+          </a:p>
+          <a:p>
+            <a:pPr algn="l" hangingPunct="1">
+              <a:spcAft>
+                <a:spcPts val="1400"/>
+              </a:spcAft>
+            </a:pPr>
+            <a:r>
+              <a:rPr lang="es-CO" sz="3000" b="1" dirty="0">
+                <a:solidFill>
+                  <a:schemeClr val="accent6"/>
+                </a:solidFill>
+                <a:latin typeface="Century Gothic" panose="020B0502020202020204" pitchFamily="34" charset="0"/>
+                <a:cs typeface="Candara"/>
+              </a:rPr>
+              <a:t>•  Contacto oficial: [completar con el correo y teléfono del CIE].</a:t>
             </a:r>
           </a:p>
         </p:txBody>

</xml_diff>

<commit_message>
Ruta (Word y PPT): 3 componentes transversales, red de mentores y actividades conjuntas (alineado al informe)
</commit_message>
<xml_diff>
--- a/Ruta-Emprendimiento-CIE.pptx
+++ b/Ruta-Emprendimiento-CIE.pptx
@@ -20,15 +20,16 @@
     <p:sldId id="651" r:id="rId30"/>
     <p:sldId id="652" r:id="rId31"/>
     <p:sldId id="660" r:id="rId39"/>
+    <p:sldId id="661" r:id="rId40"/>
     <p:sldId id="653" r:id="rId32"/>
     <p:sldId id="654" r:id="rId33"/>
     <p:sldId id="655" r:id="rId34"/>
     <p:sldId id="656" r:id="rId35"/>
     <p:sldId id="657" r:id="rId36"/>
     <p:sldId id="658" r:id="rId37"/>
-    <p:sldId id="661" r:id="rId40"/>
     <p:sldId id="662" r:id="rId41"/>
     <p:sldId id="663" r:id="rId42"/>
+    <p:sldId id="664" r:id="rId43"/>
     <p:sldId id="580" r:id="rId18"/>
   </p:sldIdLst>
   <p:sldSz cx="24384000" cy="13716000"/>
@@ -7318,7 +7319,7 @@
                 <a:latin typeface="Century Gothic" panose="020B0502020202020204" pitchFamily="34" charset="0"/>
                 <a:cs typeface="Candara"/>
               </a:rPr>
-              <a:t>•  Mentores multidisciplinarios: docentes, empresarios y egresados.</a:t>
+              <a:t>•  Red de mentores multidisciplinarios: docentes, empresarios y egresados.</a:t>
             </a:r>
           </a:p>
           <a:p>
@@ -7467,8 +7468,8 @@
         </p:blipFill>
         <p:spPr>
           <a:xfrm>
-            <a:off x="4062610" y="3840480"/>
-            <a:ext cx="16261828" cy="7863840"/>
+            <a:off x="5159708" y="3840480"/>
+            <a:ext cx="14067631" cy="7863840"/>
           </a:xfrm>
           <a:prstGeom prst="rect">
             <a:avLst/>
@@ -9702,7 +9703,7 @@
                 </a:solidFill>
                 <a:latin typeface="Century Gothic"/>
               </a:rPr>
-              <a:t>CIE, mentores y docentes enlace.</a:t>
+              <a:t>CIE, red de mentores y docentes enlace.</a:t>
             </a:r>
           </a:p>
           <a:p>
@@ -10286,7 +10287,7 @@
                 </a:solidFill>
                 <a:latin typeface="Century Gothic"/>
               </a:rPr>
-              <a:t>mentores multidisciplinarios y aliados.</a:t>
+              <a:t>red de mentores multidisciplinarios y aliados.</a:t>
             </a:r>
           </a:p>
           <a:p>
@@ -11456,629 +11457,6 @@
       <p:grpSpPr/>
       <p:sp>
         <p:nvSpPr>
-          <p:cNvPr id="2" name="Google Shape;234;p28"/>
-          <p:cNvSpPr txBox="1">
-            <a:spLocks/>
-          </p:cNvSpPr>
-          <p:nvPr/>
-        </p:nvSpPr>
-        <p:spPr>
-          <a:xfrm>
-            <a:off x="3731714" y="4777893"/>
-            <a:ext cx="16341340" cy="2192170"/>
-          </a:xfrm>
-          <a:prstGeom prst="rect">
-            <a:avLst/>
-          </a:prstGeom>
-        </p:spPr>
-        <p:txBody>
-          <a:bodyPr spcFirstLastPara="1" wrap="square" lIns="91425" tIns="91425" rIns="91425" bIns="91425" anchor="b" anchorCtr="0">
-            <a:noAutofit/>
-          </a:bodyPr>
-          <a:lstStyle>
-            <a:lvl1pPr marL="0" marR="0" indent="0" algn="l" defTabSz="825500" rtl="0" latinLnBrk="0">
-              <a:lnSpc>
-                <a:spcPct val="80000"/>
-              </a:lnSpc>
-              <a:spcBef>
-                <a:spcPts val="0"/>
-              </a:spcBef>
-              <a:spcAft>
-                <a:spcPts val="0"/>
-              </a:spcAft>
-              <a:buClrTx/>
-              <a:buSzTx/>
-              <a:buFontTx/>
-              <a:buNone/>
-              <a:tabLst/>
-              <a:defRPr sz="9600" b="0" i="0" u="none" strike="noStrike" cap="all" spc="0" baseline="12500">
-                <a:ln>
-                  <a:noFill/>
-                </a:ln>
-                <a:solidFill>
-                  <a:srgbClr val="17222C"/>
-                </a:solidFill>
-                <a:uFillTx/>
-                <a:latin typeface="+mn-lt"/>
-                <a:ea typeface="+mn-ea"/>
-                <a:cs typeface="+mn-cs"/>
-                <a:sym typeface="Montserrat-Bold"/>
-              </a:defRPr>
-            </a:lvl1pPr>
-            <a:lvl2pPr marL="0" marR="0" indent="228600" algn="l" defTabSz="825500" rtl="0" latinLnBrk="0">
-              <a:lnSpc>
-                <a:spcPct val="80000"/>
-              </a:lnSpc>
-              <a:spcBef>
-                <a:spcPts val="0"/>
-              </a:spcBef>
-              <a:spcAft>
-                <a:spcPts val="0"/>
-              </a:spcAft>
-              <a:buClrTx/>
-              <a:buSzTx/>
-              <a:buFontTx/>
-              <a:buNone/>
-              <a:tabLst/>
-              <a:defRPr sz="9600" b="0" i="0" u="none" strike="noStrike" cap="all" spc="0" baseline="12500">
-                <a:ln>
-                  <a:noFill/>
-                </a:ln>
-                <a:solidFill>
-                  <a:srgbClr val="17222C"/>
-                </a:solidFill>
-                <a:uFillTx/>
-                <a:latin typeface="+mn-lt"/>
-                <a:ea typeface="+mn-ea"/>
-                <a:cs typeface="+mn-cs"/>
-                <a:sym typeface="Montserrat-Bold"/>
-              </a:defRPr>
-            </a:lvl2pPr>
-            <a:lvl3pPr marL="0" marR="0" indent="457200" algn="l" defTabSz="825500" rtl="0" latinLnBrk="0">
-              <a:lnSpc>
-                <a:spcPct val="80000"/>
-              </a:lnSpc>
-              <a:spcBef>
-                <a:spcPts val="0"/>
-              </a:spcBef>
-              <a:spcAft>
-                <a:spcPts val="0"/>
-              </a:spcAft>
-              <a:buClrTx/>
-              <a:buSzTx/>
-              <a:buFontTx/>
-              <a:buNone/>
-              <a:tabLst/>
-              <a:defRPr sz="9600" b="0" i="0" u="none" strike="noStrike" cap="all" spc="0" baseline="12500">
-                <a:ln>
-                  <a:noFill/>
-                </a:ln>
-                <a:solidFill>
-                  <a:srgbClr val="17222C"/>
-                </a:solidFill>
-                <a:uFillTx/>
-                <a:latin typeface="+mn-lt"/>
-                <a:ea typeface="+mn-ea"/>
-                <a:cs typeface="+mn-cs"/>
-                <a:sym typeface="Montserrat-Bold"/>
-              </a:defRPr>
-            </a:lvl3pPr>
-            <a:lvl4pPr marL="0" marR="0" indent="685800" algn="l" defTabSz="825500" rtl="0" latinLnBrk="0">
-              <a:lnSpc>
-                <a:spcPct val="80000"/>
-              </a:lnSpc>
-              <a:spcBef>
-                <a:spcPts val="0"/>
-              </a:spcBef>
-              <a:spcAft>
-                <a:spcPts val="0"/>
-              </a:spcAft>
-              <a:buClrTx/>
-              <a:buSzTx/>
-              <a:buFontTx/>
-              <a:buNone/>
-              <a:tabLst/>
-              <a:defRPr sz="9600" b="0" i="0" u="none" strike="noStrike" cap="all" spc="0" baseline="12500">
-                <a:ln>
-                  <a:noFill/>
-                </a:ln>
-                <a:solidFill>
-                  <a:srgbClr val="17222C"/>
-                </a:solidFill>
-                <a:uFillTx/>
-                <a:latin typeface="+mn-lt"/>
-                <a:ea typeface="+mn-ea"/>
-                <a:cs typeface="+mn-cs"/>
-                <a:sym typeface="Montserrat-Bold"/>
-              </a:defRPr>
-            </a:lvl4pPr>
-            <a:lvl5pPr marL="0" marR="0" indent="914400" algn="l" defTabSz="825500" rtl="0" latinLnBrk="0">
-              <a:lnSpc>
-                <a:spcPct val="80000"/>
-              </a:lnSpc>
-              <a:spcBef>
-                <a:spcPts val="0"/>
-              </a:spcBef>
-              <a:spcAft>
-                <a:spcPts val="0"/>
-              </a:spcAft>
-              <a:buClrTx/>
-              <a:buSzTx/>
-              <a:buFontTx/>
-              <a:buNone/>
-              <a:tabLst/>
-              <a:defRPr sz="9600" b="0" i="0" u="none" strike="noStrike" cap="all" spc="0" baseline="12500">
-                <a:ln>
-                  <a:noFill/>
-                </a:ln>
-                <a:solidFill>
-                  <a:srgbClr val="17222C"/>
-                </a:solidFill>
-                <a:uFillTx/>
-                <a:latin typeface="+mn-lt"/>
-                <a:ea typeface="+mn-ea"/>
-                <a:cs typeface="+mn-cs"/>
-                <a:sym typeface="Montserrat-Bold"/>
-              </a:defRPr>
-            </a:lvl5pPr>
-            <a:lvl6pPr marL="0" marR="0" indent="1143000" algn="l" defTabSz="825500" rtl="0" latinLnBrk="0">
-              <a:lnSpc>
-                <a:spcPct val="80000"/>
-              </a:lnSpc>
-              <a:spcBef>
-                <a:spcPts val="0"/>
-              </a:spcBef>
-              <a:spcAft>
-                <a:spcPts val="0"/>
-              </a:spcAft>
-              <a:buClrTx/>
-              <a:buSzTx/>
-              <a:buFontTx/>
-              <a:buNone/>
-              <a:tabLst/>
-              <a:defRPr sz="9600" b="0" i="0" u="none" strike="noStrike" cap="all" spc="0" baseline="12500">
-                <a:ln>
-                  <a:noFill/>
-                </a:ln>
-                <a:solidFill>
-                  <a:srgbClr val="17222C"/>
-                </a:solidFill>
-                <a:uFillTx/>
-                <a:latin typeface="+mn-lt"/>
-                <a:ea typeface="+mn-ea"/>
-                <a:cs typeface="+mn-cs"/>
-                <a:sym typeface="Montserrat-Bold"/>
-              </a:defRPr>
-            </a:lvl6pPr>
-            <a:lvl7pPr marL="0" marR="0" indent="1371600" algn="l" defTabSz="825500" rtl="0" latinLnBrk="0">
-              <a:lnSpc>
-                <a:spcPct val="80000"/>
-              </a:lnSpc>
-              <a:spcBef>
-                <a:spcPts val="0"/>
-              </a:spcBef>
-              <a:spcAft>
-                <a:spcPts val="0"/>
-              </a:spcAft>
-              <a:buClrTx/>
-              <a:buSzTx/>
-              <a:buFontTx/>
-              <a:buNone/>
-              <a:tabLst/>
-              <a:defRPr sz="9600" b="0" i="0" u="none" strike="noStrike" cap="all" spc="0" baseline="12500">
-                <a:ln>
-                  <a:noFill/>
-                </a:ln>
-                <a:solidFill>
-                  <a:srgbClr val="17222C"/>
-                </a:solidFill>
-                <a:uFillTx/>
-                <a:latin typeface="+mn-lt"/>
-                <a:ea typeface="+mn-ea"/>
-                <a:cs typeface="+mn-cs"/>
-                <a:sym typeface="Montserrat-Bold"/>
-              </a:defRPr>
-            </a:lvl7pPr>
-            <a:lvl8pPr marL="0" marR="0" indent="1600200" algn="l" defTabSz="825500" rtl="0" latinLnBrk="0">
-              <a:lnSpc>
-                <a:spcPct val="80000"/>
-              </a:lnSpc>
-              <a:spcBef>
-                <a:spcPts val="0"/>
-              </a:spcBef>
-              <a:spcAft>
-                <a:spcPts val="0"/>
-              </a:spcAft>
-              <a:buClrTx/>
-              <a:buSzTx/>
-              <a:buFontTx/>
-              <a:buNone/>
-              <a:tabLst/>
-              <a:defRPr sz="9600" b="0" i="0" u="none" strike="noStrike" cap="all" spc="0" baseline="12500">
-                <a:ln>
-                  <a:noFill/>
-                </a:ln>
-                <a:solidFill>
-                  <a:srgbClr val="17222C"/>
-                </a:solidFill>
-                <a:uFillTx/>
-                <a:latin typeface="+mn-lt"/>
-                <a:ea typeface="+mn-ea"/>
-                <a:cs typeface="+mn-cs"/>
-                <a:sym typeface="Montserrat-Bold"/>
-              </a:defRPr>
-            </a:lvl8pPr>
-            <a:lvl9pPr marL="0" marR="0" indent="1828800" algn="l" defTabSz="825500" rtl="0" latinLnBrk="0">
-              <a:lnSpc>
-                <a:spcPct val="80000"/>
-              </a:lnSpc>
-              <a:spcBef>
-                <a:spcPts val="0"/>
-              </a:spcBef>
-              <a:spcAft>
-                <a:spcPts val="0"/>
-              </a:spcAft>
-              <a:buClrTx/>
-              <a:buSzTx/>
-              <a:buFontTx/>
-              <a:buNone/>
-              <a:tabLst/>
-              <a:defRPr sz="9600" b="0" i="0" u="none" strike="noStrike" cap="all" spc="0" baseline="12500">
-                <a:ln>
-                  <a:noFill/>
-                </a:ln>
-                <a:solidFill>
-                  <a:srgbClr val="17222C"/>
-                </a:solidFill>
-                <a:uFillTx/>
-                <a:latin typeface="+mn-lt"/>
-                <a:ea typeface="+mn-ea"/>
-                <a:cs typeface="+mn-cs"/>
-                <a:sym typeface="Montserrat-Bold"/>
-              </a:defRPr>
-            </a:lvl9pPr>
-          </a:lstStyle>
-          <a:p>
-            <a:pPr algn="ctr" hangingPunct="1">
-              <a:lnSpc>
-                <a:spcPct val="100000"/>
-              </a:lnSpc>
-            </a:pPr>
-            <a:r>
-              <a:rPr lang="es-CO" b="1" dirty="0" sz="6000">
-                <a:solidFill>
-                  <a:schemeClr val="tx1"/>
-                </a:solidFill>
-                <a:latin typeface="Century Gothic" panose="020B0502020202020204" pitchFamily="34" charset="0"/>
-                <a:cs typeface="Candara"/>
-              </a:rPr>
-              <a:t>Las 6 fases de la ruta</a:t>
-            </a:r>
-          </a:p>
-        </p:txBody>
-      </p:sp>
-      <p:sp>
-        <p:nvSpPr>
-          <p:cNvPr id="3" name="Google Shape;235;p28"/>
-          <p:cNvSpPr txBox="1">
-            <a:spLocks/>
-          </p:cNvSpPr>
-          <p:nvPr/>
-        </p:nvSpPr>
-        <p:spPr>
-          <a:xfrm>
-            <a:off x="3387220" y="7842022"/>
-            <a:ext cx="17030329" cy="2267076"/>
-          </a:xfrm>
-          <a:prstGeom prst="rect">
-            <a:avLst/>
-          </a:prstGeom>
-        </p:spPr>
-        <p:txBody>
-          <a:bodyPr spcFirstLastPara="1" wrap="square" lIns="91425" tIns="91425" rIns="91425" bIns="91425" anchor="t" anchorCtr="0">
-            <a:noAutofit/>
-          </a:bodyPr>
-          <a:lstStyle>
-            <a:lvl1pPr marL="0" marR="0" indent="0" algn="just" defTabSz="825500" rtl="0" latinLnBrk="0">
-              <a:lnSpc>
-                <a:spcPct val="120000"/>
-              </a:lnSpc>
-              <a:spcBef>
-                <a:spcPts val="0"/>
-              </a:spcBef>
-              <a:spcAft>
-                <a:spcPts val="0"/>
-              </a:spcAft>
-              <a:buClrTx/>
-              <a:buSzTx/>
-              <a:buFontTx/>
-              <a:buNone/>
-              <a:tabLst/>
-              <a:defRPr sz="2400" b="0" i="0" u="none" strike="noStrike" cap="none" spc="0" baseline="0">
-                <a:ln>
-                  <a:noFill/>
-                </a:ln>
-                <a:solidFill>
-                  <a:srgbClr val="868A8D"/>
-                </a:solidFill>
-                <a:uFillTx/>
-                <a:latin typeface="Montserrat Light"/>
-                <a:ea typeface="Montserrat Light"/>
-                <a:cs typeface="Montserrat Light"/>
-                <a:sym typeface="Montserrat Light"/>
-              </a:defRPr>
-            </a:lvl1pPr>
-            <a:lvl2pPr marL="0" marR="0" indent="228600" algn="just" defTabSz="825500" rtl="0" latinLnBrk="0">
-              <a:lnSpc>
-                <a:spcPct val="120000"/>
-              </a:lnSpc>
-              <a:spcBef>
-                <a:spcPts val="0"/>
-              </a:spcBef>
-              <a:spcAft>
-                <a:spcPts val="0"/>
-              </a:spcAft>
-              <a:buClrTx/>
-              <a:buSzTx/>
-              <a:buFontTx/>
-              <a:buNone/>
-              <a:tabLst/>
-              <a:defRPr sz="2400" b="0" i="0" u="none" strike="noStrike" cap="none" spc="0" baseline="0">
-                <a:ln>
-                  <a:noFill/>
-                </a:ln>
-                <a:solidFill>
-                  <a:srgbClr val="868A8D"/>
-                </a:solidFill>
-                <a:uFillTx/>
-                <a:latin typeface="Montserrat Light"/>
-                <a:ea typeface="Montserrat Light"/>
-                <a:cs typeface="Montserrat Light"/>
-                <a:sym typeface="Montserrat Light"/>
-              </a:defRPr>
-            </a:lvl2pPr>
-            <a:lvl3pPr marL="0" marR="0" indent="457200" algn="just" defTabSz="825500" rtl="0" latinLnBrk="0">
-              <a:lnSpc>
-                <a:spcPct val="120000"/>
-              </a:lnSpc>
-              <a:spcBef>
-                <a:spcPts val="0"/>
-              </a:spcBef>
-              <a:spcAft>
-                <a:spcPts val="0"/>
-              </a:spcAft>
-              <a:buClrTx/>
-              <a:buSzTx/>
-              <a:buFontTx/>
-              <a:buNone/>
-              <a:tabLst/>
-              <a:defRPr sz="2400" b="0" i="0" u="none" strike="noStrike" cap="none" spc="0" baseline="0">
-                <a:ln>
-                  <a:noFill/>
-                </a:ln>
-                <a:solidFill>
-                  <a:srgbClr val="868A8D"/>
-                </a:solidFill>
-                <a:uFillTx/>
-                <a:latin typeface="Montserrat Light"/>
-                <a:ea typeface="Montserrat Light"/>
-                <a:cs typeface="Montserrat Light"/>
-                <a:sym typeface="Montserrat Light"/>
-              </a:defRPr>
-            </a:lvl3pPr>
-            <a:lvl4pPr marL="0" marR="0" indent="685800" algn="just" defTabSz="825500" rtl="0" latinLnBrk="0">
-              <a:lnSpc>
-                <a:spcPct val="120000"/>
-              </a:lnSpc>
-              <a:spcBef>
-                <a:spcPts val="0"/>
-              </a:spcBef>
-              <a:spcAft>
-                <a:spcPts val="0"/>
-              </a:spcAft>
-              <a:buClrTx/>
-              <a:buSzTx/>
-              <a:buFontTx/>
-              <a:buNone/>
-              <a:tabLst/>
-              <a:defRPr sz="2400" b="0" i="0" u="none" strike="noStrike" cap="none" spc="0" baseline="0">
-                <a:ln>
-                  <a:noFill/>
-                </a:ln>
-                <a:solidFill>
-                  <a:srgbClr val="868A8D"/>
-                </a:solidFill>
-                <a:uFillTx/>
-                <a:latin typeface="Montserrat Light"/>
-                <a:ea typeface="Montserrat Light"/>
-                <a:cs typeface="Montserrat Light"/>
-                <a:sym typeface="Montserrat Light"/>
-              </a:defRPr>
-            </a:lvl4pPr>
-            <a:lvl5pPr marL="0" marR="0" indent="914400" algn="just" defTabSz="825500" rtl="0" latinLnBrk="0">
-              <a:lnSpc>
-                <a:spcPct val="120000"/>
-              </a:lnSpc>
-              <a:spcBef>
-                <a:spcPts val="0"/>
-              </a:spcBef>
-              <a:spcAft>
-                <a:spcPts val="0"/>
-              </a:spcAft>
-              <a:buClrTx/>
-              <a:buSzTx/>
-              <a:buFontTx/>
-              <a:buNone/>
-              <a:tabLst/>
-              <a:defRPr sz="2400" b="0" i="0" u="none" strike="noStrike" cap="none" spc="0" baseline="0">
-                <a:ln>
-                  <a:noFill/>
-                </a:ln>
-                <a:solidFill>
-                  <a:srgbClr val="868A8D"/>
-                </a:solidFill>
-                <a:uFillTx/>
-                <a:latin typeface="Montserrat Light"/>
-                <a:ea typeface="Montserrat Light"/>
-                <a:cs typeface="Montserrat Light"/>
-                <a:sym typeface="Montserrat Light"/>
-              </a:defRPr>
-            </a:lvl5pPr>
-            <a:lvl6pPr marL="0" marR="0" indent="1143000" algn="just" defTabSz="825500" rtl="0" latinLnBrk="0">
-              <a:lnSpc>
-                <a:spcPct val="120000"/>
-              </a:lnSpc>
-              <a:spcBef>
-                <a:spcPts val="0"/>
-              </a:spcBef>
-              <a:spcAft>
-                <a:spcPts val="0"/>
-              </a:spcAft>
-              <a:buClrTx/>
-              <a:buSzTx/>
-              <a:buFontTx/>
-              <a:buNone/>
-              <a:tabLst/>
-              <a:defRPr sz="2400" b="0" i="0" u="none" strike="noStrike" cap="none" spc="0" baseline="0">
-                <a:ln>
-                  <a:noFill/>
-                </a:ln>
-                <a:solidFill>
-                  <a:srgbClr val="868A8D"/>
-                </a:solidFill>
-                <a:uFillTx/>
-                <a:latin typeface="Montserrat Light"/>
-                <a:ea typeface="Montserrat Light"/>
-                <a:cs typeface="Montserrat Light"/>
-                <a:sym typeface="Montserrat Light"/>
-              </a:defRPr>
-            </a:lvl6pPr>
-            <a:lvl7pPr marL="0" marR="0" indent="1371600" algn="just" defTabSz="825500" rtl="0" latinLnBrk="0">
-              <a:lnSpc>
-                <a:spcPct val="120000"/>
-              </a:lnSpc>
-              <a:spcBef>
-                <a:spcPts val="0"/>
-              </a:spcBef>
-              <a:spcAft>
-                <a:spcPts val="0"/>
-              </a:spcAft>
-              <a:buClrTx/>
-              <a:buSzTx/>
-              <a:buFontTx/>
-              <a:buNone/>
-              <a:tabLst/>
-              <a:defRPr sz="2400" b="0" i="0" u="none" strike="noStrike" cap="none" spc="0" baseline="0">
-                <a:ln>
-                  <a:noFill/>
-                </a:ln>
-                <a:solidFill>
-                  <a:srgbClr val="868A8D"/>
-                </a:solidFill>
-                <a:uFillTx/>
-                <a:latin typeface="Montserrat Light"/>
-                <a:ea typeface="Montserrat Light"/>
-                <a:cs typeface="Montserrat Light"/>
-                <a:sym typeface="Montserrat Light"/>
-              </a:defRPr>
-            </a:lvl7pPr>
-            <a:lvl8pPr marL="0" marR="0" indent="1600200" algn="just" defTabSz="825500" rtl="0" latinLnBrk="0">
-              <a:lnSpc>
-                <a:spcPct val="120000"/>
-              </a:lnSpc>
-              <a:spcBef>
-                <a:spcPts val="0"/>
-              </a:spcBef>
-              <a:spcAft>
-                <a:spcPts val="0"/>
-              </a:spcAft>
-              <a:buClrTx/>
-              <a:buSzTx/>
-              <a:buFontTx/>
-              <a:buNone/>
-              <a:tabLst/>
-              <a:defRPr sz="2400" b="0" i="0" u="none" strike="noStrike" cap="none" spc="0" baseline="0">
-                <a:ln>
-                  <a:noFill/>
-                </a:ln>
-                <a:solidFill>
-                  <a:srgbClr val="868A8D"/>
-                </a:solidFill>
-                <a:uFillTx/>
-                <a:latin typeface="Montserrat Light"/>
-                <a:ea typeface="Montserrat Light"/>
-                <a:cs typeface="Montserrat Light"/>
-                <a:sym typeface="Montserrat Light"/>
-              </a:defRPr>
-            </a:lvl8pPr>
-            <a:lvl9pPr marL="0" marR="0" indent="1828800" algn="just" defTabSz="825500" rtl="0" latinLnBrk="0">
-              <a:lnSpc>
-                <a:spcPct val="120000"/>
-              </a:lnSpc>
-              <a:spcBef>
-                <a:spcPts val="0"/>
-              </a:spcBef>
-              <a:spcAft>
-                <a:spcPts val="0"/>
-              </a:spcAft>
-              <a:buClrTx/>
-              <a:buSzTx/>
-              <a:buFontTx/>
-              <a:buNone/>
-              <a:tabLst/>
-              <a:defRPr sz="2400" b="0" i="0" u="none" strike="noStrike" cap="none" spc="0" baseline="0">
-                <a:ln>
-                  <a:noFill/>
-                </a:ln>
-                <a:solidFill>
-                  <a:srgbClr val="868A8D"/>
-                </a:solidFill>
-                <a:uFillTx/>
-                <a:latin typeface="Montserrat Light"/>
-                <a:ea typeface="Montserrat Light"/>
-                <a:cs typeface="Montserrat Light"/>
-                <a:sym typeface="Montserrat Light"/>
-              </a:defRPr>
-            </a:lvl9pPr>
-          </a:lstStyle>
-          <a:p>
-            <a:pPr marL="114300" algn="ctr" hangingPunct="1">
-              <a:lnSpc>
-                <a:spcPct val="100000"/>
-              </a:lnSpc>
-            </a:pPr>
-            <a:r>
-              <a:rPr lang="es-ES" sz="3000" dirty="0">
-                <a:solidFill>
-                  <a:schemeClr val="tx1"/>
-                </a:solidFill>
-                <a:latin typeface="Century Gothic" panose="020B0502020202020204" pitchFamily="34" charset="0"/>
-              </a:rPr>
-              <a:t>De la idea al mercado: un acompañamiento por etapas</a:t>
-            </a:r>
-          </a:p>
-        </p:txBody>
-      </p:sp>
-    </p:spTree>
-  </p:cSld>
-  <p:clrMapOvr>
-    <a:masterClrMapping/>
-  </p:clrMapOvr>
-</p:sld>
-</file>
-
-<file path=ppt/slides/slide32.xml><?xml version="1.0" encoding="utf-8"?>
-<p:sld xmlns:a="http://schemas.openxmlformats.org/drawingml/2006/main" xmlns:p="http://schemas.openxmlformats.org/presentationml/2006/main" xmlns:r="http://schemas.openxmlformats.org/officeDocument/2006/relationships">
-  <p:cSld>
-    <p:spTree>
-      <p:nvGrpSpPr>
-        <p:cNvPr id="1" name=""/>
-        <p:cNvGrpSpPr/>
-        <p:nvPr/>
-      </p:nvGrpSpPr>
-      <p:grpSpPr/>
-      <p:sp>
-        <p:nvSpPr>
           <p:cNvPr id="12" name="Rounded Rectangle 8"/>
           <p:cNvSpPr/>
           <p:nvPr/>
@@ -12127,7 +11505,7 @@
               <a:defRPr/>
             </a:pPr>
             <a:r>
-              <a:rPr lang="pt-BR" sz="4000" b="1" kern="1200" dirty="0">
+              <a:rPr lang="pt-BR" sz="3400" b="1" kern="1200" dirty="0">
                 <a:ln w="0">
                   <a:noFill/>
                 </a:ln>
@@ -12136,7 +11514,7 @@
                 </a:solidFill>
                 <a:latin typeface="Century Gothic" panose="020B0502020202020204" pitchFamily="34" charset="0"/>
               </a:rPr>
-              <a:t>Indicadores de seguimiento</a:t>
+              <a:t>Componentes transversales (T1 · T2 · T3)</a:t>
             </a:r>
             <a:endParaRPr kumimoji="0" lang="en-US" sz="4800" b="0" i="0" u="none" strike="noStrike" kern="1200" cap="none" spc="0" normalizeH="0" baseline="0" noProof="0" dirty="0">
               <a:ln>
@@ -12444,14 +11822,14 @@
               </a:spcAft>
             </a:pPr>
             <a:r>
-              <a:rPr lang="es-CO" sz="3200" b="1" dirty="0">
+              <a:rPr lang="es-CO" sz="3000" b="1" dirty="0">
                 <a:solidFill>
                   <a:schemeClr val="accent6"/>
                 </a:solidFill>
                 <a:latin typeface="Century Gothic" panose="020B0502020202020204" pitchFamily="34" charset="0"/>
                 <a:cs typeface="Candara"/>
               </a:rPr>
-              <a:t>•  Personas sensibilizadas por año.</a:t>
+              <a:t>•  T1. Comunicación: difusión por correo institucional y WhatsApp para elevar la visibilidad del CIE.</a:t>
             </a:r>
           </a:p>
           <a:p>
@@ -12461,14 +11839,14 @@
               </a:spcAft>
             </a:pPr>
             <a:r>
-              <a:rPr lang="es-CO" sz="3200" b="1" dirty="0">
+              <a:rPr lang="es-CO" sz="3000" b="1" dirty="0">
                 <a:solidFill>
                   <a:schemeClr val="accent6"/>
                 </a:solidFill>
                 <a:latin typeface="Century Gothic" panose="020B0502020202020204" pitchFamily="34" charset="0"/>
                 <a:cs typeface="Candara"/>
               </a:rPr>
-              <a:t>•  Proyectos diagnosticados y acompañados por fase.</a:t>
+              <a:t>•  T2. Seguimiento e indicadores: registro del avance y medición del impacto (meta PDI ≥ 3%).</a:t>
             </a:r>
           </a:p>
           <a:p>
@@ -12478,14 +11856,14 @@
               </a:spcAft>
             </a:pPr>
             <a:r>
-              <a:rPr lang="es-CO" sz="3200" b="1" dirty="0">
+              <a:rPr lang="es-CO" sz="3000" b="1" dirty="0">
                 <a:solidFill>
                   <a:schemeClr val="accent6"/>
                 </a:solidFill>
                 <a:latin typeface="Century Gothic" panose="020B0502020202020204" pitchFamily="34" charset="0"/>
                 <a:cs typeface="Candara"/>
               </a:rPr>
-              <a:t>•  % de proyectos vigentes a 3 años (≥3% — meta PDI).</a:t>
+              <a:t>•  T3. Articulación con las facultades: docente enlace y coordinación permanente.</a:t>
             </a:r>
           </a:p>
           <a:p>
@@ -12495,31 +11873,637 @@
               </a:spcAft>
             </a:pPr>
             <a:r>
-              <a:rPr lang="es-CO" sz="3200" b="1" dirty="0">
+              <a:rPr lang="es-CO" sz="3000" b="1" dirty="0">
                 <a:solidFill>
                   <a:schemeClr val="accent6"/>
                 </a:solidFill>
                 <a:latin typeface="Century Gothic" panose="020B0502020202020204" pitchFamily="34" charset="0"/>
                 <a:cs typeface="Candara"/>
               </a:rPr>
-              <a:t>•  Títulos de propiedad intelectual y spin-offs.</a:t>
+              <a:t>•  Acompañan las seis fases, de principio a fin.</a:t>
             </a:r>
           </a:p>
+        </p:txBody>
+      </p:sp>
+    </p:spTree>
+  </p:cSld>
+  <p:clrMapOvr>
+    <a:masterClrMapping/>
+  </p:clrMapOvr>
+</p:sld>
+</file>
+
+<file path=ppt/slides/slide32.xml><?xml version="1.0" encoding="utf-8"?>
+<p:sld xmlns:a="http://schemas.openxmlformats.org/drawingml/2006/main" xmlns:p="http://schemas.openxmlformats.org/presentationml/2006/main" xmlns:r="http://schemas.openxmlformats.org/officeDocument/2006/relationships">
+  <p:cSld>
+    <p:spTree>
+      <p:nvGrpSpPr>
+        <p:cNvPr id="1" name=""/>
+        <p:cNvGrpSpPr/>
+        <p:nvPr/>
+      </p:nvGrpSpPr>
+      <p:grpSpPr/>
+      <p:sp>
+        <p:nvSpPr>
+          <p:cNvPr id="2" name="Google Shape;234;p28"/>
+          <p:cNvSpPr txBox="1">
+            <a:spLocks/>
+          </p:cNvSpPr>
+          <p:nvPr/>
+        </p:nvSpPr>
+        <p:spPr>
+          <a:xfrm>
+            <a:off x="3731714" y="4777893"/>
+            <a:ext cx="16341340" cy="2192170"/>
+          </a:xfrm>
+          <a:prstGeom prst="rect">
+            <a:avLst/>
+          </a:prstGeom>
+        </p:spPr>
+        <p:txBody>
+          <a:bodyPr spcFirstLastPara="1" wrap="square" lIns="91425" tIns="91425" rIns="91425" bIns="91425" anchor="b" anchorCtr="0">
+            <a:noAutofit/>
+          </a:bodyPr>
+          <a:lstStyle>
+            <a:lvl1pPr marL="0" marR="0" indent="0" algn="l" defTabSz="825500" rtl="0" latinLnBrk="0">
+              <a:lnSpc>
+                <a:spcPct val="80000"/>
+              </a:lnSpc>
+              <a:spcBef>
+                <a:spcPts val="0"/>
+              </a:spcBef>
+              <a:spcAft>
+                <a:spcPts val="0"/>
+              </a:spcAft>
+              <a:buClrTx/>
+              <a:buSzTx/>
+              <a:buFontTx/>
+              <a:buNone/>
+              <a:tabLst/>
+              <a:defRPr sz="9600" b="0" i="0" u="none" strike="noStrike" cap="all" spc="0" baseline="12500">
+                <a:ln>
+                  <a:noFill/>
+                </a:ln>
+                <a:solidFill>
+                  <a:srgbClr val="17222C"/>
+                </a:solidFill>
+                <a:uFillTx/>
+                <a:latin typeface="+mn-lt"/>
+                <a:ea typeface="+mn-ea"/>
+                <a:cs typeface="+mn-cs"/>
+                <a:sym typeface="Montserrat-Bold"/>
+              </a:defRPr>
+            </a:lvl1pPr>
+            <a:lvl2pPr marL="0" marR="0" indent="228600" algn="l" defTabSz="825500" rtl="0" latinLnBrk="0">
+              <a:lnSpc>
+                <a:spcPct val="80000"/>
+              </a:lnSpc>
+              <a:spcBef>
+                <a:spcPts val="0"/>
+              </a:spcBef>
+              <a:spcAft>
+                <a:spcPts val="0"/>
+              </a:spcAft>
+              <a:buClrTx/>
+              <a:buSzTx/>
+              <a:buFontTx/>
+              <a:buNone/>
+              <a:tabLst/>
+              <a:defRPr sz="9600" b="0" i="0" u="none" strike="noStrike" cap="all" spc="0" baseline="12500">
+                <a:ln>
+                  <a:noFill/>
+                </a:ln>
+                <a:solidFill>
+                  <a:srgbClr val="17222C"/>
+                </a:solidFill>
+                <a:uFillTx/>
+                <a:latin typeface="+mn-lt"/>
+                <a:ea typeface="+mn-ea"/>
+                <a:cs typeface="+mn-cs"/>
+                <a:sym typeface="Montserrat-Bold"/>
+              </a:defRPr>
+            </a:lvl2pPr>
+            <a:lvl3pPr marL="0" marR="0" indent="457200" algn="l" defTabSz="825500" rtl="0" latinLnBrk="0">
+              <a:lnSpc>
+                <a:spcPct val="80000"/>
+              </a:lnSpc>
+              <a:spcBef>
+                <a:spcPts val="0"/>
+              </a:spcBef>
+              <a:spcAft>
+                <a:spcPts val="0"/>
+              </a:spcAft>
+              <a:buClrTx/>
+              <a:buSzTx/>
+              <a:buFontTx/>
+              <a:buNone/>
+              <a:tabLst/>
+              <a:defRPr sz="9600" b="0" i="0" u="none" strike="noStrike" cap="all" spc="0" baseline="12500">
+                <a:ln>
+                  <a:noFill/>
+                </a:ln>
+                <a:solidFill>
+                  <a:srgbClr val="17222C"/>
+                </a:solidFill>
+                <a:uFillTx/>
+                <a:latin typeface="+mn-lt"/>
+                <a:ea typeface="+mn-ea"/>
+                <a:cs typeface="+mn-cs"/>
+                <a:sym typeface="Montserrat-Bold"/>
+              </a:defRPr>
+            </a:lvl3pPr>
+            <a:lvl4pPr marL="0" marR="0" indent="685800" algn="l" defTabSz="825500" rtl="0" latinLnBrk="0">
+              <a:lnSpc>
+                <a:spcPct val="80000"/>
+              </a:lnSpc>
+              <a:spcBef>
+                <a:spcPts val="0"/>
+              </a:spcBef>
+              <a:spcAft>
+                <a:spcPts val="0"/>
+              </a:spcAft>
+              <a:buClrTx/>
+              <a:buSzTx/>
+              <a:buFontTx/>
+              <a:buNone/>
+              <a:tabLst/>
+              <a:defRPr sz="9600" b="0" i="0" u="none" strike="noStrike" cap="all" spc="0" baseline="12500">
+                <a:ln>
+                  <a:noFill/>
+                </a:ln>
+                <a:solidFill>
+                  <a:srgbClr val="17222C"/>
+                </a:solidFill>
+                <a:uFillTx/>
+                <a:latin typeface="+mn-lt"/>
+                <a:ea typeface="+mn-ea"/>
+                <a:cs typeface="+mn-cs"/>
+                <a:sym typeface="Montserrat-Bold"/>
+              </a:defRPr>
+            </a:lvl4pPr>
+            <a:lvl5pPr marL="0" marR="0" indent="914400" algn="l" defTabSz="825500" rtl="0" latinLnBrk="0">
+              <a:lnSpc>
+                <a:spcPct val="80000"/>
+              </a:lnSpc>
+              <a:spcBef>
+                <a:spcPts val="0"/>
+              </a:spcBef>
+              <a:spcAft>
+                <a:spcPts val="0"/>
+              </a:spcAft>
+              <a:buClrTx/>
+              <a:buSzTx/>
+              <a:buFontTx/>
+              <a:buNone/>
+              <a:tabLst/>
+              <a:defRPr sz="9600" b="0" i="0" u="none" strike="noStrike" cap="all" spc="0" baseline="12500">
+                <a:ln>
+                  <a:noFill/>
+                </a:ln>
+                <a:solidFill>
+                  <a:srgbClr val="17222C"/>
+                </a:solidFill>
+                <a:uFillTx/>
+                <a:latin typeface="+mn-lt"/>
+                <a:ea typeface="+mn-ea"/>
+                <a:cs typeface="+mn-cs"/>
+                <a:sym typeface="Montserrat-Bold"/>
+              </a:defRPr>
+            </a:lvl5pPr>
+            <a:lvl6pPr marL="0" marR="0" indent="1143000" algn="l" defTabSz="825500" rtl="0" latinLnBrk="0">
+              <a:lnSpc>
+                <a:spcPct val="80000"/>
+              </a:lnSpc>
+              <a:spcBef>
+                <a:spcPts val="0"/>
+              </a:spcBef>
+              <a:spcAft>
+                <a:spcPts val="0"/>
+              </a:spcAft>
+              <a:buClrTx/>
+              <a:buSzTx/>
+              <a:buFontTx/>
+              <a:buNone/>
+              <a:tabLst/>
+              <a:defRPr sz="9600" b="0" i="0" u="none" strike="noStrike" cap="all" spc="0" baseline="12500">
+                <a:ln>
+                  <a:noFill/>
+                </a:ln>
+                <a:solidFill>
+                  <a:srgbClr val="17222C"/>
+                </a:solidFill>
+                <a:uFillTx/>
+                <a:latin typeface="+mn-lt"/>
+                <a:ea typeface="+mn-ea"/>
+                <a:cs typeface="+mn-cs"/>
+                <a:sym typeface="Montserrat-Bold"/>
+              </a:defRPr>
+            </a:lvl6pPr>
+            <a:lvl7pPr marL="0" marR="0" indent="1371600" algn="l" defTabSz="825500" rtl="0" latinLnBrk="0">
+              <a:lnSpc>
+                <a:spcPct val="80000"/>
+              </a:lnSpc>
+              <a:spcBef>
+                <a:spcPts val="0"/>
+              </a:spcBef>
+              <a:spcAft>
+                <a:spcPts val="0"/>
+              </a:spcAft>
+              <a:buClrTx/>
+              <a:buSzTx/>
+              <a:buFontTx/>
+              <a:buNone/>
+              <a:tabLst/>
+              <a:defRPr sz="9600" b="0" i="0" u="none" strike="noStrike" cap="all" spc="0" baseline="12500">
+                <a:ln>
+                  <a:noFill/>
+                </a:ln>
+                <a:solidFill>
+                  <a:srgbClr val="17222C"/>
+                </a:solidFill>
+                <a:uFillTx/>
+                <a:latin typeface="+mn-lt"/>
+                <a:ea typeface="+mn-ea"/>
+                <a:cs typeface="+mn-cs"/>
+                <a:sym typeface="Montserrat-Bold"/>
+              </a:defRPr>
+            </a:lvl7pPr>
+            <a:lvl8pPr marL="0" marR="0" indent="1600200" algn="l" defTabSz="825500" rtl="0" latinLnBrk="0">
+              <a:lnSpc>
+                <a:spcPct val="80000"/>
+              </a:lnSpc>
+              <a:spcBef>
+                <a:spcPts val="0"/>
+              </a:spcBef>
+              <a:spcAft>
+                <a:spcPts val="0"/>
+              </a:spcAft>
+              <a:buClrTx/>
+              <a:buSzTx/>
+              <a:buFontTx/>
+              <a:buNone/>
+              <a:tabLst/>
+              <a:defRPr sz="9600" b="0" i="0" u="none" strike="noStrike" cap="all" spc="0" baseline="12500">
+                <a:ln>
+                  <a:noFill/>
+                </a:ln>
+                <a:solidFill>
+                  <a:srgbClr val="17222C"/>
+                </a:solidFill>
+                <a:uFillTx/>
+                <a:latin typeface="+mn-lt"/>
+                <a:ea typeface="+mn-ea"/>
+                <a:cs typeface="+mn-cs"/>
+                <a:sym typeface="Montserrat-Bold"/>
+              </a:defRPr>
+            </a:lvl8pPr>
+            <a:lvl9pPr marL="0" marR="0" indent="1828800" algn="l" defTabSz="825500" rtl="0" latinLnBrk="0">
+              <a:lnSpc>
+                <a:spcPct val="80000"/>
+              </a:lnSpc>
+              <a:spcBef>
+                <a:spcPts val="0"/>
+              </a:spcBef>
+              <a:spcAft>
+                <a:spcPts val="0"/>
+              </a:spcAft>
+              <a:buClrTx/>
+              <a:buSzTx/>
+              <a:buFontTx/>
+              <a:buNone/>
+              <a:tabLst/>
+              <a:defRPr sz="9600" b="0" i="0" u="none" strike="noStrike" cap="all" spc="0" baseline="12500">
+                <a:ln>
+                  <a:noFill/>
+                </a:ln>
+                <a:solidFill>
+                  <a:srgbClr val="17222C"/>
+                </a:solidFill>
+                <a:uFillTx/>
+                <a:latin typeface="+mn-lt"/>
+                <a:ea typeface="+mn-ea"/>
+                <a:cs typeface="+mn-cs"/>
+                <a:sym typeface="Montserrat-Bold"/>
+              </a:defRPr>
+            </a:lvl9pPr>
+          </a:lstStyle>
           <a:p>
-            <a:pPr algn="l" hangingPunct="1">
-              <a:spcAft>
-                <a:spcPts val="1400"/>
-              </a:spcAft>
+            <a:pPr algn="ctr" hangingPunct="1">
+              <a:lnSpc>
+                <a:spcPct val="100000"/>
+              </a:lnSpc>
             </a:pPr>
             <a:r>
-              <a:rPr lang="es-CO" sz="3200" b="1" dirty="0">
-                <a:solidFill>
-                  <a:schemeClr val="accent6"/>
+              <a:rPr lang="es-CO" b="1" dirty="0" sz="6000">
+                <a:solidFill>
+                  <a:schemeClr val="tx1"/>
                 </a:solidFill>
                 <a:latin typeface="Century Gothic" panose="020B0502020202020204" pitchFamily="34" charset="0"/>
                 <a:cs typeface="Candara"/>
               </a:rPr>
-              <a:t>•  Facultades con docente enlace activo.</a:t>
+              <a:t>Las 6 fases de la ruta</a:t>
+            </a:r>
+          </a:p>
+        </p:txBody>
+      </p:sp>
+      <p:sp>
+        <p:nvSpPr>
+          <p:cNvPr id="3" name="Google Shape;235;p28"/>
+          <p:cNvSpPr txBox="1">
+            <a:spLocks/>
+          </p:cNvSpPr>
+          <p:nvPr/>
+        </p:nvSpPr>
+        <p:spPr>
+          <a:xfrm>
+            <a:off x="3387220" y="7842022"/>
+            <a:ext cx="17030329" cy="2267076"/>
+          </a:xfrm>
+          <a:prstGeom prst="rect">
+            <a:avLst/>
+          </a:prstGeom>
+        </p:spPr>
+        <p:txBody>
+          <a:bodyPr spcFirstLastPara="1" wrap="square" lIns="91425" tIns="91425" rIns="91425" bIns="91425" anchor="t" anchorCtr="0">
+            <a:noAutofit/>
+          </a:bodyPr>
+          <a:lstStyle>
+            <a:lvl1pPr marL="0" marR="0" indent="0" algn="just" defTabSz="825500" rtl="0" latinLnBrk="0">
+              <a:lnSpc>
+                <a:spcPct val="120000"/>
+              </a:lnSpc>
+              <a:spcBef>
+                <a:spcPts val="0"/>
+              </a:spcBef>
+              <a:spcAft>
+                <a:spcPts val="0"/>
+              </a:spcAft>
+              <a:buClrTx/>
+              <a:buSzTx/>
+              <a:buFontTx/>
+              <a:buNone/>
+              <a:tabLst/>
+              <a:defRPr sz="2400" b="0" i="0" u="none" strike="noStrike" cap="none" spc="0" baseline="0">
+                <a:ln>
+                  <a:noFill/>
+                </a:ln>
+                <a:solidFill>
+                  <a:srgbClr val="868A8D"/>
+                </a:solidFill>
+                <a:uFillTx/>
+                <a:latin typeface="Montserrat Light"/>
+                <a:ea typeface="Montserrat Light"/>
+                <a:cs typeface="Montserrat Light"/>
+                <a:sym typeface="Montserrat Light"/>
+              </a:defRPr>
+            </a:lvl1pPr>
+            <a:lvl2pPr marL="0" marR="0" indent="228600" algn="just" defTabSz="825500" rtl="0" latinLnBrk="0">
+              <a:lnSpc>
+                <a:spcPct val="120000"/>
+              </a:lnSpc>
+              <a:spcBef>
+                <a:spcPts val="0"/>
+              </a:spcBef>
+              <a:spcAft>
+                <a:spcPts val="0"/>
+              </a:spcAft>
+              <a:buClrTx/>
+              <a:buSzTx/>
+              <a:buFontTx/>
+              <a:buNone/>
+              <a:tabLst/>
+              <a:defRPr sz="2400" b="0" i="0" u="none" strike="noStrike" cap="none" spc="0" baseline="0">
+                <a:ln>
+                  <a:noFill/>
+                </a:ln>
+                <a:solidFill>
+                  <a:srgbClr val="868A8D"/>
+                </a:solidFill>
+                <a:uFillTx/>
+                <a:latin typeface="Montserrat Light"/>
+                <a:ea typeface="Montserrat Light"/>
+                <a:cs typeface="Montserrat Light"/>
+                <a:sym typeface="Montserrat Light"/>
+              </a:defRPr>
+            </a:lvl2pPr>
+            <a:lvl3pPr marL="0" marR="0" indent="457200" algn="just" defTabSz="825500" rtl="0" latinLnBrk="0">
+              <a:lnSpc>
+                <a:spcPct val="120000"/>
+              </a:lnSpc>
+              <a:spcBef>
+                <a:spcPts val="0"/>
+              </a:spcBef>
+              <a:spcAft>
+                <a:spcPts val="0"/>
+              </a:spcAft>
+              <a:buClrTx/>
+              <a:buSzTx/>
+              <a:buFontTx/>
+              <a:buNone/>
+              <a:tabLst/>
+              <a:defRPr sz="2400" b="0" i="0" u="none" strike="noStrike" cap="none" spc="0" baseline="0">
+                <a:ln>
+                  <a:noFill/>
+                </a:ln>
+                <a:solidFill>
+                  <a:srgbClr val="868A8D"/>
+                </a:solidFill>
+                <a:uFillTx/>
+                <a:latin typeface="Montserrat Light"/>
+                <a:ea typeface="Montserrat Light"/>
+                <a:cs typeface="Montserrat Light"/>
+                <a:sym typeface="Montserrat Light"/>
+              </a:defRPr>
+            </a:lvl3pPr>
+            <a:lvl4pPr marL="0" marR="0" indent="685800" algn="just" defTabSz="825500" rtl="0" latinLnBrk="0">
+              <a:lnSpc>
+                <a:spcPct val="120000"/>
+              </a:lnSpc>
+              <a:spcBef>
+                <a:spcPts val="0"/>
+              </a:spcBef>
+              <a:spcAft>
+                <a:spcPts val="0"/>
+              </a:spcAft>
+              <a:buClrTx/>
+              <a:buSzTx/>
+              <a:buFontTx/>
+              <a:buNone/>
+              <a:tabLst/>
+              <a:defRPr sz="2400" b="0" i="0" u="none" strike="noStrike" cap="none" spc="0" baseline="0">
+                <a:ln>
+                  <a:noFill/>
+                </a:ln>
+                <a:solidFill>
+                  <a:srgbClr val="868A8D"/>
+                </a:solidFill>
+                <a:uFillTx/>
+                <a:latin typeface="Montserrat Light"/>
+                <a:ea typeface="Montserrat Light"/>
+                <a:cs typeface="Montserrat Light"/>
+                <a:sym typeface="Montserrat Light"/>
+              </a:defRPr>
+            </a:lvl4pPr>
+            <a:lvl5pPr marL="0" marR="0" indent="914400" algn="just" defTabSz="825500" rtl="0" latinLnBrk="0">
+              <a:lnSpc>
+                <a:spcPct val="120000"/>
+              </a:lnSpc>
+              <a:spcBef>
+                <a:spcPts val="0"/>
+              </a:spcBef>
+              <a:spcAft>
+                <a:spcPts val="0"/>
+              </a:spcAft>
+              <a:buClrTx/>
+              <a:buSzTx/>
+              <a:buFontTx/>
+              <a:buNone/>
+              <a:tabLst/>
+              <a:defRPr sz="2400" b="0" i="0" u="none" strike="noStrike" cap="none" spc="0" baseline="0">
+                <a:ln>
+                  <a:noFill/>
+                </a:ln>
+                <a:solidFill>
+                  <a:srgbClr val="868A8D"/>
+                </a:solidFill>
+                <a:uFillTx/>
+                <a:latin typeface="Montserrat Light"/>
+                <a:ea typeface="Montserrat Light"/>
+                <a:cs typeface="Montserrat Light"/>
+                <a:sym typeface="Montserrat Light"/>
+              </a:defRPr>
+            </a:lvl5pPr>
+            <a:lvl6pPr marL="0" marR="0" indent="1143000" algn="just" defTabSz="825500" rtl="0" latinLnBrk="0">
+              <a:lnSpc>
+                <a:spcPct val="120000"/>
+              </a:lnSpc>
+              <a:spcBef>
+                <a:spcPts val="0"/>
+              </a:spcBef>
+              <a:spcAft>
+                <a:spcPts val="0"/>
+              </a:spcAft>
+              <a:buClrTx/>
+              <a:buSzTx/>
+              <a:buFontTx/>
+              <a:buNone/>
+              <a:tabLst/>
+              <a:defRPr sz="2400" b="0" i="0" u="none" strike="noStrike" cap="none" spc="0" baseline="0">
+                <a:ln>
+                  <a:noFill/>
+                </a:ln>
+                <a:solidFill>
+                  <a:srgbClr val="868A8D"/>
+                </a:solidFill>
+                <a:uFillTx/>
+                <a:latin typeface="Montserrat Light"/>
+                <a:ea typeface="Montserrat Light"/>
+                <a:cs typeface="Montserrat Light"/>
+                <a:sym typeface="Montserrat Light"/>
+              </a:defRPr>
+            </a:lvl6pPr>
+            <a:lvl7pPr marL="0" marR="0" indent="1371600" algn="just" defTabSz="825500" rtl="0" latinLnBrk="0">
+              <a:lnSpc>
+                <a:spcPct val="120000"/>
+              </a:lnSpc>
+              <a:spcBef>
+                <a:spcPts val="0"/>
+              </a:spcBef>
+              <a:spcAft>
+                <a:spcPts val="0"/>
+              </a:spcAft>
+              <a:buClrTx/>
+              <a:buSzTx/>
+              <a:buFontTx/>
+              <a:buNone/>
+              <a:tabLst/>
+              <a:defRPr sz="2400" b="0" i="0" u="none" strike="noStrike" cap="none" spc="0" baseline="0">
+                <a:ln>
+                  <a:noFill/>
+                </a:ln>
+                <a:solidFill>
+                  <a:srgbClr val="868A8D"/>
+                </a:solidFill>
+                <a:uFillTx/>
+                <a:latin typeface="Montserrat Light"/>
+                <a:ea typeface="Montserrat Light"/>
+                <a:cs typeface="Montserrat Light"/>
+                <a:sym typeface="Montserrat Light"/>
+              </a:defRPr>
+            </a:lvl7pPr>
+            <a:lvl8pPr marL="0" marR="0" indent="1600200" algn="just" defTabSz="825500" rtl="0" latinLnBrk="0">
+              <a:lnSpc>
+                <a:spcPct val="120000"/>
+              </a:lnSpc>
+              <a:spcBef>
+                <a:spcPts val="0"/>
+              </a:spcBef>
+              <a:spcAft>
+                <a:spcPts val="0"/>
+              </a:spcAft>
+              <a:buClrTx/>
+              <a:buSzTx/>
+              <a:buFontTx/>
+              <a:buNone/>
+              <a:tabLst/>
+              <a:defRPr sz="2400" b="0" i="0" u="none" strike="noStrike" cap="none" spc="0" baseline="0">
+                <a:ln>
+                  <a:noFill/>
+                </a:ln>
+                <a:solidFill>
+                  <a:srgbClr val="868A8D"/>
+                </a:solidFill>
+                <a:uFillTx/>
+                <a:latin typeface="Montserrat Light"/>
+                <a:ea typeface="Montserrat Light"/>
+                <a:cs typeface="Montserrat Light"/>
+                <a:sym typeface="Montserrat Light"/>
+              </a:defRPr>
+            </a:lvl8pPr>
+            <a:lvl9pPr marL="0" marR="0" indent="1828800" algn="just" defTabSz="825500" rtl="0" latinLnBrk="0">
+              <a:lnSpc>
+                <a:spcPct val="120000"/>
+              </a:lnSpc>
+              <a:spcBef>
+                <a:spcPts val="0"/>
+              </a:spcBef>
+              <a:spcAft>
+                <a:spcPts val="0"/>
+              </a:spcAft>
+              <a:buClrTx/>
+              <a:buSzTx/>
+              <a:buFontTx/>
+              <a:buNone/>
+              <a:tabLst/>
+              <a:defRPr sz="2400" b="0" i="0" u="none" strike="noStrike" cap="none" spc="0" baseline="0">
+                <a:ln>
+                  <a:noFill/>
+                </a:ln>
+                <a:solidFill>
+                  <a:srgbClr val="868A8D"/>
+                </a:solidFill>
+                <a:uFillTx/>
+                <a:latin typeface="Montserrat Light"/>
+                <a:ea typeface="Montserrat Light"/>
+                <a:cs typeface="Montserrat Light"/>
+                <a:sym typeface="Montserrat Light"/>
+              </a:defRPr>
+            </a:lvl9pPr>
+          </a:lstStyle>
+          <a:p>
+            <a:pPr marL="114300" algn="ctr" hangingPunct="1">
+              <a:lnSpc>
+                <a:spcPct val="100000"/>
+              </a:lnSpc>
+            </a:pPr>
+            <a:r>
+              <a:rPr lang="es-ES" sz="3000" dirty="0">
+                <a:solidFill>
+                  <a:schemeClr val="tx1"/>
+                </a:solidFill>
+                <a:latin typeface="Century Gothic" panose="020B0502020202020204" pitchFamily="34" charset="0"/>
+              </a:rPr>
+              <a:t>De la idea al mercado: un acompañamiento por etapas</a:t>
             </a:r>
           </a:p>
         </p:txBody>
@@ -12592,6 +12576,471 @@
               <a:defRPr/>
             </a:pPr>
             <a:r>
+              <a:rPr lang="pt-BR" sz="4000" b="1" kern="1200" dirty="0">
+                <a:ln w="0">
+                  <a:noFill/>
+                </a:ln>
+                <a:solidFill>
+                  <a:schemeClr val="tx1"/>
+                </a:solidFill>
+                <a:latin typeface="Century Gothic" panose="020B0502020202020204" pitchFamily="34" charset="0"/>
+              </a:rPr>
+              <a:t>Indicadores de seguimiento</a:t>
+            </a:r>
+            <a:endParaRPr kumimoji="0" lang="en-US" sz="4800" b="0" i="0" u="none" strike="noStrike" kern="1200" cap="none" spc="0" normalizeH="0" baseline="0" noProof="0" dirty="0">
+              <a:ln>
+                <a:noFill/>
+              </a:ln>
+              <a:solidFill>
+                <a:schemeClr val="tx1"/>
+              </a:solidFill>
+              <a:effectLst/>
+              <a:uLnTx/>
+              <a:uFillTx/>
+              <a:latin typeface="Lato Black" panose="020F0A02020204030203" pitchFamily="34" charset="0"/>
+            </a:endParaRPr>
+          </a:p>
+        </p:txBody>
+      </p:sp>
+      <p:sp>
+        <p:nvSpPr>
+          <p:cNvPr id="13" name="Google Shape;139;p19"/>
+          <p:cNvSpPr txBox="1">
+            <a:spLocks/>
+          </p:cNvSpPr>
+          <p:nvPr/>
+        </p:nvSpPr>
+        <p:spPr>
+          <a:xfrm>
+            <a:off x="2194560" y="3657600"/>
+            <a:ext cx="19933920" cy="7863840"/>
+          </a:xfrm>
+          <a:prstGeom prst="rect">
+            <a:avLst/>
+          </a:prstGeom>
+        </p:spPr>
+        <p:txBody>
+          <a:bodyPr spcFirstLastPara="1" wrap="square" lIns="91425" tIns="91425" rIns="91425" bIns="91425" anchor="t" anchorCtr="0">
+            <a:noAutofit/>
+          </a:bodyPr>
+          <a:lstStyle>
+            <a:lvl1pPr marL="0" marR="0" indent="0" algn="just" defTabSz="825500" rtl="0" latinLnBrk="0">
+              <a:lnSpc>
+                <a:spcPct val="120000"/>
+              </a:lnSpc>
+              <a:spcBef>
+                <a:spcPts val="0"/>
+              </a:spcBef>
+              <a:spcAft>
+                <a:spcPts val="0"/>
+              </a:spcAft>
+              <a:buClrTx/>
+              <a:buSzTx/>
+              <a:buFontTx/>
+              <a:buNone/>
+              <a:tabLst/>
+              <a:defRPr sz="2400" b="0" i="0" u="none" strike="noStrike" cap="none" spc="0" baseline="0">
+                <a:ln>
+                  <a:noFill/>
+                </a:ln>
+                <a:solidFill>
+                  <a:srgbClr val="868A8D"/>
+                </a:solidFill>
+                <a:uFillTx/>
+                <a:latin typeface="Montserrat Light"/>
+                <a:ea typeface="Montserrat Light"/>
+                <a:cs typeface="Montserrat Light"/>
+                <a:sym typeface="Montserrat Light"/>
+              </a:defRPr>
+            </a:lvl1pPr>
+            <a:lvl2pPr marL="0" marR="0" indent="228600" algn="just" defTabSz="825500" rtl="0" latinLnBrk="0">
+              <a:lnSpc>
+                <a:spcPct val="120000"/>
+              </a:lnSpc>
+              <a:spcBef>
+                <a:spcPts val="0"/>
+              </a:spcBef>
+              <a:spcAft>
+                <a:spcPts val="0"/>
+              </a:spcAft>
+              <a:buClrTx/>
+              <a:buSzTx/>
+              <a:buFontTx/>
+              <a:buNone/>
+              <a:tabLst/>
+              <a:defRPr sz="2400" b="0" i="0" u="none" strike="noStrike" cap="none" spc="0" baseline="0">
+                <a:ln>
+                  <a:noFill/>
+                </a:ln>
+                <a:solidFill>
+                  <a:srgbClr val="868A8D"/>
+                </a:solidFill>
+                <a:uFillTx/>
+                <a:latin typeface="Montserrat Light"/>
+                <a:ea typeface="Montserrat Light"/>
+                <a:cs typeface="Montserrat Light"/>
+                <a:sym typeface="Montserrat Light"/>
+              </a:defRPr>
+            </a:lvl2pPr>
+            <a:lvl3pPr marL="0" marR="0" indent="457200" algn="just" defTabSz="825500" rtl="0" latinLnBrk="0">
+              <a:lnSpc>
+                <a:spcPct val="120000"/>
+              </a:lnSpc>
+              <a:spcBef>
+                <a:spcPts val="0"/>
+              </a:spcBef>
+              <a:spcAft>
+                <a:spcPts val="0"/>
+              </a:spcAft>
+              <a:buClrTx/>
+              <a:buSzTx/>
+              <a:buFontTx/>
+              <a:buNone/>
+              <a:tabLst/>
+              <a:defRPr sz="2400" b="0" i="0" u="none" strike="noStrike" cap="none" spc="0" baseline="0">
+                <a:ln>
+                  <a:noFill/>
+                </a:ln>
+                <a:solidFill>
+                  <a:srgbClr val="868A8D"/>
+                </a:solidFill>
+                <a:uFillTx/>
+                <a:latin typeface="Montserrat Light"/>
+                <a:ea typeface="Montserrat Light"/>
+                <a:cs typeface="Montserrat Light"/>
+                <a:sym typeface="Montserrat Light"/>
+              </a:defRPr>
+            </a:lvl3pPr>
+            <a:lvl4pPr marL="0" marR="0" indent="685800" algn="just" defTabSz="825500" rtl="0" latinLnBrk="0">
+              <a:lnSpc>
+                <a:spcPct val="120000"/>
+              </a:lnSpc>
+              <a:spcBef>
+                <a:spcPts val="0"/>
+              </a:spcBef>
+              <a:spcAft>
+                <a:spcPts val="0"/>
+              </a:spcAft>
+              <a:buClrTx/>
+              <a:buSzTx/>
+              <a:buFontTx/>
+              <a:buNone/>
+              <a:tabLst/>
+              <a:defRPr sz="2400" b="0" i="0" u="none" strike="noStrike" cap="none" spc="0" baseline="0">
+                <a:ln>
+                  <a:noFill/>
+                </a:ln>
+                <a:solidFill>
+                  <a:srgbClr val="868A8D"/>
+                </a:solidFill>
+                <a:uFillTx/>
+                <a:latin typeface="Montserrat Light"/>
+                <a:ea typeface="Montserrat Light"/>
+                <a:cs typeface="Montserrat Light"/>
+                <a:sym typeface="Montserrat Light"/>
+              </a:defRPr>
+            </a:lvl4pPr>
+            <a:lvl5pPr marL="0" marR="0" indent="914400" algn="just" defTabSz="825500" rtl="0" latinLnBrk="0">
+              <a:lnSpc>
+                <a:spcPct val="120000"/>
+              </a:lnSpc>
+              <a:spcBef>
+                <a:spcPts val="0"/>
+              </a:spcBef>
+              <a:spcAft>
+                <a:spcPts val="0"/>
+              </a:spcAft>
+              <a:buClrTx/>
+              <a:buSzTx/>
+              <a:buFontTx/>
+              <a:buNone/>
+              <a:tabLst/>
+              <a:defRPr sz="2400" b="0" i="0" u="none" strike="noStrike" cap="none" spc="0" baseline="0">
+                <a:ln>
+                  <a:noFill/>
+                </a:ln>
+                <a:solidFill>
+                  <a:srgbClr val="868A8D"/>
+                </a:solidFill>
+                <a:uFillTx/>
+                <a:latin typeface="Montserrat Light"/>
+                <a:ea typeface="Montserrat Light"/>
+                <a:cs typeface="Montserrat Light"/>
+                <a:sym typeface="Montserrat Light"/>
+              </a:defRPr>
+            </a:lvl5pPr>
+            <a:lvl6pPr marL="0" marR="0" indent="1143000" algn="just" defTabSz="825500" rtl="0" latinLnBrk="0">
+              <a:lnSpc>
+                <a:spcPct val="120000"/>
+              </a:lnSpc>
+              <a:spcBef>
+                <a:spcPts val="0"/>
+              </a:spcBef>
+              <a:spcAft>
+                <a:spcPts val="0"/>
+              </a:spcAft>
+              <a:buClrTx/>
+              <a:buSzTx/>
+              <a:buFontTx/>
+              <a:buNone/>
+              <a:tabLst/>
+              <a:defRPr sz="2400" b="0" i="0" u="none" strike="noStrike" cap="none" spc="0" baseline="0">
+                <a:ln>
+                  <a:noFill/>
+                </a:ln>
+                <a:solidFill>
+                  <a:srgbClr val="868A8D"/>
+                </a:solidFill>
+                <a:uFillTx/>
+                <a:latin typeface="Montserrat Light"/>
+                <a:ea typeface="Montserrat Light"/>
+                <a:cs typeface="Montserrat Light"/>
+                <a:sym typeface="Montserrat Light"/>
+              </a:defRPr>
+            </a:lvl6pPr>
+            <a:lvl7pPr marL="0" marR="0" indent="1371600" algn="just" defTabSz="825500" rtl="0" latinLnBrk="0">
+              <a:lnSpc>
+                <a:spcPct val="120000"/>
+              </a:lnSpc>
+              <a:spcBef>
+                <a:spcPts val="0"/>
+              </a:spcBef>
+              <a:spcAft>
+                <a:spcPts val="0"/>
+              </a:spcAft>
+              <a:buClrTx/>
+              <a:buSzTx/>
+              <a:buFontTx/>
+              <a:buNone/>
+              <a:tabLst/>
+              <a:defRPr sz="2400" b="0" i="0" u="none" strike="noStrike" cap="none" spc="0" baseline="0">
+                <a:ln>
+                  <a:noFill/>
+                </a:ln>
+                <a:solidFill>
+                  <a:srgbClr val="868A8D"/>
+                </a:solidFill>
+                <a:uFillTx/>
+                <a:latin typeface="Montserrat Light"/>
+                <a:ea typeface="Montserrat Light"/>
+                <a:cs typeface="Montserrat Light"/>
+                <a:sym typeface="Montserrat Light"/>
+              </a:defRPr>
+            </a:lvl7pPr>
+            <a:lvl8pPr marL="0" marR="0" indent="1600200" algn="just" defTabSz="825500" rtl="0" latinLnBrk="0">
+              <a:lnSpc>
+                <a:spcPct val="120000"/>
+              </a:lnSpc>
+              <a:spcBef>
+                <a:spcPts val="0"/>
+              </a:spcBef>
+              <a:spcAft>
+                <a:spcPts val="0"/>
+              </a:spcAft>
+              <a:buClrTx/>
+              <a:buSzTx/>
+              <a:buFontTx/>
+              <a:buNone/>
+              <a:tabLst/>
+              <a:defRPr sz="2400" b="0" i="0" u="none" strike="noStrike" cap="none" spc="0" baseline="0">
+                <a:ln>
+                  <a:noFill/>
+                </a:ln>
+                <a:solidFill>
+                  <a:srgbClr val="868A8D"/>
+                </a:solidFill>
+                <a:uFillTx/>
+                <a:latin typeface="Montserrat Light"/>
+                <a:ea typeface="Montserrat Light"/>
+                <a:cs typeface="Montserrat Light"/>
+                <a:sym typeface="Montserrat Light"/>
+              </a:defRPr>
+            </a:lvl8pPr>
+            <a:lvl9pPr marL="0" marR="0" indent="1828800" algn="just" defTabSz="825500" rtl="0" latinLnBrk="0">
+              <a:lnSpc>
+                <a:spcPct val="120000"/>
+              </a:lnSpc>
+              <a:spcBef>
+                <a:spcPts val="0"/>
+              </a:spcBef>
+              <a:spcAft>
+                <a:spcPts val="0"/>
+              </a:spcAft>
+              <a:buClrTx/>
+              <a:buSzTx/>
+              <a:buFontTx/>
+              <a:buNone/>
+              <a:tabLst/>
+              <a:defRPr sz="2400" b="0" i="0" u="none" strike="noStrike" cap="none" spc="0" baseline="0">
+                <a:ln>
+                  <a:noFill/>
+                </a:ln>
+                <a:solidFill>
+                  <a:srgbClr val="868A8D"/>
+                </a:solidFill>
+                <a:uFillTx/>
+                <a:latin typeface="Montserrat Light"/>
+                <a:ea typeface="Montserrat Light"/>
+                <a:cs typeface="Montserrat Light"/>
+                <a:sym typeface="Montserrat Light"/>
+              </a:defRPr>
+            </a:lvl9pPr>
+          </a:lstStyle>
+          <a:p>
+            <a:pPr algn="l" hangingPunct="1">
+              <a:spcAft>
+                <a:spcPts val="1400"/>
+              </a:spcAft>
+            </a:pPr>
+            <a:r>
+              <a:rPr lang="es-CO" sz="3200" b="1" dirty="0">
+                <a:solidFill>
+                  <a:schemeClr val="accent6"/>
+                </a:solidFill>
+                <a:latin typeface="Century Gothic" panose="020B0502020202020204" pitchFamily="34" charset="0"/>
+                <a:cs typeface="Candara"/>
+              </a:rPr>
+              <a:t>•  Personas sensibilizadas por año.</a:t>
+            </a:r>
+          </a:p>
+          <a:p>
+            <a:pPr algn="l" hangingPunct="1">
+              <a:spcAft>
+                <a:spcPts val="1400"/>
+              </a:spcAft>
+            </a:pPr>
+            <a:r>
+              <a:rPr lang="es-CO" sz="3200" b="1" dirty="0">
+                <a:solidFill>
+                  <a:schemeClr val="accent6"/>
+                </a:solidFill>
+                <a:latin typeface="Century Gothic" panose="020B0502020202020204" pitchFamily="34" charset="0"/>
+                <a:cs typeface="Candara"/>
+              </a:rPr>
+              <a:t>•  Proyectos diagnosticados y acompañados por fase.</a:t>
+            </a:r>
+          </a:p>
+          <a:p>
+            <a:pPr algn="l" hangingPunct="1">
+              <a:spcAft>
+                <a:spcPts val="1400"/>
+              </a:spcAft>
+            </a:pPr>
+            <a:r>
+              <a:rPr lang="es-CO" sz="3200" b="1" dirty="0">
+                <a:solidFill>
+                  <a:schemeClr val="accent6"/>
+                </a:solidFill>
+                <a:latin typeface="Century Gothic" panose="020B0502020202020204" pitchFamily="34" charset="0"/>
+                <a:cs typeface="Candara"/>
+              </a:rPr>
+              <a:t>•  % de proyectos vigentes a 3 años (≥3% — meta PDI).</a:t>
+            </a:r>
+          </a:p>
+          <a:p>
+            <a:pPr algn="l" hangingPunct="1">
+              <a:spcAft>
+                <a:spcPts val="1400"/>
+              </a:spcAft>
+            </a:pPr>
+            <a:r>
+              <a:rPr lang="es-CO" sz="3200" b="1" dirty="0">
+                <a:solidFill>
+                  <a:schemeClr val="accent6"/>
+                </a:solidFill>
+                <a:latin typeface="Century Gothic" panose="020B0502020202020204" pitchFamily="34" charset="0"/>
+                <a:cs typeface="Candara"/>
+              </a:rPr>
+              <a:t>•  Títulos de propiedad intelectual y spin-offs.</a:t>
+            </a:r>
+          </a:p>
+          <a:p>
+            <a:pPr algn="l" hangingPunct="1">
+              <a:spcAft>
+                <a:spcPts val="1400"/>
+              </a:spcAft>
+            </a:pPr>
+            <a:r>
+              <a:rPr lang="es-CO" sz="3200" b="1" dirty="0">
+                <a:solidFill>
+                  <a:schemeClr val="accent6"/>
+                </a:solidFill>
+                <a:latin typeface="Century Gothic" panose="020B0502020202020204" pitchFamily="34" charset="0"/>
+                <a:cs typeface="Candara"/>
+              </a:rPr>
+              <a:t>•  Facultades con docente enlace activo.</a:t>
+            </a:r>
+          </a:p>
+        </p:txBody>
+      </p:sp>
+    </p:spTree>
+  </p:cSld>
+  <p:clrMapOvr>
+    <a:masterClrMapping/>
+  </p:clrMapOvr>
+</p:sld>
+</file>
+
+<file path=ppt/slides/slide34.xml><?xml version="1.0" encoding="utf-8"?>
+<p:sld xmlns:a="http://schemas.openxmlformats.org/drawingml/2006/main" xmlns:p="http://schemas.openxmlformats.org/presentationml/2006/main" xmlns:r="http://schemas.openxmlformats.org/officeDocument/2006/relationships">
+  <p:cSld>
+    <p:spTree>
+      <p:nvGrpSpPr>
+        <p:cNvPr id="1" name=""/>
+        <p:cNvGrpSpPr/>
+        <p:nvPr/>
+      </p:nvGrpSpPr>
+      <p:grpSpPr/>
+      <p:sp>
+        <p:nvSpPr>
+          <p:cNvPr id="12" name="Rounded Rectangle 8"/>
+          <p:cNvSpPr/>
+          <p:nvPr/>
+        </p:nvSpPr>
+        <p:spPr>
+          <a:xfrm>
+            <a:off x="3017520" y="1097280"/>
+            <a:ext cx="18288000" cy="1737360"/>
+          </a:xfrm>
+          <a:prstGeom prst="roundRect">
+            <a:avLst>
+              <a:gd name="adj" fmla="val 50000"/>
+            </a:avLst>
+          </a:prstGeom>
+          <a:solidFill>
+            <a:srgbClr val="D07137"/>
+          </a:solidFill>
+          <a:ln>
+            <a:noFill/>
+          </a:ln>
+        </p:spPr>
+        <p:style>
+          <a:lnRef idx="2">
+            <a:schemeClr val="accent1">
+              <a:shade val="50000"/>
+            </a:schemeClr>
+          </a:lnRef>
+          <a:fillRef idx="1">
+            <a:schemeClr val="accent1"/>
+          </a:fillRef>
+          <a:effectRef idx="0">
+            <a:schemeClr val="accent1"/>
+          </a:effectRef>
+          <a:fontRef idx="minor">
+            <a:schemeClr val="lt1"/>
+          </a:fontRef>
+        </p:style>
+        <p:txBody>
+          <a:bodyPr rtlCol="0" anchor="ctr"/>
+          <a:lstStyle/>
+          <a:p>
+            <a:pPr lvl="0" algn="ctr" defTabSz="914400" hangingPunct="1">
+              <a:lnSpc>
+                <a:spcPct val="100000"/>
+              </a:lnSpc>
+              <a:defRPr/>
+            </a:pPr>
+            <a:r>
               <a:rPr lang="pt-BR" sz="3400" b="1" kern="1200" dirty="0">
                 <a:ln w="0">
                   <a:noFill/>
@@ -12950,7 +13399,7 @@
                 <a:latin typeface="Century Gothic" panose="020B0502020202020204" pitchFamily="34" charset="0"/>
                 <a:cs typeface="Candara"/>
               </a:rPr>
-              <a:t>•  Retos interdisciplinarios entre facultades.</a:t>
+              <a:t>•  Actividades y eventos conjuntos por facultad.</a:t>
             </a:r>
           </a:p>
           <a:p>
@@ -12980,7 +13429,7 @@
 </p:sld>
 </file>
 
-<file path=ppt/slides/slide34.xml><?xml version="1.0" encoding="utf-8"?>
+<file path=ppt/slides/slide35.xml><?xml version="1.0" encoding="utf-8"?>
 <p:sld xmlns:a="http://schemas.openxmlformats.org/drawingml/2006/main" xmlns:p="http://schemas.openxmlformats.org/presentationml/2006/main" xmlns:r="http://schemas.openxmlformats.org/officeDocument/2006/relationships">
   <p:cSld>
     <p:spTree>

</xml_diff>

<commit_message>
Ruta PPT: alinea fundamento del PDI (Linea 3, motor Articulacion, meta spin-off RSU)
</commit_message>
<xml_diff>
--- a/Ruta-Emprendimiento-CIE.pptx
+++ b/Ruta-Emprendimiento-CIE.pptx
@@ -6348,14 +6348,14 @@
               </a:spcAft>
             </a:pPr>
             <a:r>
-              <a:rPr lang="es-CO" sz="2800" b="1" dirty="0">
+              <a:rPr lang="es-CO" sz="2600" b="1" dirty="0">
                 <a:solidFill>
                   <a:schemeClr val="accent6"/>
                 </a:solidFill>
                 <a:latin typeface="Century Gothic" panose="020B0502020202020204" pitchFamily="34" charset="0"/>
                 <a:cs typeface="Candara"/>
               </a:rPr>
-              <a:t>•  Línea Estratégica 3: Extensión y Proyección Social.</a:t>
+              <a:t>•  Línea Estratégica 3: Impacto regional, nacional e internacional desde la Extensión y Proyección Social.</a:t>
             </a:r>
           </a:p>
           <a:p>
@@ -6365,7 +6365,24 @@
               </a:spcAft>
             </a:pPr>
             <a:r>
-              <a:rPr lang="es-CO" sz="2800" b="1" dirty="0">
+              <a:rPr lang="es-CO" sz="2600" b="1" dirty="0">
+                <a:solidFill>
+                  <a:schemeClr val="accent6"/>
+                </a:solidFill>
+                <a:latin typeface="Century Gothic" panose="020B0502020202020204" pitchFamily="34" charset="0"/>
+                <a:cs typeface="Candara"/>
+              </a:rPr>
+              <a:t>•  Motor de desarrollo: «Articulación con el sector productivo y la sociedad» (donde se ubica el emprendimiento).</a:t>
+            </a:r>
+          </a:p>
+          <a:p>
+            <a:pPr algn="l" hangingPunct="1">
+              <a:spcAft>
+                <a:spcPts val="1400"/>
+              </a:spcAft>
+            </a:pPr>
+            <a:r>
+              <a:rPr lang="es-CO" sz="2600" b="1" dirty="0">
                 <a:solidFill>
                   <a:schemeClr val="accent6"/>
                 </a:solidFill>
@@ -6382,7 +6399,7 @@
               </a:spcAft>
             </a:pPr>
             <a:r>
-              <a:rPr lang="es-CO" sz="2800" b="1" dirty="0">
+              <a:rPr lang="es-CO" sz="2600" b="1" dirty="0">
                 <a:solidFill>
                   <a:schemeClr val="accent6"/>
                 </a:solidFill>
@@ -6399,14 +6416,14 @@
               </a:spcAft>
             </a:pPr>
             <a:r>
-              <a:rPr lang="es-CO" sz="2800" b="1" dirty="0">
+              <a:rPr lang="es-CO" sz="2600" b="1" dirty="0">
                 <a:solidFill>
                   <a:schemeClr val="accent6"/>
                 </a:solidFill>
                 <a:latin typeface="Century Gothic" panose="020B0502020202020204" pitchFamily="34" charset="0"/>
                 <a:cs typeface="Candara"/>
               </a:rPr>
-              <a:t>•  Metas: política de innovación y emprendimiento; Centro 'UA Emprende' (≥3% sostenibilidad); 2 spin-off; Parque Tecnológico del Caribe.</a:t>
+              <a:t>•  Metas: Centro 'UA Emprende' con sostenibilidad ≥3%; 30 proyectos de innovación y 7 productos de transferencia; comercialización de ≥2 spin-off (motor RSU).</a:t>
             </a:r>
           </a:p>
         </p:txBody>

</xml_diff>